<commit_message>
Gesellschafterversammlung: TOP 1 auf Gesamt-Auswertung, Zeitstrahl mit Projektliste, TOP-Abschnitte
TOP 1 zeigt die Kennzahlen der Zeile „Summe Bestätigt“ aus der
App-Auswertung (Werte folgen), der Zeitstrahl listet die 17 Projekte
je Monat Mai bis September, die Folien sind in PowerPoint-Abschnitte
je TOP gegliedert und mehrteilige TOPs tragen „Folie x von y“.

Co-Authored-By: Claude Fable 5.1 <noreply@anthropic.com>
Claude-Session: https://claude.ai/code/session_0118VeQCFGC8WVSdKpLNkHCn
</commit_message>
<xml_diff>
--- a/praesentationen/Gesellschafterversammlung_2026-09-23.pptx
+++ b/praesentationen/Gesellschafterversammlung_2026-09-23.pptx
@@ -114,6 +114,58 @@
       </a:defRPr>
     </a:lvl9pPr>
   </p:defaultTextStyle>
+  <p:extLst>
+    <p:ext uri="{521415D9-36F7-43E2-AB2F-B90AF26B5E84}">
+      <p14:sectionLst xmlns:p14="http://schemas.microsoft.com/office/powerpoint/2010/main">
+        <p14:section name="Einstieg" id="{ca132568-6624-3ee9-3f95-5e0ae2375e09}">
+          <p14:sldIdLst>
+            <p14:sldId id="256"/>
+            <p14:sldId id="257"/>
+          </p14:sldIdLst>
+        </p14:section>
+        <p14:section name="TOP 1 · Kurze Zusammenfassung und IST-Zustand" id="{1677242e-35a7-b6db-211c-2da4457cd85e}">
+          <p14:sldIdLst>
+            <p14:sldId id="258"/>
+          </p14:sldIdLst>
+        </p14:section>
+        <p14:section name="TOP 2 · Überblick der letzten 4 Monate" id="{97032db0-3c11-6f3f-5a2d-aafd3c92e556}">
+          <p14:sldIdLst>
+            <p14:sldId id="259"/>
+            <p14:sldId id="260"/>
+          </p14:sldIdLst>
+        </p14:section>
+        <p14:section name="TOP 3 · 80er im Detail und Zukunft Kunde MK?" id="{f22165a2-f4b7-5029-8535-4ae7f5e68773}">
+          <p14:sldIdLst>
+            <p14:sldId id="261"/>
+            <p14:sldId id="262"/>
+          </p14:sldIdLst>
+        </p14:section>
+        <p14:section name="TOP 4 · Messeauftritt" id="{86a873c1-8002-dfc8-7e9a-f960192a8078}">
+          <p14:sldIdLst>
+            <p14:sldId id="263"/>
+          </p14:sldIdLst>
+        </p14:section>
+        <p14:section name="TOP 5 · Forecast und Ausblick" id="{456d17fd-d8cc-181e-2e71-5ed8db7204e8}">
+          <p14:sldIdLst>
+            <p14:sldId id="264"/>
+          </p14:sldIdLst>
+        </p14:section>
+        <p14:section name="TOP 6 · Sonstiges" id="{4e61fdda-bfab-5427-0241-2cd88527019c}">
+          <p14:sldIdLst>
+            <p14:sldId id="265"/>
+          </p14:sldIdLst>
+        </p14:section>
+        <p14:section name="Abschluss" id="{3b6fa6bd-af9f-1b2d-2b4f-d8522a7d4424}">
+          <p14:sldIdLst>
+            <p14:sldId id="266"/>
+          </p14:sldIdLst>
+        </p14:section>
+      </p14:sectionLst>
+    </p:ext>
+    <p:ext uri="{EFAFB233-063F-42B5-8137-9DF3F51BA10A}">
+      <p15:sldGuideLst xmlns:p15="http://schemas.microsoft.com/office/powerpoint/2012/main"/>
+    </p:ext>
+  </p:extLst>
 </p:presentation>
 </file>
 
@@ -1537,7 +1589,7 @@
           <a:p>
             <a:r>
               <a:rPr lang="en-US" dirty="0"/>
-              <a:t>TOP 1 – Kurze Zusammenfassung und IST-Zustand. Kennzahlen stammen aus der Deal-Auswertung ProEvent 2026 (Stand 07.08.2026).</a:t>
+              <a:t>TOP 1 – Kurze Zusammenfassung und IST-Zustand. Kennzahlen = Zeile „Summe Bestätigt“ der Auswertung in der Nova Works App (alle bestätigten Projekte, netto).</a:t>
             </a:r>
             <a:endParaRPr lang="en-US" dirty="0"/>
           </a:p>
@@ -1625,7 +1677,7 @@
           <a:p>
             <a:r>
               <a:rPr lang="en-US" dirty="0"/>
-              <a:t>TOP 2 – Überblick der letzten 4 Monate. Zeitstrahl der Projekte seit Mai 2026.</a:t>
+              <a:t>TOP 2 – Überblick der letzten 4 Monate: Projekte je Monat (Mai bis September 2026).</a:t>
             </a:r>
             <a:endParaRPr lang="en-US" dirty="0"/>
           </a:p>
@@ -5906,7 +5958,7 @@
                 <a:ea typeface="Helvetica" pitchFamily="34" charset="-122"/>
                 <a:cs typeface="Helvetica" pitchFamily="34" charset="-120"/>
               </a:rPr>
-              <a:t>Wo steht die NOVA WORKS GmbH heute?</a:t>
+              <a:t>Gesamt Nova Works · Auswertung der bestätigten Projekte · alle Beträge netto</a:t>
             </a:r>
             <a:endParaRPr lang="en-US" sz="1250" dirty="0"/>
           </a:p>
@@ -5921,7 +5973,7 @@
         <p:spPr>
           <a:xfrm>
             <a:off x="548640" y="1783080"/>
-            <a:ext cx="6400800" cy="274320"/>
+            <a:ext cx="7315200" cy="274320"/>
           </a:xfrm>
           <a:prstGeom prst="rect">
             <a:avLst/>
@@ -5945,7 +5997,7 @@
                 <a:ea typeface="Helvetica" pitchFamily="34" charset="-122"/>
                 <a:cs typeface="Helvetica" pitchFamily="34" charset="-120"/>
               </a:rPr>
-              <a:t>ZAHLEN AUS DEM DEAL PROEVENT 2026 · STAND 07.08.2026 · NETTO</a:t>
+              <a:t>SUMME BESTÄTIGT</a:t>
             </a:r>
             <a:endParaRPr lang="en-US" sz="900" dirty="0"/>
           </a:p>
@@ -5960,7 +6012,7 @@
         <p:spPr>
           <a:xfrm>
             <a:off x="548640" y="2103120"/>
-            <a:ext cx="3383280" cy="1234440"/>
+            <a:ext cx="1755648" cy="1234440"/>
           </a:xfrm>
           <a:prstGeom prst="roundRect">
             <a:avLst>
@@ -5994,7 +6046,7 @@
         <p:spPr>
           <a:xfrm>
             <a:off x="777240" y="2267712"/>
-            <a:ext cx="2926080" cy="256032"/>
+            <a:ext cx="1298448" cy="256032"/>
           </a:xfrm>
           <a:prstGeom prst="rect">
             <a:avLst/>
@@ -6010,7 +6062,7 @@
               <a:buNone/>
             </a:pPr>
             <a:r>
-              <a:rPr lang="en-US" sz="900" spc="150" kern="0" dirty="0">
+              <a:rPr lang="en-US" sz="800" spc="60" kern="0" dirty="0">
                 <a:solidFill>
                   <a:srgbClr val="6A6A6A"/>
                 </a:solidFill>
@@ -6018,9 +6070,9 @@
                 <a:ea typeface="Helvetica" pitchFamily="34" charset="-122"/>
                 <a:cs typeface="Helvetica" pitchFamily="34" charset="-120"/>
               </a:rPr>
-              <a:t>UMSATZ NOVA WORKS</a:t>
-            </a:r>
-            <a:endParaRPr lang="en-US" sz="900" dirty="0"/>
+              <a:t>ANGEBOT</a:t>
+            </a:r>
+            <a:endParaRPr lang="en-US" sz="800" dirty="0"/>
           </a:p>
         </p:txBody>
       </p:sp>
@@ -6033,7 +6085,7 @@
         <p:spPr>
           <a:xfrm>
             <a:off x="777240" y="2514600"/>
-            <a:ext cx="2926080" cy="457200"/>
+            <a:ext cx="1298448" cy="457200"/>
           </a:xfrm>
           <a:prstGeom prst="rect">
             <a:avLst/>
@@ -6057,7 +6109,7 @@
                 <a:ea typeface="Helvetica" pitchFamily="34" charset="-122"/>
                 <a:cs typeface="Helvetica" pitchFamily="34" charset="-120"/>
               </a:rPr>
-              <a:t>526.766 €</a:t>
+              <a:t>–</a:t>
             </a:r>
             <a:endParaRPr lang="en-US" sz="2200" dirty="0"/>
           </a:p>
@@ -6072,7 +6124,7 @@
         <p:spPr>
           <a:xfrm>
             <a:off x="777240" y="2971800"/>
-            <a:ext cx="2926080" cy="256032"/>
+            <a:ext cx="1298448" cy="256032"/>
           </a:xfrm>
           <a:prstGeom prst="rect">
             <a:avLst/>
@@ -6096,7 +6148,7 @@
                 <a:ea typeface="Helvetica" pitchFamily="34" charset="-122"/>
                 <a:cs typeface="Helvetica" pitchFamily="34" charset="-120"/>
               </a:rPr>
-              <a:t>Anteil 47 % am Gesamtdeal 1.126.766 €</a:t>
+              <a:t>Netto aus den Angeboten</a:t>
             </a:r>
             <a:endParaRPr lang="en-US" sz="950" dirty="0"/>
           </a:p>
@@ -6110,8 +6162,8 @@
         </p:nvSpPr>
         <p:spPr>
           <a:xfrm>
-            <a:off x="4114800" y="2103120"/>
-            <a:ext cx="3383280" cy="1234440"/>
+            <a:off x="2441448" y="2103120"/>
+            <a:ext cx="1755648" cy="1234440"/>
           </a:xfrm>
           <a:prstGeom prst="roundRect">
             <a:avLst>
@@ -6144,8 +6196,8 @@
         </p:nvSpPr>
         <p:spPr>
           <a:xfrm>
-            <a:off x="4343400" y="2267712"/>
-            <a:ext cx="2926080" cy="256032"/>
+            <a:off x="2670048" y="2267712"/>
+            <a:ext cx="1298448" cy="256032"/>
           </a:xfrm>
           <a:prstGeom prst="rect">
             <a:avLst/>
@@ -6161,7 +6213,7 @@
               <a:buNone/>
             </a:pPr>
             <a:r>
-              <a:rPr lang="en-US" sz="900" spc="150" kern="0" dirty="0">
+              <a:rPr lang="en-US" sz="800" spc="60" kern="0" dirty="0">
                 <a:solidFill>
                   <a:srgbClr val="6A6A6A"/>
                 </a:solidFill>
@@ -6169,9 +6221,9 @@
                 <a:ea typeface="Helvetica" pitchFamily="34" charset="-122"/>
                 <a:cs typeface="Helvetica" pitchFamily="34" charset="-120"/>
               </a:rPr>
-              <a:t>MARGE NOVA-WORKS-SICHT</a:t>
-            </a:r>
-            <a:endParaRPr lang="en-US" sz="900" dirty="0"/>
+              <a:t>BESTÄTIGT</a:t>
+            </a:r>
+            <a:endParaRPr lang="en-US" sz="800" dirty="0"/>
           </a:p>
         </p:txBody>
       </p:sp>
@@ -6183,8 +6235,8 @@
         </p:nvSpPr>
         <p:spPr>
           <a:xfrm>
-            <a:off x="4343400" y="2514600"/>
-            <a:ext cx="2926080" cy="457200"/>
+            <a:off x="2670048" y="2514600"/>
+            <a:ext cx="1298448" cy="457200"/>
           </a:xfrm>
           <a:prstGeom prst="rect">
             <a:avLst/>
@@ -6208,7 +6260,7 @@
                 <a:ea typeface="Helvetica" pitchFamily="34" charset="-122"/>
                 <a:cs typeface="Helvetica" pitchFamily="34" charset="-120"/>
               </a:rPr>
-              <a:t>218.169 €</a:t>
+              <a:t>–</a:t>
             </a:r>
             <a:endParaRPr lang="en-US" sz="2200" dirty="0"/>
           </a:p>
@@ -6222,8 +6274,8 @@
         </p:nvSpPr>
         <p:spPr>
           <a:xfrm>
-            <a:off x="4343400" y="2971800"/>
-            <a:ext cx="2926080" cy="256032"/>
+            <a:off x="2670048" y="2971800"/>
+            <a:ext cx="1298448" cy="256032"/>
           </a:xfrm>
           <a:prstGeom prst="rect">
             <a:avLst/>
@@ -6247,7 +6299,7 @@
                 <a:ea typeface="Helvetica" pitchFamily="34" charset="-122"/>
                 <a:cs typeface="Helvetica" pitchFamily="34" charset="-120"/>
               </a:rPr>
-              <a:t>41 % · Kosten 308.597 €</a:t>
+              <a:t>aktuelle Projektsumme bestätigter Projekte</a:t>
             </a:r>
             <a:endParaRPr lang="en-US" sz="950" dirty="0"/>
           </a:p>
@@ -6261,8 +6313,8 @@
         </p:nvSpPr>
         <p:spPr>
           <a:xfrm>
-            <a:off x="548640" y="3520440"/>
-            <a:ext cx="3383280" cy="1234440"/>
+            <a:off x="4334256" y="2103120"/>
+            <a:ext cx="1755648" cy="1234440"/>
           </a:xfrm>
           <a:prstGeom prst="roundRect">
             <a:avLst>
@@ -6295,8 +6347,8 @@
         </p:nvSpPr>
         <p:spPr>
           <a:xfrm>
-            <a:off x="777240" y="3685032"/>
-            <a:ext cx="2926080" cy="256032"/>
+            <a:off x="4562856" y="2267712"/>
+            <a:ext cx="1298448" cy="256032"/>
           </a:xfrm>
           <a:prstGeom prst="rect">
             <a:avLst/>
@@ -6312,7 +6364,7 @@
               <a:buNone/>
             </a:pPr>
             <a:r>
-              <a:rPr lang="en-US" sz="900" spc="150" kern="0" dirty="0">
+              <a:rPr lang="en-US" sz="800" spc="60" kern="0" dirty="0">
                 <a:solidFill>
                   <a:srgbClr val="6A6A6A"/>
                 </a:solidFill>
@@ -6320,9 +6372,9 @@
                 <a:ea typeface="Helvetica" pitchFamily="34" charset="-122"/>
                 <a:cs typeface="Helvetica" pitchFamily="34" charset="-120"/>
               </a:rPr>
-              <a:t>OFFENE KUNDENRECHNUNGEN</a:t>
-            </a:r>
-            <a:endParaRPr lang="en-US" sz="900" dirty="0"/>
+              <a:t>ERLÖSE (IST)</a:t>
+            </a:r>
+            <a:endParaRPr lang="en-US" sz="800" dirty="0"/>
           </a:p>
         </p:txBody>
       </p:sp>
@@ -6334,8 +6386,8 @@
         </p:nvSpPr>
         <p:spPr>
           <a:xfrm>
-            <a:off x="777240" y="3931920"/>
-            <a:ext cx="2926080" cy="457200"/>
+            <a:off x="4562856" y="2514600"/>
+            <a:ext cx="1298448" cy="457200"/>
           </a:xfrm>
           <a:prstGeom prst="rect">
             <a:avLst/>
@@ -6353,13 +6405,13 @@
             <a:r>
               <a:rPr lang="en-US" sz="2200" b="1" dirty="0">
                 <a:solidFill>
-                  <a:srgbClr val="A8884F"/>
-                </a:solidFill>
-                <a:latin typeface="Helvetica" pitchFamily="34" charset="0"/>
-                <a:ea typeface="Helvetica" pitchFamily="34" charset="-122"/>
-                <a:cs typeface="Helvetica" pitchFamily="34" charset="-120"/>
-              </a:rPr>
-              <a:t>361.760 €</a:t>
+                  <a:srgbClr val="3D3D3D"/>
+                </a:solidFill>
+                <a:latin typeface="Helvetica" pitchFamily="34" charset="0"/>
+                <a:ea typeface="Helvetica" pitchFamily="34" charset="-122"/>
+                <a:cs typeface="Helvetica" pitchFamily="34" charset="-120"/>
+              </a:rPr>
+              <a:t>–</a:t>
             </a:r>
             <a:endParaRPr lang="en-US" sz="2200" dirty="0"/>
           </a:p>
@@ -6373,8 +6425,8 @@
         </p:nvSpPr>
         <p:spPr>
           <a:xfrm>
-            <a:off x="777240" y="4389120"/>
-            <a:ext cx="2926080" cy="256032"/>
+            <a:off x="4562856" y="2971800"/>
+            <a:ext cx="1298448" cy="256032"/>
           </a:xfrm>
           <a:prstGeom prst="rect">
             <a:avLst/>
@@ -6398,7 +6450,7 @@
                 <a:ea typeface="Helvetica" pitchFamily="34" charset="-122"/>
                 <a:cs typeface="Helvetica" pitchFamily="34" charset="-120"/>
               </a:rPr>
-              <a:t>7 Rechnungen · brutto · alle Parteien</a:t>
+              <a:t>Summe aller Ausgangsrechnungen</a:t>
             </a:r>
             <a:endParaRPr lang="en-US" sz="950" dirty="0"/>
           </a:p>
@@ -6412,8 +6464,8 @@
         </p:nvSpPr>
         <p:spPr>
           <a:xfrm>
-            <a:off x="4114800" y="3520440"/>
-            <a:ext cx="3383280" cy="1234440"/>
+            <a:off x="6227064" y="2103120"/>
+            <a:ext cx="1755648" cy="1234440"/>
           </a:xfrm>
           <a:prstGeom prst="roundRect">
             <a:avLst>
@@ -6446,8 +6498,8 @@
         </p:nvSpPr>
         <p:spPr>
           <a:xfrm>
-            <a:off x="4343400" y="3685032"/>
-            <a:ext cx="2926080" cy="256032"/>
+            <a:off x="6455664" y="2267712"/>
+            <a:ext cx="1298448" cy="256032"/>
           </a:xfrm>
           <a:prstGeom prst="rect">
             <a:avLst/>
@@ -6463,7 +6515,7 @@
               <a:buNone/>
             </a:pPr>
             <a:r>
-              <a:rPr lang="en-US" sz="900" spc="150" kern="0" dirty="0">
+              <a:rPr lang="en-US" sz="800" spc="60" kern="0" dirty="0">
                 <a:solidFill>
                   <a:srgbClr val="6A6A6A"/>
                 </a:solidFill>
@@ -6471,9 +6523,9 @@
                 <a:ea typeface="Helvetica" pitchFamily="34" charset="-122"/>
                 <a:cs typeface="Helvetica" pitchFamily="34" charset="-120"/>
               </a:rPr>
-              <a:t>BEZAHLT</a:t>
-            </a:r>
-            <a:endParaRPr lang="en-US" sz="900" dirty="0"/>
+              <a:t>KOSTEN (IST)</a:t>
+            </a:r>
+            <a:endParaRPr lang="en-US" sz="800" dirty="0"/>
           </a:p>
         </p:txBody>
       </p:sp>
@@ -6485,8 +6537,8 @@
         </p:nvSpPr>
         <p:spPr>
           <a:xfrm>
-            <a:off x="4343400" y="3931920"/>
-            <a:ext cx="2926080" cy="457200"/>
+            <a:off x="6455664" y="2514600"/>
+            <a:ext cx="1298448" cy="457200"/>
           </a:xfrm>
           <a:prstGeom prst="rect">
             <a:avLst/>
@@ -6510,7 +6562,7 @@
                 <a:ea typeface="Helvetica" pitchFamily="34" charset="-122"/>
                 <a:cs typeface="Helvetica" pitchFamily="34" charset="-120"/>
               </a:rPr>
-              <a:t>678.993 €</a:t>
+              <a:t>–</a:t>
             </a:r>
             <a:endParaRPr lang="en-US" sz="2200" dirty="0"/>
           </a:p>
@@ -6524,8 +6576,8 @@
         </p:nvSpPr>
         <p:spPr>
           <a:xfrm>
-            <a:off x="4343400" y="4389120"/>
-            <a:ext cx="2926080" cy="256032"/>
+            <a:off x="6455664" y="2971800"/>
+            <a:ext cx="1298448" cy="256032"/>
           </a:xfrm>
           <a:prstGeom prst="rect">
             <a:avLst/>
@@ -6549,7 +6601,7 @@
                 <a:ea typeface="Helvetica" pitchFamily="34" charset="-122"/>
                 <a:cs typeface="Helvetica" pitchFamily="34" charset="-120"/>
               </a:rPr>
-              <a:t>15 Rechnungen · brutto · alle Parteien</a:t>
+              <a:t>zugeordnete Eingangsrechnungen</a:t>
             </a:r>
             <a:endParaRPr lang="en-US" sz="950" dirty="0"/>
           </a:p>
@@ -6563,12 +6615,12 @@
         </p:nvSpPr>
         <p:spPr>
           <a:xfrm>
-            <a:off x="7863840" y="1783080"/>
-            <a:ext cx="3776472" cy="4206240"/>
+            <a:off x="548640" y="3520440"/>
+            <a:ext cx="1755648" cy="1234440"/>
           </a:xfrm>
           <a:prstGeom prst="roundRect">
             <a:avLst>
-              <a:gd name="adj" fmla="val 2906"/>
+              <a:gd name="adj" fmla="val 8889"/>
             </a:avLst>
           </a:prstGeom>
           <a:solidFill>
@@ -6597,8 +6649,8 @@
         </p:nvSpPr>
         <p:spPr>
           <a:xfrm>
-            <a:off x="8138160" y="1965960"/>
-            <a:ext cx="3291840" cy="274320"/>
+            <a:off x="777240" y="3685032"/>
+            <a:ext cx="1298448" cy="256032"/>
           </a:xfrm>
           <a:prstGeom prst="rect">
             <a:avLst/>
@@ -6614,6 +6666,649 @@
               <a:buNone/>
             </a:pPr>
             <a:r>
+              <a:rPr lang="en-US" sz="800" spc="60" kern="0" dirty="0">
+                <a:solidFill>
+                  <a:srgbClr val="6A6A6A"/>
+                </a:solidFill>
+                <a:latin typeface="Helvetica" pitchFamily="34" charset="0"/>
+                <a:ea typeface="Helvetica" pitchFamily="34" charset="-122"/>
+                <a:cs typeface="Helvetica" pitchFamily="34" charset="-120"/>
+              </a:rPr>
+              <a:t>MARGE SOLL</a:t>
+            </a:r>
+            <a:endParaRPr lang="en-US" sz="800" dirty="0"/>
+          </a:p>
+        </p:txBody>
+      </p:sp>
+      <p:sp>
+        <p:nvSpPr>
+          <p:cNvPr id="28" name="Text 25"/>
+          <p:cNvSpPr txBox="1"/>
+          <p:nvPr/>
+        </p:nvSpPr>
+        <p:spPr>
+          <a:xfrm>
+            <a:off x="777240" y="3931920"/>
+            <a:ext cx="1298448" cy="457200"/>
+          </a:xfrm>
+          <a:prstGeom prst="rect">
+            <a:avLst/>
+          </a:prstGeom>
+          <a:noFill/>
+          <a:ln/>
+        </p:spPr>
+        <p:txBody>
+          <a:bodyPr wrap="square" lIns="0" tIns="0" rIns="0" bIns="0" rtlCol="0" anchor="ctr"/>
+          <a:lstStyle/>
+          <a:p>
+            <a:pPr indent="0" marL="0">
+              <a:buNone/>
+            </a:pPr>
+            <a:r>
+              <a:rPr lang="en-US" sz="2200" b="1" dirty="0">
+                <a:solidFill>
+                  <a:srgbClr val="5A7D52"/>
+                </a:solidFill>
+                <a:latin typeface="Helvetica" pitchFamily="34" charset="0"/>
+                <a:ea typeface="Helvetica" pitchFamily="34" charset="-122"/>
+                <a:cs typeface="Helvetica" pitchFamily="34" charset="-120"/>
+              </a:rPr>
+              <a:t>–</a:t>
+            </a:r>
+            <a:endParaRPr lang="en-US" sz="2200" dirty="0"/>
+          </a:p>
+        </p:txBody>
+      </p:sp>
+      <p:sp>
+        <p:nvSpPr>
+          <p:cNvPr id="29" name="Text 26"/>
+          <p:cNvSpPr txBox="1"/>
+          <p:nvPr/>
+        </p:nvSpPr>
+        <p:spPr>
+          <a:xfrm>
+            <a:off x="777240" y="4389120"/>
+            <a:ext cx="1298448" cy="256032"/>
+          </a:xfrm>
+          <a:prstGeom prst="rect">
+            <a:avLst/>
+          </a:prstGeom>
+          <a:noFill/>
+          <a:ln/>
+        </p:spPr>
+        <p:txBody>
+          <a:bodyPr wrap="square" lIns="0" tIns="0" rIns="0" bIns="0" rtlCol="0" anchor="ctr"/>
+          <a:lstStyle/>
+          <a:p>
+            <a:pPr indent="0" marL="0">
+              <a:buNone/>
+            </a:pPr>
+            <a:r>
+              <a:rPr lang="en-US" sz="950" dirty="0">
+                <a:solidFill>
+                  <a:srgbClr val="6A6A6A"/>
+                </a:solidFill>
+                <a:latin typeface="Helvetica" pitchFamily="34" charset="0"/>
+                <a:ea typeface="Helvetica" pitchFamily="34" charset="-122"/>
+                <a:cs typeface="Helvetica" pitchFamily="34" charset="-120"/>
+              </a:rPr>
+              <a:t>Budget − geplante Kosten (Kalkulations-Soll)</a:t>
+            </a:r>
+            <a:endParaRPr lang="en-US" sz="950" dirty="0"/>
+          </a:p>
+        </p:txBody>
+      </p:sp>
+      <p:sp>
+        <p:nvSpPr>
+          <p:cNvPr id="30" name="Shape 27"/>
+          <p:cNvSpPr/>
+          <p:nvPr/>
+        </p:nvSpPr>
+        <p:spPr>
+          <a:xfrm>
+            <a:off x="2441448" y="3520440"/>
+            <a:ext cx="1755648" cy="1234440"/>
+          </a:xfrm>
+          <a:prstGeom prst="roundRect">
+            <a:avLst>
+              <a:gd name="adj" fmla="val 8889"/>
+            </a:avLst>
+          </a:prstGeom>
+          <a:solidFill>
+            <a:srgbClr val="FFFFFF"/>
+          </a:solidFill>
+          <a:ln w="9525">
+            <a:solidFill>
+              <a:srgbClr val="E4E1DB"/>
+            </a:solidFill>
+            <a:prstDash val="solid"/>
+          </a:ln>
+          <a:effectLst>
+            <a:outerShdw sx="100000" sy="100000" kx="0" ky="0" algn="bl" rotWithShape="0" blurRad="76200" dist="25400" dir="5400000">
+              <a:srgbClr val="000000">
+                <a:alpha val="6000"/>
+              </a:srgbClr>
+            </a:outerShdw>
+          </a:effectLst>
+        </p:spPr>
+      </p:sp>
+      <p:sp>
+        <p:nvSpPr>
+          <p:cNvPr id="31" name="Text 28"/>
+          <p:cNvSpPr txBox="1"/>
+          <p:nvPr/>
+        </p:nvSpPr>
+        <p:spPr>
+          <a:xfrm>
+            <a:off x="2670048" y="3685032"/>
+            <a:ext cx="1298448" cy="256032"/>
+          </a:xfrm>
+          <a:prstGeom prst="rect">
+            <a:avLst/>
+          </a:prstGeom>
+          <a:noFill/>
+          <a:ln/>
+        </p:spPr>
+        <p:txBody>
+          <a:bodyPr wrap="square" lIns="0" tIns="0" rIns="0" bIns="0" rtlCol="0" anchor="ctr"/>
+          <a:lstStyle/>
+          <a:p>
+            <a:pPr indent="0" marL="0">
+              <a:buNone/>
+            </a:pPr>
+            <a:r>
+              <a:rPr lang="en-US" sz="800" spc="60" kern="0" dirty="0">
+                <a:solidFill>
+                  <a:srgbClr val="6A6A6A"/>
+                </a:solidFill>
+                <a:latin typeface="Helvetica" pitchFamily="34" charset="0"/>
+                <a:ea typeface="Helvetica" pitchFamily="34" charset="-122"/>
+                <a:cs typeface="Helvetica" pitchFamily="34" charset="-120"/>
+              </a:rPr>
+              <a:t>MARGE IST</a:t>
+            </a:r>
+            <a:endParaRPr lang="en-US" sz="800" dirty="0"/>
+          </a:p>
+        </p:txBody>
+      </p:sp>
+      <p:sp>
+        <p:nvSpPr>
+          <p:cNvPr id="32" name="Text 29"/>
+          <p:cNvSpPr txBox="1"/>
+          <p:nvPr/>
+        </p:nvSpPr>
+        <p:spPr>
+          <a:xfrm>
+            <a:off x="2670048" y="3931920"/>
+            <a:ext cx="1298448" cy="457200"/>
+          </a:xfrm>
+          <a:prstGeom prst="rect">
+            <a:avLst/>
+          </a:prstGeom>
+          <a:noFill/>
+          <a:ln/>
+        </p:spPr>
+        <p:txBody>
+          <a:bodyPr wrap="square" lIns="0" tIns="0" rIns="0" bIns="0" rtlCol="0" anchor="ctr"/>
+          <a:lstStyle/>
+          <a:p>
+            <a:pPr indent="0" marL="0">
+              <a:buNone/>
+            </a:pPr>
+            <a:r>
+              <a:rPr lang="en-US" sz="2200" b="1" dirty="0">
+                <a:solidFill>
+                  <a:srgbClr val="5A7D52"/>
+                </a:solidFill>
+                <a:latin typeface="Helvetica" pitchFamily="34" charset="0"/>
+                <a:ea typeface="Helvetica" pitchFamily="34" charset="-122"/>
+                <a:cs typeface="Helvetica" pitchFamily="34" charset="-120"/>
+              </a:rPr>
+              <a:t>–</a:t>
+            </a:r>
+            <a:endParaRPr lang="en-US" sz="2200" dirty="0"/>
+          </a:p>
+        </p:txBody>
+      </p:sp>
+      <p:sp>
+        <p:nvSpPr>
+          <p:cNvPr id="33" name="Text 30"/>
+          <p:cNvSpPr txBox="1"/>
+          <p:nvPr/>
+        </p:nvSpPr>
+        <p:spPr>
+          <a:xfrm>
+            <a:off x="2670048" y="4389120"/>
+            <a:ext cx="1298448" cy="256032"/>
+          </a:xfrm>
+          <a:prstGeom prst="rect">
+            <a:avLst/>
+          </a:prstGeom>
+          <a:noFill/>
+          <a:ln/>
+        </p:spPr>
+        <p:txBody>
+          <a:bodyPr wrap="square" lIns="0" tIns="0" rIns="0" bIns="0" rtlCol="0" anchor="ctr"/>
+          <a:lstStyle/>
+          <a:p>
+            <a:pPr indent="0" marL="0">
+              <a:buNone/>
+            </a:pPr>
+            <a:r>
+              <a:rPr lang="en-US" sz="950" dirty="0">
+                <a:solidFill>
+                  <a:srgbClr val="6A6A6A"/>
+                </a:solidFill>
+                <a:latin typeface="Helvetica" pitchFamily="34" charset="0"/>
+                <a:ea typeface="Helvetica" pitchFamily="34" charset="-122"/>
+                <a:cs typeface="Helvetica" pitchFamily="34" charset="-120"/>
+              </a:rPr>
+              <a:t>Budget − Kosten Ist</a:t>
+            </a:r>
+            <a:endParaRPr lang="en-US" sz="950" dirty="0"/>
+          </a:p>
+        </p:txBody>
+      </p:sp>
+      <p:sp>
+        <p:nvSpPr>
+          <p:cNvPr id="34" name="Shape 31"/>
+          <p:cNvSpPr/>
+          <p:nvPr/>
+        </p:nvSpPr>
+        <p:spPr>
+          <a:xfrm>
+            <a:off x="4334256" y="3520440"/>
+            <a:ext cx="1755648" cy="1234440"/>
+          </a:xfrm>
+          <a:prstGeom prst="roundRect">
+            <a:avLst>
+              <a:gd name="adj" fmla="val 8889"/>
+            </a:avLst>
+          </a:prstGeom>
+          <a:solidFill>
+            <a:srgbClr val="FFFFFF"/>
+          </a:solidFill>
+          <a:ln w="9525">
+            <a:solidFill>
+              <a:srgbClr val="E4E1DB"/>
+            </a:solidFill>
+            <a:prstDash val="solid"/>
+          </a:ln>
+          <a:effectLst>
+            <a:outerShdw sx="100000" sy="100000" kx="0" ky="0" algn="bl" rotWithShape="0" blurRad="76200" dist="25400" dir="5400000">
+              <a:srgbClr val="000000">
+                <a:alpha val="6000"/>
+              </a:srgbClr>
+            </a:outerShdw>
+          </a:effectLst>
+        </p:spPr>
+      </p:sp>
+      <p:sp>
+        <p:nvSpPr>
+          <p:cNvPr id="35" name="Text 32"/>
+          <p:cNvSpPr txBox="1"/>
+          <p:nvPr/>
+        </p:nvSpPr>
+        <p:spPr>
+          <a:xfrm>
+            <a:off x="4562856" y="3685032"/>
+            <a:ext cx="1298448" cy="256032"/>
+          </a:xfrm>
+          <a:prstGeom prst="rect">
+            <a:avLst/>
+          </a:prstGeom>
+          <a:noFill/>
+          <a:ln/>
+        </p:spPr>
+        <p:txBody>
+          <a:bodyPr wrap="square" lIns="0" tIns="0" rIns="0" bIns="0" rtlCol="0" anchor="ctr"/>
+          <a:lstStyle/>
+          <a:p>
+            <a:pPr indent="0" marL="0">
+              <a:buNone/>
+            </a:pPr>
+            <a:r>
+              <a:rPr lang="en-US" sz="800" spc="60" kern="0" dirty="0">
+                <a:solidFill>
+                  <a:srgbClr val="6A6A6A"/>
+                </a:solidFill>
+                <a:latin typeface="Helvetica" pitchFamily="34" charset="0"/>
+                <a:ea typeface="Helvetica" pitchFamily="34" charset="-122"/>
+                <a:cs typeface="Helvetica" pitchFamily="34" charset="-120"/>
+              </a:rPr>
+              <a:t>EINGANGSRECHN.</a:t>
+            </a:r>
+            <a:endParaRPr lang="en-US" sz="800" dirty="0"/>
+          </a:p>
+        </p:txBody>
+      </p:sp>
+      <p:sp>
+        <p:nvSpPr>
+          <p:cNvPr id="36" name="Text 33"/>
+          <p:cNvSpPr txBox="1"/>
+          <p:nvPr/>
+        </p:nvSpPr>
+        <p:spPr>
+          <a:xfrm>
+            <a:off x="4562856" y="3931920"/>
+            <a:ext cx="1298448" cy="457200"/>
+          </a:xfrm>
+          <a:prstGeom prst="rect">
+            <a:avLst/>
+          </a:prstGeom>
+          <a:noFill/>
+          <a:ln/>
+        </p:spPr>
+        <p:txBody>
+          <a:bodyPr wrap="square" lIns="0" tIns="0" rIns="0" bIns="0" rtlCol="0" anchor="ctr"/>
+          <a:lstStyle/>
+          <a:p>
+            <a:pPr indent="0" marL="0">
+              <a:buNone/>
+            </a:pPr>
+            <a:r>
+              <a:rPr lang="en-US" sz="2200" b="1" dirty="0">
+                <a:solidFill>
+                  <a:srgbClr val="3D3D3D"/>
+                </a:solidFill>
+                <a:latin typeface="Helvetica" pitchFamily="34" charset="0"/>
+                <a:ea typeface="Helvetica" pitchFamily="34" charset="-122"/>
+                <a:cs typeface="Helvetica" pitchFamily="34" charset="-120"/>
+              </a:rPr>
+              <a:t>–</a:t>
+            </a:r>
+            <a:endParaRPr lang="en-US" sz="2200" dirty="0"/>
+          </a:p>
+        </p:txBody>
+      </p:sp>
+      <p:sp>
+        <p:nvSpPr>
+          <p:cNvPr id="37" name="Text 34"/>
+          <p:cNvSpPr txBox="1"/>
+          <p:nvPr/>
+        </p:nvSpPr>
+        <p:spPr>
+          <a:xfrm>
+            <a:off x="4562856" y="4389120"/>
+            <a:ext cx="1298448" cy="256032"/>
+          </a:xfrm>
+          <a:prstGeom prst="rect">
+            <a:avLst/>
+          </a:prstGeom>
+          <a:noFill/>
+          <a:ln/>
+        </p:spPr>
+        <p:txBody>
+          <a:bodyPr wrap="square" lIns="0" tIns="0" rIns="0" bIns="0" rtlCol="0" anchor="ctr"/>
+          <a:lstStyle/>
+          <a:p>
+            <a:pPr indent="0" marL="0">
+              <a:buNone/>
+            </a:pPr>
+            <a:r>
+              <a:rPr lang="en-US" sz="950" dirty="0">
+                <a:solidFill>
+                  <a:srgbClr val="6A6A6A"/>
+                </a:solidFill>
+                <a:latin typeface="Helvetica" pitchFamily="34" charset="0"/>
+                <a:ea typeface="Helvetica" pitchFamily="34" charset="-122"/>
+                <a:cs typeface="Helvetica" pitchFamily="34" charset="-120"/>
+              </a:rPr>
+              <a:t>zugewiesene Eingangsrechnungen</a:t>
+            </a:r>
+            <a:endParaRPr lang="en-US" sz="950" dirty="0"/>
+          </a:p>
+        </p:txBody>
+      </p:sp>
+      <p:sp>
+        <p:nvSpPr>
+          <p:cNvPr id="38" name="Shape 35"/>
+          <p:cNvSpPr/>
+          <p:nvPr/>
+        </p:nvSpPr>
+        <p:spPr>
+          <a:xfrm>
+            <a:off x="6227064" y="3520440"/>
+            <a:ext cx="1755648" cy="1234440"/>
+          </a:xfrm>
+          <a:prstGeom prst="roundRect">
+            <a:avLst>
+              <a:gd name="adj" fmla="val 8889"/>
+            </a:avLst>
+          </a:prstGeom>
+          <a:solidFill>
+            <a:srgbClr val="FFFFFF"/>
+          </a:solidFill>
+          <a:ln w="9525">
+            <a:solidFill>
+              <a:srgbClr val="E4E1DB"/>
+            </a:solidFill>
+            <a:prstDash val="solid"/>
+          </a:ln>
+          <a:effectLst>
+            <a:outerShdw sx="100000" sy="100000" kx="0" ky="0" algn="bl" rotWithShape="0" blurRad="76200" dist="25400" dir="5400000">
+              <a:srgbClr val="000000">
+                <a:alpha val="6000"/>
+              </a:srgbClr>
+            </a:outerShdw>
+          </a:effectLst>
+        </p:spPr>
+      </p:sp>
+      <p:sp>
+        <p:nvSpPr>
+          <p:cNvPr id="39" name="Text 36"/>
+          <p:cNvSpPr txBox="1"/>
+          <p:nvPr/>
+        </p:nvSpPr>
+        <p:spPr>
+          <a:xfrm>
+            <a:off x="6455664" y="3685032"/>
+            <a:ext cx="1298448" cy="256032"/>
+          </a:xfrm>
+          <a:prstGeom prst="rect">
+            <a:avLst/>
+          </a:prstGeom>
+          <a:noFill/>
+          <a:ln/>
+        </p:spPr>
+        <p:txBody>
+          <a:bodyPr wrap="square" lIns="0" tIns="0" rIns="0" bIns="0" rtlCol="0" anchor="ctr"/>
+          <a:lstStyle/>
+          <a:p>
+            <a:pPr indent="0" marL="0">
+              <a:buNone/>
+            </a:pPr>
+            <a:r>
+              <a:rPr lang="en-US" sz="800" spc="60" kern="0" dirty="0">
+                <a:solidFill>
+                  <a:srgbClr val="6A6A6A"/>
+                </a:solidFill>
+                <a:latin typeface="Helvetica" pitchFamily="34" charset="0"/>
+                <a:ea typeface="Helvetica" pitchFamily="34" charset="-122"/>
+                <a:cs typeface="Helvetica" pitchFamily="34" charset="-120"/>
+              </a:rPr>
+              <a:t>OFFEN BEIM KUNDEN</a:t>
+            </a:r>
+            <a:endParaRPr lang="en-US" sz="800" dirty="0"/>
+          </a:p>
+        </p:txBody>
+      </p:sp>
+      <p:sp>
+        <p:nvSpPr>
+          <p:cNvPr id="40" name="Text 37"/>
+          <p:cNvSpPr txBox="1"/>
+          <p:nvPr/>
+        </p:nvSpPr>
+        <p:spPr>
+          <a:xfrm>
+            <a:off x="6455664" y="3931920"/>
+            <a:ext cx="1298448" cy="457200"/>
+          </a:xfrm>
+          <a:prstGeom prst="rect">
+            <a:avLst/>
+          </a:prstGeom>
+          <a:noFill/>
+          <a:ln/>
+        </p:spPr>
+        <p:txBody>
+          <a:bodyPr wrap="square" lIns="0" tIns="0" rIns="0" bIns="0" rtlCol="0" anchor="ctr"/>
+          <a:lstStyle/>
+          <a:p>
+            <a:pPr indent="0" marL="0">
+              <a:buNone/>
+            </a:pPr>
+            <a:r>
+              <a:rPr lang="en-US" sz="2200" b="1" dirty="0">
+                <a:solidFill>
+                  <a:srgbClr val="A8884F"/>
+                </a:solidFill>
+                <a:latin typeface="Helvetica" pitchFamily="34" charset="0"/>
+                <a:ea typeface="Helvetica" pitchFamily="34" charset="-122"/>
+                <a:cs typeface="Helvetica" pitchFamily="34" charset="-120"/>
+              </a:rPr>
+              <a:t>–</a:t>
+            </a:r>
+            <a:endParaRPr lang="en-US" sz="2200" dirty="0"/>
+          </a:p>
+        </p:txBody>
+      </p:sp>
+      <p:sp>
+        <p:nvSpPr>
+          <p:cNvPr id="41" name="Text 38"/>
+          <p:cNvSpPr txBox="1"/>
+          <p:nvPr/>
+        </p:nvSpPr>
+        <p:spPr>
+          <a:xfrm>
+            <a:off x="6455664" y="4389120"/>
+            <a:ext cx="1298448" cy="256032"/>
+          </a:xfrm>
+          <a:prstGeom prst="rect">
+            <a:avLst/>
+          </a:prstGeom>
+          <a:noFill/>
+          <a:ln/>
+        </p:spPr>
+        <p:txBody>
+          <a:bodyPr wrap="square" lIns="0" tIns="0" rIns="0" bIns="0" rtlCol="0" anchor="ctr"/>
+          <a:lstStyle/>
+          <a:p>
+            <a:pPr indent="0" marL="0">
+              <a:buNone/>
+            </a:pPr>
+            <a:r>
+              <a:rPr lang="en-US" sz="950" dirty="0">
+                <a:solidFill>
+                  <a:srgbClr val="6A6A6A"/>
+                </a:solidFill>
+                <a:latin typeface="Helvetica" pitchFamily="34" charset="0"/>
+                <a:ea typeface="Helvetica" pitchFamily="34" charset="-122"/>
+                <a:cs typeface="Helvetica" pitchFamily="34" charset="-120"/>
+              </a:rPr>
+              <a:t>Bestätigt − Erlöse (Ist)</a:t>
+            </a:r>
+            <a:endParaRPr lang="en-US" sz="950" dirty="0"/>
+          </a:p>
+        </p:txBody>
+      </p:sp>
+      <p:sp>
+        <p:nvSpPr>
+          <p:cNvPr id="42" name="Text 39"/>
+          <p:cNvSpPr txBox="1"/>
+          <p:nvPr/>
+        </p:nvSpPr>
+        <p:spPr>
+          <a:xfrm>
+            <a:off x="548640" y="4892040"/>
+            <a:ext cx="7498080" cy="365760"/>
+          </a:xfrm>
+          <a:prstGeom prst="rect">
+            <a:avLst/>
+          </a:prstGeom>
+          <a:noFill/>
+          <a:ln/>
+        </p:spPr>
+        <p:txBody>
+          <a:bodyPr wrap="square" lIns="0" tIns="0" rIns="0" bIns="0" rtlCol="0" anchor="ctr"/>
+          <a:lstStyle/>
+          <a:p>
+            <a:pPr indent="0" marL="0">
+              <a:buNone/>
+            </a:pPr>
+            <a:r>
+              <a:rPr lang="en-US" sz="1000" i="1" dirty="0">
+                <a:solidFill>
+                  <a:srgbClr val="C7AB78"/>
+                </a:solidFill>
+                <a:latin typeface="Helvetica" pitchFamily="34" charset="0"/>
+                <a:ea typeface="Helvetica" pitchFamily="34" charset="-122"/>
+                <a:cs typeface="Helvetica" pitchFamily="34" charset="-120"/>
+              </a:rPr>
+              <a:t>Zahlen folgen aus der Nova Works App (Auswertung → Zeile „Summe Bestätigt“).</a:t>
+            </a:r>
+            <a:endParaRPr lang="en-US" sz="1000" dirty="0"/>
+          </a:p>
+        </p:txBody>
+      </p:sp>
+      <p:sp>
+        <p:nvSpPr>
+          <p:cNvPr id="43" name="Shape 40"/>
+          <p:cNvSpPr/>
+          <p:nvPr/>
+        </p:nvSpPr>
+        <p:spPr>
+          <a:xfrm>
+            <a:off x="8229600" y="1783080"/>
+            <a:ext cx="3410712" cy="4206240"/>
+          </a:xfrm>
+          <a:prstGeom prst="roundRect">
+            <a:avLst>
+              <a:gd name="adj" fmla="val 3217"/>
+            </a:avLst>
+          </a:prstGeom>
+          <a:solidFill>
+            <a:srgbClr val="FFFFFF"/>
+          </a:solidFill>
+          <a:ln w="9525">
+            <a:solidFill>
+              <a:srgbClr val="E4E1DB"/>
+            </a:solidFill>
+            <a:prstDash val="solid"/>
+          </a:ln>
+          <a:effectLst>
+            <a:outerShdw sx="100000" sy="100000" kx="0" ky="0" algn="bl" rotWithShape="0" blurRad="76200" dist="25400" dir="5400000">
+              <a:srgbClr val="000000">
+                <a:alpha val="6000"/>
+              </a:srgbClr>
+            </a:outerShdw>
+          </a:effectLst>
+        </p:spPr>
+      </p:sp>
+      <p:sp>
+        <p:nvSpPr>
+          <p:cNvPr id="44" name="Text 41"/>
+          <p:cNvSpPr txBox="1"/>
+          <p:nvPr/>
+        </p:nvSpPr>
+        <p:spPr>
+          <a:xfrm>
+            <a:off x="8503920" y="1965960"/>
+            <a:ext cx="2926080" cy="274320"/>
+          </a:xfrm>
+          <a:prstGeom prst="rect">
+            <a:avLst/>
+          </a:prstGeom>
+          <a:noFill/>
+          <a:ln/>
+        </p:spPr>
+        <p:txBody>
+          <a:bodyPr wrap="square" lIns="0" tIns="0" rIns="0" bIns="0" rtlCol="0" anchor="ctr"/>
+          <a:lstStyle/>
+          <a:p>
+            <a:pPr indent="0" marL="0">
+              <a:buNone/>
+            </a:pPr>
+            <a:r>
               <a:rPr lang="en-US" sz="900" spc="150" kern="0" dirty="0">
                 <a:solidFill>
                   <a:srgbClr val="6A6A6A"/>
@@ -6630,14 +7325,14 @@
       </p:sp>
       <p:sp>
         <p:nvSpPr>
-          <p:cNvPr id="28" name="Text 25"/>
-          <p:cNvSpPr txBox="1"/>
-          <p:nvPr/>
-        </p:nvSpPr>
-        <p:spPr>
-          <a:xfrm>
-            <a:off x="8138160" y="2286000"/>
-            <a:ext cx="3291840" cy="2377440"/>
+          <p:cNvPr id="45" name="Text 42"/>
+          <p:cNvSpPr txBox="1"/>
+          <p:nvPr/>
+        </p:nvSpPr>
+        <p:spPr>
+          <a:xfrm>
+            <a:off x="8503920" y="2286000"/>
+            <a:ext cx="2926080" cy="2651760"/>
           </a:xfrm>
           <a:prstGeom prst="rect">
             <a:avLst/>
@@ -6657,7 +7352,7 @@
               <a:buChar char="■"/>
             </a:pPr>
             <a:r>
-              <a:rPr lang="en-US" sz="1250" dirty="0">
+              <a:rPr lang="en-US" sz="1200" dirty="0">
                 <a:solidFill>
                   <a:srgbClr val="3D3D3D"/>
                 </a:solidFill>
@@ -6667,7 +7362,7 @@
               </a:rPr>
               <a:t>Team und Auslastung</a:t>
             </a:r>
-            <a:endParaRPr lang="en-US" sz="1250" dirty="0"/>
+            <a:endParaRPr lang="en-US" sz="1200" dirty="0"/>
           </a:p>
           <a:p>
             <a:pPr marL="342900" indent="-342900">
@@ -6678,7 +7373,7 @@
               <a:buChar char="■"/>
             </a:pPr>
             <a:r>
-              <a:rPr lang="en-US" sz="1250" dirty="0">
+              <a:rPr lang="en-US" sz="1200" dirty="0">
                 <a:solidFill>
                   <a:srgbClr val="3D3D3D"/>
                 </a:solidFill>
@@ -6688,7 +7383,7 @@
               </a:rPr>
               <a:t>Liquidität und offene Forderungen</a:t>
             </a:r>
-            <a:endParaRPr lang="en-US" sz="1250" dirty="0"/>
+            <a:endParaRPr lang="en-US" sz="1200" dirty="0"/>
           </a:p>
           <a:p>
             <a:pPr marL="342900" indent="-342900">
@@ -6699,7 +7394,7 @@
               <a:buChar char="■"/>
             </a:pPr>
             <a:r>
-              <a:rPr lang="en-US" sz="1250" dirty="0">
+              <a:rPr lang="en-US" sz="1200" dirty="0">
                 <a:solidFill>
                   <a:srgbClr val="3D3D3D"/>
                 </a:solidFill>
@@ -6707,9 +7402,9 @@
                 <a:ea typeface="Helvetica" pitchFamily="34" charset="-122"/>
                 <a:cs typeface="Helvetica" pitchFamily="34" charset="-120"/>
               </a:rPr>
-              <a:t>Kunden und Partner (ProEvent, CGS, TCLG)</a:t>
-            </a:r>
-            <a:endParaRPr lang="en-US" sz="1250" dirty="0"/>
+              <a:t>Kunden und Partner</a:t>
+            </a:r>
+            <a:endParaRPr lang="en-US" sz="1200" dirty="0"/>
           </a:p>
           <a:p>
             <a:pPr marL="342900" indent="-342900">
@@ -6720,7 +7415,7 @@
               <a:buChar char="■"/>
             </a:pPr>
             <a:r>
-              <a:rPr lang="en-US" sz="1250" dirty="0">
+              <a:rPr lang="en-US" sz="1200" dirty="0">
                 <a:solidFill>
                   <a:srgbClr val="3D3D3D"/>
                 </a:solidFill>
@@ -6730,7 +7425,7 @@
               </a:rPr>
               <a:t>Werkzeuge: Nova Works App im Einsatz</a:t>
             </a:r>
-            <a:endParaRPr lang="en-US" sz="1250" dirty="0"/>
+            <a:endParaRPr lang="en-US" sz="1200" dirty="0"/>
           </a:p>
           <a:p>
             <a:pPr marL="342900" indent="-342900">
@@ -6741,7 +7436,7 @@
               <a:buChar char="■"/>
             </a:pPr>
             <a:r>
-              <a:rPr lang="en-US" sz="1250" dirty="0">
+              <a:rPr lang="en-US" sz="1200" dirty="0">
                 <a:solidFill>
                   <a:srgbClr val="3D3D3D"/>
                 </a:solidFill>
@@ -6751,20 +7446,20 @@
               </a:rPr>
               <a:t>Offene Punkte</a:t>
             </a:r>
-            <a:endParaRPr lang="en-US" sz="1250" dirty="0"/>
-          </a:p>
-        </p:txBody>
-      </p:sp>
-      <p:sp>
-        <p:nvSpPr>
-          <p:cNvPr id="29" name="Text 26"/>
-          <p:cNvSpPr txBox="1"/>
-          <p:nvPr/>
-        </p:nvSpPr>
-        <p:spPr>
-          <a:xfrm>
-            <a:off x="8138160" y="5212080"/>
-            <a:ext cx="3291840" cy="548640"/>
+            <a:endParaRPr lang="en-US" sz="1200" dirty="0"/>
+          </a:p>
+        </p:txBody>
+      </p:sp>
+      <p:sp>
+        <p:nvSpPr>
+          <p:cNvPr id="46" name="Text 43"/>
+          <p:cNvSpPr txBox="1"/>
+          <p:nvPr/>
+        </p:nvSpPr>
+        <p:spPr>
+          <a:xfrm>
+            <a:off x="8503920" y="5212080"/>
+            <a:ext cx="2926080" cy="548640"/>
           </a:xfrm>
           <a:prstGeom prst="rect">
             <a:avLst/>
@@ -6826,9 +7521,48 @@
           <a:chExt cx="0" cy="0"/>
         </a:xfrm>
       </p:grpSpPr>
+      <p:sp>
+        <p:nvSpPr>
+          <p:cNvPr id="2" name="Text 0"/>
+          <p:cNvSpPr txBox="1"/>
+          <p:nvPr/>
+        </p:nvSpPr>
+        <p:spPr>
+          <a:xfrm>
+            <a:off x="7802575" y="914400"/>
+            <a:ext cx="3840480" cy="256032"/>
+          </a:xfrm>
+          <a:prstGeom prst="rect">
+            <a:avLst/>
+          </a:prstGeom>
+          <a:noFill/>
+          <a:ln/>
+        </p:spPr>
+        <p:txBody>
+          <a:bodyPr wrap="square" lIns="0" tIns="0" rIns="0" bIns="0" rtlCol="0" anchor="ctr"/>
+          <a:lstStyle/>
+          <a:p>
+            <a:pPr algn="r" indent="0" marL="0">
+              <a:buNone/>
+            </a:pPr>
+            <a:r>
+              <a:rPr lang="en-US" sz="850" b="1" spc="200" kern="0" dirty="0">
+                <a:solidFill>
+                  <a:srgbClr val="A8884F"/>
+                </a:solidFill>
+                <a:latin typeface="Helvetica" pitchFamily="34" charset="0"/>
+                <a:ea typeface="Helvetica" pitchFamily="34" charset="-122"/>
+                <a:cs typeface="Helvetica" pitchFamily="34" charset="-120"/>
+              </a:rPr>
+              <a:t>TOP 2  ·  FOLIE 1 von 2</a:t>
+            </a:r>
+            <a:endParaRPr lang="en-US" sz="850" dirty="0"/>
+          </a:p>
+        </p:txBody>
+      </p:sp>
       <p:pic>
         <p:nvPicPr>
-          <p:cNvPr id="2" name="Image 0" descr="/home/user/nova-works-app/scripts/assets/nova-works-logo.png">    </p:cNvPr>
+          <p:cNvPr id="3" name="Image 0" descr="/home/user/nova-works-app/scripts/assets/nova-works-logo.png">    </p:cNvPr>
           <p:cNvPicPr>
             <a:picLocks noChangeAspect="1"/>
           </p:cNvPicPr>
@@ -6852,7 +7586,7 @@
       </p:pic>
       <p:sp>
         <p:nvSpPr>
-          <p:cNvPr id="3" name="Text 0"/>
+          <p:cNvPr id="4" name="Text 1"/>
           <p:cNvSpPr txBox="1"/>
           <p:nvPr/>
         </p:nvSpPr>
@@ -6891,7 +7625,7 @@
       </p:sp>
       <p:sp>
         <p:nvSpPr>
-          <p:cNvPr id="4" name="Text 1"/>
+          <p:cNvPr id="5" name="Text 2"/>
           <p:cNvSpPr txBox="1"/>
           <p:nvPr/>
         </p:nvSpPr>
@@ -6930,7 +7664,7 @@
       </p:sp>
       <p:sp>
         <p:nvSpPr>
-          <p:cNvPr id="5" name="Shape 2"/>
+          <p:cNvPr id="6" name="Shape 3"/>
           <p:cNvSpPr/>
           <p:nvPr/>
         </p:nvSpPr>
@@ -6955,7 +7689,7 @@
       </p:sp>
       <p:sp>
         <p:nvSpPr>
-          <p:cNvPr id="6" name="Text 3"/>
+          <p:cNvPr id="7" name="Text 4"/>
           <p:cNvSpPr txBox="1"/>
           <p:nvPr/>
         </p:nvSpPr>
@@ -6994,7 +7728,7 @@
       </p:sp>
       <p:sp>
         <p:nvSpPr>
-          <p:cNvPr id="7" name="Text 4"/>
+          <p:cNvPr id="8" name="Text 5"/>
           <p:cNvSpPr txBox="1"/>
           <p:nvPr/>
         </p:nvSpPr>
@@ -7033,7 +7767,7 @@
       </p:sp>
       <p:sp>
         <p:nvSpPr>
-          <p:cNvPr id="8" name="Text 5"/>
+          <p:cNvPr id="9" name="Text 6"/>
           <p:cNvSpPr txBox="1"/>
           <p:nvPr/>
         </p:nvSpPr>
@@ -7064,7 +7798,7 @@
                 <a:ea typeface="Helvetica" pitchFamily="34" charset="-122"/>
                 <a:cs typeface="Helvetica" pitchFamily="34" charset="-120"/>
               </a:rPr>
-              <a:t>Was ist seit Mai 2026 passiert?</a:t>
+              <a:t>Projekte Mai bis September 2026</a:t>
             </a:r>
             <a:endParaRPr lang="en-US" sz="1250" dirty="0"/>
           </a:p>
@@ -7072,13 +7806,13 @@
       </p:sp>
       <p:sp>
         <p:nvSpPr>
-          <p:cNvPr id="9" name="Shape 6"/>
+          <p:cNvPr id="10" name="Shape 7"/>
           <p:cNvSpPr/>
           <p:nvPr/>
         </p:nvSpPr>
         <p:spPr>
           <a:xfrm>
-            <a:off x="548640" y="2331720"/>
+            <a:off x="548640" y="2148840"/>
             <a:ext cx="11094415" cy="0"/>
           </a:xfrm>
           <a:prstGeom prst="line">
@@ -7095,13 +7829,52 @@
       </p:sp>
       <p:sp>
         <p:nvSpPr>
-          <p:cNvPr id="10" name="Shape 7"/>
+          <p:cNvPr id="11" name="Text 8"/>
+          <p:cNvSpPr txBox="1"/>
+          <p:nvPr/>
+        </p:nvSpPr>
+        <p:spPr>
+          <a:xfrm>
+            <a:off x="7802575" y="1188720"/>
+            <a:ext cx="3840480" cy="320040"/>
+          </a:xfrm>
+          <a:prstGeom prst="rect">
+            <a:avLst/>
+          </a:prstGeom>
+          <a:noFill/>
+          <a:ln/>
+        </p:spPr>
+        <p:txBody>
+          <a:bodyPr wrap="square" lIns="0" tIns="0" rIns="0" bIns="0" rtlCol="0" anchor="ctr"/>
+          <a:lstStyle/>
+          <a:p>
+            <a:pPr algn="r" indent="0" marL="0">
+              <a:buNone/>
+            </a:pPr>
+            <a:r>
+              <a:rPr lang="en-US" sz="1250" dirty="0">
+                <a:solidFill>
+                  <a:srgbClr val="6A6A6A"/>
+                </a:solidFill>
+                <a:latin typeface="Helvetica" pitchFamily="34" charset="0"/>
+                <a:ea typeface="Helvetica" pitchFamily="34" charset="-122"/>
+                <a:cs typeface="Helvetica" pitchFamily="34" charset="-120"/>
+              </a:rPr>
+              <a:t>17 Projekte in fünf Monaten</a:t>
+            </a:r>
+            <a:endParaRPr lang="en-US" sz="1250" dirty="0"/>
+          </a:p>
+        </p:txBody>
+      </p:sp>
+      <p:sp>
+        <p:nvSpPr>
+          <p:cNvPr id="12" name="Shape 9"/>
           <p:cNvSpPr/>
           <p:nvPr/>
         </p:nvSpPr>
         <p:spPr>
           <a:xfrm>
-            <a:off x="1575786" y="2249424"/>
+            <a:off x="1575786" y="2066544"/>
             <a:ext cx="164592" cy="164592"/>
           </a:xfrm>
           <a:prstGeom prst="ellipse">
@@ -7120,13 +7893,13 @@
       </p:sp>
       <p:sp>
         <p:nvSpPr>
-          <p:cNvPr id="11" name="Text 8"/>
-          <p:cNvSpPr txBox="1"/>
-          <p:nvPr/>
-        </p:nvSpPr>
-        <p:spPr>
-          <a:xfrm>
-            <a:off x="548640" y="1828800"/>
+          <p:cNvPr id="13" name="Text 10"/>
+          <p:cNvSpPr txBox="1"/>
+          <p:nvPr/>
+        </p:nvSpPr>
+        <p:spPr>
+          <a:xfrm>
+            <a:off x="548640" y="1645920"/>
             <a:ext cx="2218883" cy="320040"/>
           </a:xfrm>
           <a:prstGeom prst="rect">
@@ -7152,70 +7925,6 @@
                 <a:cs typeface="Helvetica" pitchFamily="34" charset="-120"/>
               </a:rPr>
               <a:t>Mai 2026</a:t>
-            </a:r>
-            <a:endParaRPr lang="en-US" sz="1200" dirty="0"/>
-          </a:p>
-        </p:txBody>
-      </p:sp>
-      <p:sp>
-        <p:nvSpPr>
-          <p:cNvPr id="12" name="Shape 9"/>
-          <p:cNvSpPr/>
-          <p:nvPr/>
-        </p:nvSpPr>
-        <p:spPr>
-          <a:xfrm>
-            <a:off x="3794669" y="2249424"/>
-            <a:ext cx="164592" cy="164592"/>
-          </a:xfrm>
-          <a:prstGeom prst="ellipse">
-            <a:avLst/>
-          </a:prstGeom>
-          <a:solidFill>
-            <a:srgbClr val="A8884F"/>
-          </a:solidFill>
-          <a:ln w="12700">
-            <a:solidFill>
-              <a:srgbClr val="A8884F"/>
-            </a:solidFill>
-            <a:prstDash val="solid"/>
-          </a:ln>
-        </p:spPr>
-      </p:sp>
-      <p:sp>
-        <p:nvSpPr>
-          <p:cNvPr id="13" name="Text 10"/>
-          <p:cNvSpPr txBox="1"/>
-          <p:nvPr/>
-        </p:nvSpPr>
-        <p:spPr>
-          <a:xfrm>
-            <a:off x="2767523" y="1828800"/>
-            <a:ext cx="2218883" cy="320040"/>
-          </a:xfrm>
-          <a:prstGeom prst="rect">
-            <a:avLst/>
-          </a:prstGeom>
-          <a:noFill/>
-          <a:ln/>
-        </p:spPr>
-        <p:txBody>
-          <a:bodyPr wrap="square" lIns="0" tIns="0" rIns="0" bIns="0" rtlCol="0" anchor="ctr"/>
-          <a:lstStyle/>
-          <a:p>
-            <a:pPr algn="ctr" indent="0" marL="0">
-              <a:buNone/>
-            </a:pPr>
-            <a:r>
-              <a:rPr lang="en-US" sz="1200" b="1" dirty="0">
-                <a:solidFill>
-                  <a:srgbClr val="3D3D3D"/>
-                </a:solidFill>
-                <a:latin typeface="Helvetica" pitchFamily="34" charset="0"/>
-                <a:ea typeface="Helvetica" pitchFamily="34" charset="-122"/>
-                <a:cs typeface="Helvetica" pitchFamily="34" charset="-120"/>
-              </a:rPr>
-              <a:t>Juni 2026</a:t>
             </a:r>
             <a:endParaRPr lang="en-US" sz="1200" dirty="0"/>
           </a:p>
@@ -7229,204 +7938,12 @@
         </p:nvSpPr>
         <p:spPr>
           <a:xfrm>
-            <a:off x="6013552" y="2249424"/>
-            <a:ext cx="164592" cy="164592"/>
-          </a:xfrm>
-          <a:prstGeom prst="ellipse">
-            <a:avLst/>
-          </a:prstGeom>
-          <a:solidFill>
-            <a:srgbClr val="A8884F"/>
-          </a:solidFill>
-          <a:ln w="12700">
-            <a:solidFill>
-              <a:srgbClr val="A8884F"/>
-            </a:solidFill>
-            <a:prstDash val="solid"/>
-          </a:ln>
-        </p:spPr>
-      </p:sp>
-      <p:sp>
-        <p:nvSpPr>
-          <p:cNvPr id="15" name="Text 12"/>
-          <p:cNvSpPr txBox="1"/>
-          <p:nvPr/>
-        </p:nvSpPr>
-        <p:spPr>
-          <a:xfrm>
-            <a:off x="4986406" y="1828800"/>
-            <a:ext cx="2218883" cy="320040"/>
-          </a:xfrm>
-          <a:prstGeom prst="rect">
-            <a:avLst/>
-          </a:prstGeom>
-          <a:noFill/>
-          <a:ln/>
-        </p:spPr>
-        <p:txBody>
-          <a:bodyPr wrap="square" lIns="0" tIns="0" rIns="0" bIns="0" rtlCol="0" anchor="ctr"/>
-          <a:lstStyle/>
-          <a:p>
-            <a:pPr algn="ctr" indent="0" marL="0">
-              <a:buNone/>
-            </a:pPr>
-            <a:r>
-              <a:rPr lang="en-US" sz="1200" b="1" dirty="0">
-                <a:solidFill>
-                  <a:srgbClr val="3D3D3D"/>
-                </a:solidFill>
-                <a:latin typeface="Helvetica" pitchFamily="34" charset="0"/>
-                <a:ea typeface="Helvetica" pitchFamily="34" charset="-122"/>
-                <a:cs typeface="Helvetica" pitchFamily="34" charset="-120"/>
-              </a:rPr>
-              <a:t>Juli 2026</a:t>
-            </a:r>
-            <a:endParaRPr lang="en-US" sz="1200" dirty="0"/>
-          </a:p>
-        </p:txBody>
-      </p:sp>
-      <p:sp>
-        <p:nvSpPr>
-          <p:cNvPr id="16" name="Shape 13"/>
-          <p:cNvSpPr/>
-          <p:nvPr/>
-        </p:nvSpPr>
-        <p:spPr>
-          <a:xfrm>
-            <a:off x="8232435" y="2249424"/>
-            <a:ext cx="164592" cy="164592"/>
-          </a:xfrm>
-          <a:prstGeom prst="ellipse">
-            <a:avLst/>
-          </a:prstGeom>
-          <a:solidFill>
-            <a:srgbClr val="A8884F"/>
-          </a:solidFill>
-          <a:ln w="12700">
-            <a:solidFill>
-              <a:srgbClr val="A8884F"/>
-            </a:solidFill>
-            <a:prstDash val="solid"/>
-          </a:ln>
-        </p:spPr>
-      </p:sp>
-      <p:sp>
-        <p:nvSpPr>
-          <p:cNvPr id="17" name="Text 14"/>
-          <p:cNvSpPr txBox="1"/>
-          <p:nvPr/>
-        </p:nvSpPr>
-        <p:spPr>
-          <a:xfrm>
-            <a:off x="7205289" y="1828800"/>
-            <a:ext cx="2218883" cy="320040"/>
-          </a:xfrm>
-          <a:prstGeom prst="rect">
-            <a:avLst/>
-          </a:prstGeom>
-          <a:noFill/>
-          <a:ln/>
-        </p:spPr>
-        <p:txBody>
-          <a:bodyPr wrap="square" lIns="0" tIns="0" rIns="0" bIns="0" rtlCol="0" anchor="ctr"/>
-          <a:lstStyle/>
-          <a:p>
-            <a:pPr algn="ctr" indent="0" marL="0">
-              <a:buNone/>
-            </a:pPr>
-            <a:r>
-              <a:rPr lang="en-US" sz="1200" b="1" dirty="0">
-                <a:solidFill>
-                  <a:srgbClr val="3D3D3D"/>
-                </a:solidFill>
-                <a:latin typeface="Helvetica" pitchFamily="34" charset="0"/>
-                <a:ea typeface="Helvetica" pitchFamily="34" charset="-122"/>
-                <a:cs typeface="Helvetica" pitchFamily="34" charset="-120"/>
-              </a:rPr>
-              <a:t>August 2026</a:t>
-            </a:r>
-            <a:endParaRPr lang="en-US" sz="1200" dirty="0"/>
-          </a:p>
-        </p:txBody>
-      </p:sp>
-      <p:sp>
-        <p:nvSpPr>
-          <p:cNvPr id="18" name="Shape 15"/>
-          <p:cNvSpPr/>
-          <p:nvPr/>
-        </p:nvSpPr>
-        <p:spPr>
-          <a:xfrm>
-            <a:off x="10451318" y="2249424"/>
-            <a:ext cx="164592" cy="164592"/>
-          </a:xfrm>
-          <a:prstGeom prst="ellipse">
-            <a:avLst/>
-          </a:prstGeom>
-          <a:solidFill>
-            <a:srgbClr val="A8884F"/>
-          </a:solidFill>
-          <a:ln w="12700">
-            <a:solidFill>
-              <a:srgbClr val="A8884F"/>
-            </a:solidFill>
-            <a:prstDash val="solid"/>
-          </a:ln>
-        </p:spPr>
-      </p:sp>
-      <p:sp>
-        <p:nvSpPr>
-          <p:cNvPr id="19" name="Text 16"/>
-          <p:cNvSpPr txBox="1"/>
-          <p:nvPr/>
-        </p:nvSpPr>
-        <p:spPr>
-          <a:xfrm>
-            <a:off x="9424172" y="1828800"/>
-            <a:ext cx="2218883" cy="320040"/>
-          </a:xfrm>
-          <a:prstGeom prst="rect">
-            <a:avLst/>
-          </a:prstGeom>
-          <a:noFill/>
-          <a:ln/>
-        </p:spPr>
-        <p:txBody>
-          <a:bodyPr wrap="square" lIns="0" tIns="0" rIns="0" bIns="0" rtlCol="0" anchor="ctr"/>
-          <a:lstStyle/>
-          <a:p>
-            <a:pPr algn="ctr" indent="0" marL="0">
-              <a:buNone/>
-            </a:pPr>
-            <a:r>
-              <a:rPr lang="en-US" sz="1200" b="1" dirty="0">
-                <a:solidFill>
-                  <a:srgbClr val="3D3D3D"/>
-                </a:solidFill>
-                <a:latin typeface="Helvetica" pitchFamily="34" charset="0"/>
-                <a:ea typeface="Helvetica" pitchFamily="34" charset="-122"/>
-                <a:cs typeface="Helvetica" pitchFamily="34" charset="-120"/>
-              </a:rPr>
-              <a:t>September 2026</a:t>
-            </a:r>
-            <a:endParaRPr lang="en-US" sz="1200" dirty="0"/>
-          </a:p>
-        </p:txBody>
-      </p:sp>
-      <p:sp>
-        <p:nvSpPr>
-          <p:cNvPr id="20" name="Shape 17"/>
-          <p:cNvSpPr/>
-          <p:nvPr/>
-        </p:nvSpPr>
-        <p:spPr>
-          <a:xfrm>
-            <a:off x="658368" y="2651760"/>
-            <a:ext cx="1999427" cy="1371600"/>
+            <a:off x="640080" y="2468880"/>
+            <a:ext cx="2036003" cy="2203704"/>
           </a:xfrm>
           <a:prstGeom prst="roundRect">
             <a:avLst>
-              <a:gd name="adj" fmla="val 8000"/>
+              <a:gd name="adj" fmla="val 5389"/>
             </a:avLst>
           </a:prstGeom>
           <a:solidFill>
@@ -7449,14 +7966,53 @@
       </p:sp>
       <p:sp>
         <p:nvSpPr>
-          <p:cNvPr id="21" name="Text 18"/>
-          <p:cNvSpPr txBox="1"/>
-          <p:nvPr/>
-        </p:nvSpPr>
-        <p:spPr>
-          <a:xfrm>
-            <a:off x="822960" y="2788920"/>
-            <a:ext cx="1670243" cy="411480"/>
+          <p:cNvPr id="15" name="Text 12"/>
+          <p:cNvSpPr txBox="1"/>
+          <p:nvPr/>
+        </p:nvSpPr>
+        <p:spPr>
+          <a:xfrm>
+            <a:off x="804672" y="2633472"/>
+            <a:ext cx="1706819" cy="228600"/>
+          </a:xfrm>
+          <a:prstGeom prst="rect">
+            <a:avLst/>
+          </a:prstGeom>
+          <a:noFill/>
+          <a:ln/>
+        </p:spPr>
+        <p:txBody>
+          <a:bodyPr wrap="square" lIns="0" tIns="0" rIns="0" bIns="0" rtlCol="0" anchor="ctr"/>
+          <a:lstStyle/>
+          <a:p>
+            <a:pPr indent="0" marL="0">
+              <a:buNone/>
+            </a:pPr>
+            <a:r>
+              <a:rPr lang="en-US" sz="900" b="1" spc="100" kern="0" dirty="0">
+                <a:solidFill>
+                  <a:srgbClr val="A8884F"/>
+                </a:solidFill>
+                <a:latin typeface="Helvetica" pitchFamily="34" charset="0"/>
+                <a:ea typeface="Helvetica" pitchFamily="34" charset="-122"/>
+                <a:cs typeface="Helvetica" pitchFamily="34" charset="-120"/>
+              </a:rPr>
+              <a:t>26-0015</a:t>
+            </a:r>
+            <a:endParaRPr lang="en-US" sz="900" dirty="0"/>
+          </a:p>
+        </p:txBody>
+      </p:sp>
+      <p:sp>
+        <p:nvSpPr>
+          <p:cNvPr id="16" name="Text 13"/>
+          <p:cNvSpPr txBox="1"/>
+          <p:nvPr/>
+        </p:nvSpPr>
+        <p:spPr>
+          <a:xfrm>
+            <a:off x="804672" y="2852928"/>
+            <a:ext cx="1706819" cy="384048"/>
           </a:xfrm>
           <a:prstGeom prst="rect">
             <a:avLst/>
@@ -7472,6 +8028,226 @@
               <a:buNone/>
             </a:pPr>
             <a:r>
+              <a:rPr lang="en-US" sz="1100" b="1" dirty="0">
+                <a:solidFill>
+                  <a:srgbClr val="3D3D3D"/>
+                </a:solidFill>
+                <a:latin typeface="Helvetica" pitchFamily="34" charset="0"/>
+                <a:ea typeface="Helvetica" pitchFamily="34" charset="-122"/>
+                <a:cs typeface="Helvetica" pitchFamily="34" charset="-120"/>
+              </a:rPr>
+              <a:t>SWR3 ESC Party</a:t>
+            </a:r>
+            <a:endParaRPr lang="en-US" sz="1100" dirty="0"/>
+          </a:p>
+        </p:txBody>
+      </p:sp>
+      <p:sp>
+        <p:nvSpPr>
+          <p:cNvPr id="17" name="Text 14"/>
+          <p:cNvSpPr txBox="1"/>
+          <p:nvPr/>
+        </p:nvSpPr>
+        <p:spPr>
+          <a:xfrm>
+            <a:off x="804672" y="3291840"/>
+            <a:ext cx="1706819" cy="228600"/>
+          </a:xfrm>
+          <a:prstGeom prst="rect">
+            <a:avLst/>
+          </a:prstGeom>
+          <a:noFill/>
+          <a:ln/>
+        </p:spPr>
+        <p:txBody>
+          <a:bodyPr wrap="square" lIns="0" tIns="0" rIns="0" bIns="0" rtlCol="0" anchor="ctr"/>
+          <a:lstStyle/>
+          <a:p>
+            <a:pPr indent="0" marL="0">
+              <a:buNone/>
+            </a:pPr>
+            <a:r>
+              <a:rPr lang="en-US" sz="900" b="1" spc="100" kern="0" dirty="0">
+                <a:solidFill>
+                  <a:srgbClr val="A8884F"/>
+                </a:solidFill>
+                <a:latin typeface="Helvetica" pitchFamily="34" charset="0"/>
+                <a:ea typeface="Helvetica" pitchFamily="34" charset="-122"/>
+                <a:cs typeface="Helvetica" pitchFamily="34" charset="-120"/>
+              </a:rPr>
+              <a:t>26-0011</a:t>
+            </a:r>
+            <a:endParaRPr lang="en-US" sz="900" dirty="0"/>
+          </a:p>
+        </p:txBody>
+      </p:sp>
+      <p:sp>
+        <p:nvSpPr>
+          <p:cNvPr id="18" name="Text 15"/>
+          <p:cNvSpPr txBox="1"/>
+          <p:nvPr/>
+        </p:nvSpPr>
+        <p:spPr>
+          <a:xfrm>
+            <a:off x="804672" y="3511296"/>
+            <a:ext cx="1706819" cy="384048"/>
+          </a:xfrm>
+          <a:prstGeom prst="rect">
+            <a:avLst/>
+          </a:prstGeom>
+          <a:noFill/>
+          <a:ln/>
+        </p:spPr>
+        <p:txBody>
+          <a:bodyPr wrap="square" lIns="0" tIns="0" rIns="0" bIns="0" rtlCol="0" anchor="t"/>
+          <a:lstStyle/>
+          <a:p>
+            <a:pPr indent="0" marL="0">
+              <a:buNone/>
+            </a:pPr>
+            <a:r>
+              <a:rPr lang="en-US" sz="1100" b="1" dirty="0">
+                <a:solidFill>
+                  <a:srgbClr val="3D3D3D"/>
+                </a:solidFill>
+                <a:latin typeface="Helvetica" pitchFamily="34" charset="0"/>
+                <a:ea typeface="Helvetica" pitchFamily="34" charset="-122"/>
+                <a:cs typeface="Helvetica" pitchFamily="34" charset="-120"/>
+              </a:rPr>
+              <a:t>Ikarus</a:t>
+            </a:r>
+            <a:endParaRPr lang="en-US" sz="1100" dirty="0"/>
+          </a:p>
+        </p:txBody>
+      </p:sp>
+      <p:sp>
+        <p:nvSpPr>
+          <p:cNvPr id="19" name="Text 16"/>
+          <p:cNvSpPr txBox="1"/>
+          <p:nvPr/>
+        </p:nvSpPr>
+        <p:spPr>
+          <a:xfrm>
+            <a:off x="804672" y="3950208"/>
+            <a:ext cx="1706819" cy="228600"/>
+          </a:xfrm>
+          <a:prstGeom prst="rect">
+            <a:avLst/>
+          </a:prstGeom>
+          <a:noFill/>
+          <a:ln/>
+        </p:spPr>
+        <p:txBody>
+          <a:bodyPr wrap="square" lIns="0" tIns="0" rIns="0" bIns="0" rtlCol="0" anchor="ctr"/>
+          <a:lstStyle/>
+          <a:p>
+            <a:pPr indent="0" marL="0">
+              <a:buNone/>
+            </a:pPr>
+            <a:r>
+              <a:rPr lang="en-US" sz="900" b="1" spc="100" kern="0" dirty="0">
+                <a:solidFill>
+                  <a:srgbClr val="A8884F"/>
+                </a:solidFill>
+                <a:latin typeface="Helvetica" pitchFamily="34" charset="0"/>
+                <a:ea typeface="Helvetica" pitchFamily="34" charset="-122"/>
+                <a:cs typeface="Helvetica" pitchFamily="34" charset="-120"/>
+              </a:rPr>
+              <a:t>26-0029</a:t>
+            </a:r>
+            <a:endParaRPr lang="en-US" sz="900" dirty="0"/>
+          </a:p>
+        </p:txBody>
+      </p:sp>
+      <p:sp>
+        <p:nvSpPr>
+          <p:cNvPr id="20" name="Text 17"/>
+          <p:cNvSpPr txBox="1"/>
+          <p:nvPr/>
+        </p:nvSpPr>
+        <p:spPr>
+          <a:xfrm>
+            <a:off x="804672" y="4169664"/>
+            <a:ext cx="1706819" cy="384048"/>
+          </a:xfrm>
+          <a:prstGeom prst="rect">
+            <a:avLst/>
+          </a:prstGeom>
+          <a:noFill/>
+          <a:ln/>
+        </p:spPr>
+        <p:txBody>
+          <a:bodyPr wrap="square" lIns="0" tIns="0" rIns="0" bIns="0" rtlCol="0" anchor="t"/>
+          <a:lstStyle/>
+          <a:p>
+            <a:pPr indent="0" marL="0">
+              <a:buNone/>
+            </a:pPr>
+            <a:r>
+              <a:rPr lang="en-US" sz="1100" b="1" dirty="0">
+                <a:solidFill>
+                  <a:srgbClr val="3D3D3D"/>
+                </a:solidFill>
+                <a:latin typeface="Helvetica" pitchFamily="34" charset="0"/>
+                <a:ea typeface="Helvetica" pitchFamily="34" charset="-122"/>
+                <a:cs typeface="Helvetica" pitchFamily="34" charset="-120"/>
+              </a:rPr>
+              <a:t>LED Trailer Krones</a:t>
+            </a:r>
+            <a:endParaRPr lang="en-US" sz="1100" dirty="0"/>
+          </a:p>
+        </p:txBody>
+      </p:sp>
+      <p:sp>
+        <p:nvSpPr>
+          <p:cNvPr id="21" name="Shape 18"/>
+          <p:cNvSpPr/>
+          <p:nvPr/>
+        </p:nvSpPr>
+        <p:spPr>
+          <a:xfrm>
+            <a:off x="3794669" y="2066544"/>
+            <a:ext cx="164592" cy="164592"/>
+          </a:xfrm>
+          <a:prstGeom prst="ellipse">
+            <a:avLst/>
+          </a:prstGeom>
+          <a:solidFill>
+            <a:srgbClr val="A8884F"/>
+          </a:solidFill>
+          <a:ln w="12700">
+            <a:solidFill>
+              <a:srgbClr val="A8884F"/>
+            </a:solidFill>
+            <a:prstDash val="solid"/>
+          </a:ln>
+        </p:spPr>
+      </p:sp>
+      <p:sp>
+        <p:nvSpPr>
+          <p:cNvPr id="22" name="Text 19"/>
+          <p:cNvSpPr txBox="1"/>
+          <p:nvPr/>
+        </p:nvSpPr>
+        <p:spPr>
+          <a:xfrm>
+            <a:off x="2767523" y="1645920"/>
+            <a:ext cx="2218883" cy="320040"/>
+          </a:xfrm>
+          <a:prstGeom prst="rect">
+            <a:avLst/>
+          </a:prstGeom>
+          <a:noFill/>
+          <a:ln/>
+        </p:spPr>
+        <p:txBody>
+          <a:bodyPr wrap="square" lIns="0" tIns="0" rIns="0" bIns="0" rtlCol="0" anchor="ctr"/>
+          <a:lstStyle/>
+          <a:p>
+            <a:pPr algn="ctr" indent="0" marL="0">
+              <a:buNone/>
+            </a:pPr>
+            <a:r>
               <a:rPr lang="en-US" sz="1200" b="1" dirty="0">
                 <a:solidFill>
                   <a:srgbClr val="3D3D3D"/>
@@ -7480,48 +8256,9 @@
                 <a:ea typeface="Helvetica" pitchFamily="34" charset="-122"/>
                 <a:cs typeface="Helvetica" pitchFamily="34" charset="-120"/>
               </a:rPr>
-              <a:t>Vorbereitung Inselfieber</a:t>
+              <a:t>Juni 2026</a:t>
             </a:r>
             <a:endParaRPr lang="en-US" sz="1200" dirty="0"/>
-          </a:p>
-        </p:txBody>
-      </p:sp>
-      <p:sp>
-        <p:nvSpPr>
-          <p:cNvPr id="22" name="Text 19"/>
-          <p:cNvSpPr txBox="1"/>
-          <p:nvPr/>
-        </p:nvSpPr>
-        <p:spPr>
-          <a:xfrm>
-            <a:off x="822960" y="3218688"/>
-            <a:ext cx="1670243" cy="731520"/>
-          </a:xfrm>
-          <a:prstGeom prst="rect">
-            <a:avLst/>
-          </a:prstGeom>
-          <a:noFill/>
-          <a:ln/>
-        </p:spPr>
-        <p:txBody>
-          <a:bodyPr wrap="square" lIns="0" tIns="0" rIns="0" bIns="0" rtlCol="0" anchor="t"/>
-          <a:lstStyle/>
-          <a:p>
-            <a:pPr indent="0" marL="0">
-              <a:buNone/>
-            </a:pPr>
-            <a:r>
-              <a:rPr lang="en-US" sz="950" dirty="0">
-                <a:solidFill>
-                  <a:srgbClr val="6A6A6A"/>
-                </a:solidFill>
-                <a:latin typeface="Helvetica" pitchFamily="34" charset="0"/>
-                <a:ea typeface="Helvetica" pitchFamily="34" charset="-122"/>
-                <a:cs typeface="Helvetica" pitchFamily="34" charset="-120"/>
-              </a:rPr>
-              <a:t>26-0008 · Vorkasse an ProEvent</a:t>
-            </a:r>
-            <a:endParaRPr lang="en-US" sz="950" dirty="0"/>
           </a:p>
         </p:txBody>
       </p:sp>
@@ -7533,12 +8270,12 @@
         </p:nvSpPr>
         <p:spPr>
           <a:xfrm>
-            <a:off x="2877251" y="2651760"/>
-            <a:ext cx="1999427" cy="1371600"/>
+            <a:off x="2858963" y="2468880"/>
+            <a:ext cx="2036003" cy="2862072"/>
           </a:xfrm>
           <a:prstGeom prst="roundRect">
             <a:avLst>
-              <a:gd name="adj" fmla="val 8000"/>
+              <a:gd name="adj" fmla="val 5389"/>
             </a:avLst>
           </a:prstGeom>
           <a:solidFill>
@@ -7567,8 +8304,47 @@
         </p:nvSpPr>
         <p:spPr>
           <a:xfrm>
-            <a:off x="3041843" y="2788920"/>
-            <a:ext cx="1670243" cy="411480"/>
+            <a:off x="3023555" y="2633472"/>
+            <a:ext cx="1706819" cy="228600"/>
+          </a:xfrm>
+          <a:prstGeom prst="rect">
+            <a:avLst/>
+          </a:prstGeom>
+          <a:noFill/>
+          <a:ln/>
+        </p:spPr>
+        <p:txBody>
+          <a:bodyPr wrap="square" lIns="0" tIns="0" rIns="0" bIns="0" rtlCol="0" anchor="ctr"/>
+          <a:lstStyle/>
+          <a:p>
+            <a:pPr indent="0" marL="0">
+              <a:buNone/>
+            </a:pPr>
+            <a:r>
+              <a:rPr lang="en-US" sz="900" b="1" spc="100" kern="0" dirty="0">
+                <a:solidFill>
+                  <a:srgbClr val="A8884F"/>
+                </a:solidFill>
+                <a:latin typeface="Helvetica" pitchFamily="34" charset="0"/>
+                <a:ea typeface="Helvetica" pitchFamily="34" charset="-122"/>
+                <a:cs typeface="Helvetica" pitchFamily="34" charset="-120"/>
+              </a:rPr>
+              <a:t>26-0026</a:t>
+            </a:r>
+            <a:endParaRPr lang="en-US" sz="900" dirty="0"/>
+          </a:p>
+        </p:txBody>
+      </p:sp>
+      <p:sp>
+        <p:nvSpPr>
+          <p:cNvPr id="25" name="Text 22"/>
+          <p:cNvSpPr txBox="1"/>
+          <p:nvPr/>
+        </p:nvSpPr>
+        <p:spPr>
+          <a:xfrm>
+            <a:off x="3023555" y="2852928"/>
+            <a:ext cx="1706819" cy="384048"/>
           </a:xfrm>
           <a:prstGeom prst="rect">
             <a:avLst/>
@@ -7584,6 +8360,304 @@
               <a:buNone/>
             </a:pPr>
             <a:r>
+              <a:rPr lang="en-US" sz="1100" b="1" dirty="0">
+                <a:solidFill>
+                  <a:srgbClr val="3D3D3D"/>
+                </a:solidFill>
+                <a:latin typeface="Helvetica" pitchFamily="34" charset="0"/>
+                <a:ea typeface="Helvetica" pitchFamily="34" charset="-122"/>
+                <a:cs typeface="Helvetica" pitchFamily="34" charset="-120"/>
+              </a:rPr>
+              <a:t>i&amp;u Studios · LED Säule</a:t>
+            </a:r>
+            <a:endParaRPr lang="en-US" sz="1100" dirty="0"/>
+          </a:p>
+        </p:txBody>
+      </p:sp>
+      <p:sp>
+        <p:nvSpPr>
+          <p:cNvPr id="26" name="Text 23"/>
+          <p:cNvSpPr txBox="1"/>
+          <p:nvPr/>
+        </p:nvSpPr>
+        <p:spPr>
+          <a:xfrm>
+            <a:off x="3023555" y="3291840"/>
+            <a:ext cx="1706819" cy="228600"/>
+          </a:xfrm>
+          <a:prstGeom prst="rect">
+            <a:avLst/>
+          </a:prstGeom>
+          <a:noFill/>
+          <a:ln/>
+        </p:spPr>
+        <p:txBody>
+          <a:bodyPr wrap="square" lIns="0" tIns="0" rIns="0" bIns="0" rtlCol="0" anchor="ctr"/>
+          <a:lstStyle/>
+          <a:p>
+            <a:pPr indent="0" marL="0">
+              <a:buNone/>
+            </a:pPr>
+            <a:r>
+              <a:rPr lang="en-US" sz="900" b="1" spc="100" kern="0" dirty="0">
+                <a:solidFill>
+                  <a:srgbClr val="A8884F"/>
+                </a:solidFill>
+                <a:latin typeface="Helvetica" pitchFamily="34" charset="0"/>
+                <a:ea typeface="Helvetica" pitchFamily="34" charset="-122"/>
+                <a:cs typeface="Helvetica" pitchFamily="34" charset="-120"/>
+              </a:rPr>
+              <a:t>26-0021</a:t>
+            </a:r>
+            <a:endParaRPr lang="en-US" sz="900" dirty="0"/>
+          </a:p>
+        </p:txBody>
+      </p:sp>
+      <p:sp>
+        <p:nvSpPr>
+          <p:cNvPr id="27" name="Text 24"/>
+          <p:cNvSpPr txBox="1"/>
+          <p:nvPr/>
+        </p:nvSpPr>
+        <p:spPr>
+          <a:xfrm>
+            <a:off x="3023555" y="3511296"/>
+            <a:ext cx="1706819" cy="384048"/>
+          </a:xfrm>
+          <a:prstGeom prst="rect">
+            <a:avLst/>
+          </a:prstGeom>
+          <a:noFill/>
+          <a:ln/>
+        </p:spPr>
+        <p:txBody>
+          <a:bodyPr wrap="square" lIns="0" tIns="0" rIns="0" bIns="0" rtlCol="0" anchor="t"/>
+          <a:lstStyle/>
+          <a:p>
+            <a:pPr indent="0" marL="0">
+              <a:buNone/>
+            </a:pPr>
+            <a:r>
+              <a:rPr lang="en-US" sz="1100" b="1" dirty="0">
+                <a:solidFill>
+                  <a:srgbClr val="3D3D3D"/>
+                </a:solidFill>
+                <a:latin typeface="Helvetica" pitchFamily="34" charset="0"/>
+                <a:ea typeface="Helvetica" pitchFamily="34" charset="-122"/>
+                <a:cs typeface="Helvetica" pitchFamily="34" charset="-120"/>
+              </a:rPr>
+              <a:t>EB – No Limits FFM</a:t>
+            </a:r>
+            <a:endParaRPr lang="en-US" sz="1100" dirty="0"/>
+          </a:p>
+        </p:txBody>
+      </p:sp>
+      <p:sp>
+        <p:nvSpPr>
+          <p:cNvPr id="28" name="Text 25"/>
+          <p:cNvSpPr txBox="1"/>
+          <p:nvPr/>
+        </p:nvSpPr>
+        <p:spPr>
+          <a:xfrm>
+            <a:off x="3023555" y="3950208"/>
+            <a:ext cx="1706819" cy="228600"/>
+          </a:xfrm>
+          <a:prstGeom prst="rect">
+            <a:avLst/>
+          </a:prstGeom>
+          <a:noFill/>
+          <a:ln/>
+        </p:spPr>
+        <p:txBody>
+          <a:bodyPr wrap="square" lIns="0" tIns="0" rIns="0" bIns="0" rtlCol="0" anchor="ctr"/>
+          <a:lstStyle/>
+          <a:p>
+            <a:pPr indent="0" marL="0">
+              <a:buNone/>
+            </a:pPr>
+            <a:r>
+              <a:rPr lang="en-US" sz="900" b="1" spc="100" kern="0" dirty="0">
+                <a:solidFill>
+                  <a:srgbClr val="A8884F"/>
+                </a:solidFill>
+                <a:latin typeface="Helvetica" pitchFamily="34" charset="0"/>
+                <a:ea typeface="Helvetica" pitchFamily="34" charset="-122"/>
+                <a:cs typeface="Helvetica" pitchFamily="34" charset="-120"/>
+              </a:rPr>
+              <a:t>26-0008</a:t>
+            </a:r>
+            <a:endParaRPr lang="en-US" sz="900" dirty="0"/>
+          </a:p>
+        </p:txBody>
+      </p:sp>
+      <p:sp>
+        <p:nvSpPr>
+          <p:cNvPr id="29" name="Text 26"/>
+          <p:cNvSpPr txBox="1"/>
+          <p:nvPr/>
+        </p:nvSpPr>
+        <p:spPr>
+          <a:xfrm>
+            <a:off x="3023555" y="4169664"/>
+            <a:ext cx="1706819" cy="384048"/>
+          </a:xfrm>
+          <a:prstGeom prst="rect">
+            <a:avLst/>
+          </a:prstGeom>
+          <a:noFill/>
+          <a:ln/>
+        </p:spPr>
+        <p:txBody>
+          <a:bodyPr wrap="square" lIns="0" tIns="0" rIns="0" bIns="0" rtlCol="0" anchor="t"/>
+          <a:lstStyle/>
+          <a:p>
+            <a:pPr indent="0" marL="0">
+              <a:buNone/>
+            </a:pPr>
+            <a:r>
+              <a:rPr lang="en-US" sz="1100" b="1" dirty="0">
+                <a:solidFill>
+                  <a:srgbClr val="3D3D3D"/>
+                </a:solidFill>
+                <a:latin typeface="Helvetica" pitchFamily="34" charset="0"/>
+                <a:ea typeface="Helvetica" pitchFamily="34" charset="-122"/>
+                <a:cs typeface="Helvetica" pitchFamily="34" charset="-120"/>
+              </a:rPr>
+              <a:t>Inselfieber Oberhausen</a:t>
+            </a:r>
+            <a:endParaRPr lang="en-US" sz="1100" dirty="0"/>
+          </a:p>
+        </p:txBody>
+      </p:sp>
+      <p:sp>
+        <p:nvSpPr>
+          <p:cNvPr id="30" name="Text 27"/>
+          <p:cNvSpPr txBox="1"/>
+          <p:nvPr/>
+        </p:nvSpPr>
+        <p:spPr>
+          <a:xfrm>
+            <a:off x="3023555" y="4608576"/>
+            <a:ext cx="1706819" cy="228600"/>
+          </a:xfrm>
+          <a:prstGeom prst="rect">
+            <a:avLst/>
+          </a:prstGeom>
+          <a:noFill/>
+          <a:ln/>
+        </p:spPr>
+        <p:txBody>
+          <a:bodyPr wrap="square" lIns="0" tIns="0" rIns="0" bIns="0" rtlCol="0" anchor="ctr"/>
+          <a:lstStyle/>
+          <a:p>
+            <a:pPr indent="0" marL="0">
+              <a:buNone/>
+            </a:pPr>
+            <a:r>
+              <a:rPr lang="en-US" sz="900" b="1" spc="100" kern="0" dirty="0">
+                <a:solidFill>
+                  <a:srgbClr val="A8884F"/>
+                </a:solidFill>
+                <a:latin typeface="Helvetica" pitchFamily="34" charset="0"/>
+                <a:ea typeface="Helvetica" pitchFamily="34" charset="-122"/>
+                <a:cs typeface="Helvetica" pitchFamily="34" charset="-120"/>
+              </a:rPr>
+              <a:t>26-0016</a:t>
+            </a:r>
+            <a:endParaRPr lang="en-US" sz="900" dirty="0"/>
+          </a:p>
+        </p:txBody>
+      </p:sp>
+      <p:sp>
+        <p:nvSpPr>
+          <p:cNvPr id="31" name="Text 28"/>
+          <p:cNvSpPr txBox="1"/>
+          <p:nvPr/>
+        </p:nvSpPr>
+        <p:spPr>
+          <a:xfrm>
+            <a:off x="3023555" y="4828032"/>
+            <a:ext cx="1706819" cy="384048"/>
+          </a:xfrm>
+          <a:prstGeom prst="rect">
+            <a:avLst/>
+          </a:prstGeom>
+          <a:noFill/>
+          <a:ln/>
+        </p:spPr>
+        <p:txBody>
+          <a:bodyPr wrap="square" lIns="0" tIns="0" rIns="0" bIns="0" rtlCol="0" anchor="t"/>
+          <a:lstStyle/>
+          <a:p>
+            <a:pPr indent="0" marL="0">
+              <a:buNone/>
+            </a:pPr>
+            <a:r>
+              <a:rPr lang="en-US" sz="1100" b="1" dirty="0">
+                <a:solidFill>
+                  <a:srgbClr val="3D3D3D"/>
+                </a:solidFill>
+                <a:latin typeface="Helvetica" pitchFamily="34" charset="0"/>
+                <a:ea typeface="Helvetica" pitchFamily="34" charset="-122"/>
+                <a:cs typeface="Helvetica" pitchFamily="34" charset="-120"/>
+              </a:rPr>
+              <a:t>CSD München</a:t>
+            </a:r>
+            <a:endParaRPr lang="en-US" sz="1100" dirty="0"/>
+          </a:p>
+        </p:txBody>
+      </p:sp>
+      <p:sp>
+        <p:nvSpPr>
+          <p:cNvPr id="32" name="Shape 29"/>
+          <p:cNvSpPr/>
+          <p:nvPr/>
+        </p:nvSpPr>
+        <p:spPr>
+          <a:xfrm>
+            <a:off x="6013552" y="2066544"/>
+            <a:ext cx="164592" cy="164592"/>
+          </a:xfrm>
+          <a:prstGeom prst="ellipse">
+            <a:avLst/>
+          </a:prstGeom>
+          <a:solidFill>
+            <a:srgbClr val="A8884F"/>
+          </a:solidFill>
+          <a:ln w="12700">
+            <a:solidFill>
+              <a:srgbClr val="A8884F"/>
+            </a:solidFill>
+            <a:prstDash val="solid"/>
+          </a:ln>
+        </p:spPr>
+      </p:sp>
+      <p:sp>
+        <p:nvSpPr>
+          <p:cNvPr id="33" name="Text 30"/>
+          <p:cNvSpPr txBox="1"/>
+          <p:nvPr/>
+        </p:nvSpPr>
+        <p:spPr>
+          <a:xfrm>
+            <a:off x="4986406" y="1645920"/>
+            <a:ext cx="2218883" cy="320040"/>
+          </a:xfrm>
+          <a:prstGeom prst="rect">
+            <a:avLst/>
+          </a:prstGeom>
+          <a:noFill/>
+          <a:ln/>
+        </p:spPr>
+        <p:txBody>
+          <a:bodyPr wrap="square" lIns="0" tIns="0" rIns="0" bIns="0" rtlCol="0" anchor="ctr"/>
+          <a:lstStyle/>
+          <a:p>
+            <a:pPr algn="ctr" indent="0" marL="0">
+              <a:buNone/>
+            </a:pPr>
+            <a:r>
               <a:rPr lang="en-US" sz="1200" b="1" dirty="0">
                 <a:solidFill>
                   <a:srgbClr val="3D3D3D"/>
@@ -7592,7 +8666,7 @@
                 <a:ea typeface="Helvetica" pitchFamily="34" charset="-122"/>
                 <a:cs typeface="Helvetica" pitchFamily="34" charset="-120"/>
               </a:rPr>
-              <a:t>Inselfieber Oberhausen</a:t>
+              <a:t>Juli 2026</a:t>
             </a:r>
             <a:endParaRPr lang="en-US" sz="1200" dirty="0"/>
           </a:p>
@@ -7600,57 +8674,18 @@
       </p:sp>
       <p:sp>
         <p:nvSpPr>
-          <p:cNvPr id="25" name="Text 22"/>
-          <p:cNvSpPr txBox="1"/>
-          <p:nvPr/>
-        </p:nvSpPr>
-        <p:spPr>
-          <a:xfrm>
-            <a:off x="3041843" y="3218688"/>
-            <a:ext cx="1670243" cy="731520"/>
-          </a:xfrm>
-          <a:prstGeom prst="rect">
-            <a:avLst/>
-          </a:prstGeom>
-          <a:noFill/>
-          <a:ln/>
-        </p:spPr>
-        <p:txBody>
-          <a:bodyPr wrap="square" lIns="0" tIns="0" rIns="0" bIns="0" rtlCol="0" anchor="t"/>
-          <a:lstStyle/>
-          <a:p>
-            <a:pPr indent="0" marL="0">
-              <a:buNone/>
-            </a:pPr>
-            <a:r>
-              <a:rPr lang="en-US" sz="950" dirty="0">
-                <a:solidFill>
-                  <a:srgbClr val="6A6A6A"/>
-                </a:solidFill>
-                <a:latin typeface="Helvetica" pitchFamily="34" charset="0"/>
-                <a:ea typeface="Helvetica" pitchFamily="34" charset="-122"/>
-                <a:cs typeface="Helvetica" pitchFamily="34" charset="-120"/>
-              </a:rPr>
-              <a:t>26-0008 · 10.–15.06. · Royal Stage, Bühne, Rigging, LED</a:t>
-            </a:r>
-            <a:endParaRPr lang="en-US" sz="950" dirty="0"/>
-          </a:p>
-        </p:txBody>
-      </p:sp>
-      <p:sp>
-        <p:nvSpPr>
-          <p:cNvPr id="26" name="Shape 23"/>
+          <p:cNvPr id="34" name="Shape 31"/>
           <p:cNvSpPr/>
           <p:nvPr/>
         </p:nvSpPr>
         <p:spPr>
           <a:xfrm>
-            <a:off x="5096134" y="2651760"/>
-            <a:ext cx="1999427" cy="1371600"/>
+            <a:off x="5077846" y="2468880"/>
+            <a:ext cx="2036003" cy="2862072"/>
           </a:xfrm>
           <a:prstGeom prst="roundRect">
             <a:avLst>
-              <a:gd name="adj" fmla="val 8000"/>
+              <a:gd name="adj" fmla="val 5389"/>
             </a:avLst>
           </a:prstGeom>
           <a:solidFill>
@@ -7673,14 +8708,53 @@
       </p:sp>
       <p:sp>
         <p:nvSpPr>
-          <p:cNvPr id="27" name="Text 24"/>
-          <p:cNvSpPr txBox="1"/>
-          <p:nvPr/>
-        </p:nvSpPr>
-        <p:spPr>
-          <a:xfrm>
-            <a:off x="5260726" y="2788920"/>
-            <a:ext cx="1670243" cy="411480"/>
+          <p:cNvPr id="35" name="Text 32"/>
+          <p:cNvSpPr txBox="1"/>
+          <p:nvPr/>
+        </p:nvSpPr>
+        <p:spPr>
+          <a:xfrm>
+            <a:off x="5242438" y="2633472"/>
+            <a:ext cx="1706819" cy="228600"/>
+          </a:xfrm>
+          <a:prstGeom prst="rect">
+            <a:avLst/>
+          </a:prstGeom>
+          <a:noFill/>
+          <a:ln/>
+        </p:spPr>
+        <p:txBody>
+          <a:bodyPr wrap="square" lIns="0" tIns="0" rIns="0" bIns="0" rtlCol="0" anchor="ctr"/>
+          <a:lstStyle/>
+          <a:p>
+            <a:pPr indent="0" marL="0">
+              <a:buNone/>
+            </a:pPr>
+            <a:r>
+              <a:rPr lang="en-US" sz="900" b="1" spc="100" kern="0" dirty="0">
+                <a:solidFill>
+                  <a:srgbClr val="A8884F"/>
+                </a:solidFill>
+                <a:latin typeface="Helvetica" pitchFamily="34" charset="0"/>
+                <a:ea typeface="Helvetica" pitchFamily="34" charset="-122"/>
+                <a:cs typeface="Helvetica" pitchFamily="34" charset="-120"/>
+              </a:rPr>
+              <a:t>26-0007</a:t>
+            </a:r>
+            <a:endParaRPr lang="en-US" sz="900" dirty="0"/>
+          </a:p>
+        </p:txBody>
+      </p:sp>
+      <p:sp>
+        <p:nvSpPr>
+          <p:cNvPr id="36" name="Text 33"/>
+          <p:cNvSpPr txBox="1"/>
+          <p:nvPr/>
+        </p:nvSpPr>
+        <p:spPr>
+          <a:xfrm>
+            <a:off x="5242438" y="2852928"/>
+            <a:ext cx="1706819" cy="384048"/>
           </a:xfrm>
           <a:prstGeom prst="rect">
             <a:avLst/>
@@ -7696,6 +8770,304 @@
               <a:buNone/>
             </a:pPr>
             <a:r>
+              <a:rPr lang="en-US" sz="1100" b="1" dirty="0">
+                <a:solidFill>
+                  <a:srgbClr val="3D3D3D"/>
+                </a:solidFill>
+                <a:latin typeface="Helvetica" pitchFamily="34" charset="0"/>
+                <a:ea typeface="Helvetica" pitchFamily="34" charset="-122"/>
+                <a:cs typeface="Helvetica" pitchFamily="34" charset="-120"/>
+              </a:rPr>
+              <a:t>80er Live</a:t>
+            </a:r>
+            <a:endParaRPr lang="en-US" sz="1100" dirty="0"/>
+          </a:p>
+        </p:txBody>
+      </p:sp>
+      <p:sp>
+        <p:nvSpPr>
+          <p:cNvPr id="37" name="Text 34"/>
+          <p:cNvSpPr txBox="1"/>
+          <p:nvPr/>
+        </p:nvSpPr>
+        <p:spPr>
+          <a:xfrm>
+            <a:off x="5242438" y="3291840"/>
+            <a:ext cx="1706819" cy="228600"/>
+          </a:xfrm>
+          <a:prstGeom prst="rect">
+            <a:avLst/>
+          </a:prstGeom>
+          <a:noFill/>
+          <a:ln/>
+        </p:spPr>
+        <p:txBody>
+          <a:bodyPr wrap="square" lIns="0" tIns="0" rIns="0" bIns="0" rtlCol="0" anchor="ctr"/>
+          <a:lstStyle/>
+          <a:p>
+            <a:pPr indent="0" marL="0">
+              <a:buNone/>
+            </a:pPr>
+            <a:r>
+              <a:rPr lang="en-US" sz="900" b="1" spc="100" kern="0" dirty="0">
+                <a:solidFill>
+                  <a:srgbClr val="A8884F"/>
+                </a:solidFill>
+                <a:latin typeface="Helvetica" pitchFamily="34" charset="0"/>
+                <a:ea typeface="Helvetica" pitchFamily="34" charset="-122"/>
+                <a:cs typeface="Helvetica" pitchFamily="34" charset="-120"/>
+              </a:rPr>
+              <a:t>26-0012</a:t>
+            </a:r>
+            <a:endParaRPr lang="en-US" sz="900" dirty="0"/>
+          </a:p>
+        </p:txBody>
+      </p:sp>
+      <p:sp>
+        <p:nvSpPr>
+          <p:cNvPr id="38" name="Text 35"/>
+          <p:cNvSpPr txBox="1"/>
+          <p:nvPr/>
+        </p:nvSpPr>
+        <p:spPr>
+          <a:xfrm>
+            <a:off x="5242438" y="3511296"/>
+            <a:ext cx="1706819" cy="384048"/>
+          </a:xfrm>
+          <a:prstGeom prst="rect">
+            <a:avLst/>
+          </a:prstGeom>
+          <a:noFill/>
+          <a:ln/>
+        </p:spPr>
+        <p:txBody>
+          <a:bodyPr wrap="square" lIns="0" tIns="0" rIns="0" bIns="0" rtlCol="0" anchor="t"/>
+          <a:lstStyle/>
+          <a:p>
+            <a:pPr indent="0" marL="0">
+              <a:buNone/>
+            </a:pPr>
+            <a:r>
+              <a:rPr lang="en-US" sz="1100" b="1" dirty="0">
+                <a:solidFill>
+                  <a:srgbClr val="3D3D3D"/>
+                </a:solidFill>
+                <a:latin typeface="Helvetica" pitchFamily="34" charset="0"/>
+                <a:ea typeface="Helvetica" pitchFamily="34" charset="-122"/>
+                <a:cs typeface="Helvetica" pitchFamily="34" charset="-120"/>
+              </a:rPr>
+              <a:t>Summerjam</a:t>
+            </a:r>
+            <a:endParaRPr lang="en-US" sz="1100" dirty="0"/>
+          </a:p>
+        </p:txBody>
+      </p:sp>
+      <p:sp>
+        <p:nvSpPr>
+          <p:cNvPr id="39" name="Text 36"/>
+          <p:cNvSpPr txBox="1"/>
+          <p:nvPr/>
+        </p:nvSpPr>
+        <p:spPr>
+          <a:xfrm>
+            <a:off x="5242438" y="3950208"/>
+            <a:ext cx="1706819" cy="228600"/>
+          </a:xfrm>
+          <a:prstGeom prst="rect">
+            <a:avLst/>
+          </a:prstGeom>
+          <a:noFill/>
+          <a:ln/>
+        </p:spPr>
+        <p:txBody>
+          <a:bodyPr wrap="square" lIns="0" tIns="0" rIns="0" bIns="0" rtlCol="0" anchor="ctr"/>
+          <a:lstStyle/>
+          <a:p>
+            <a:pPr indent="0" marL="0">
+              <a:buNone/>
+            </a:pPr>
+            <a:r>
+              <a:rPr lang="en-US" sz="900" b="1" spc="100" kern="0" dirty="0">
+                <a:solidFill>
+                  <a:srgbClr val="A8884F"/>
+                </a:solidFill>
+                <a:latin typeface="Helvetica" pitchFamily="34" charset="0"/>
+                <a:ea typeface="Helvetica" pitchFamily="34" charset="-122"/>
+                <a:cs typeface="Helvetica" pitchFamily="34" charset="-120"/>
+              </a:rPr>
+              <a:t>26-0023</a:t>
+            </a:r>
+            <a:endParaRPr lang="en-US" sz="900" dirty="0"/>
+          </a:p>
+        </p:txBody>
+      </p:sp>
+      <p:sp>
+        <p:nvSpPr>
+          <p:cNvPr id="40" name="Text 37"/>
+          <p:cNvSpPr txBox="1"/>
+          <p:nvPr/>
+        </p:nvSpPr>
+        <p:spPr>
+          <a:xfrm>
+            <a:off x="5242438" y="4169664"/>
+            <a:ext cx="1706819" cy="384048"/>
+          </a:xfrm>
+          <a:prstGeom prst="rect">
+            <a:avLst/>
+          </a:prstGeom>
+          <a:noFill/>
+          <a:ln/>
+        </p:spPr>
+        <p:txBody>
+          <a:bodyPr wrap="square" lIns="0" tIns="0" rIns="0" bIns="0" rtlCol="0" anchor="t"/>
+          <a:lstStyle/>
+          <a:p>
+            <a:pPr indent="0" marL="0">
+              <a:buNone/>
+            </a:pPr>
+            <a:r>
+              <a:rPr lang="en-US" sz="1100" b="1" dirty="0">
+                <a:solidFill>
+                  <a:srgbClr val="3D3D3D"/>
+                </a:solidFill>
+                <a:latin typeface="Helvetica" pitchFamily="34" charset="0"/>
+                <a:ea typeface="Helvetica" pitchFamily="34" charset="-122"/>
+                <a:cs typeface="Helvetica" pitchFamily="34" charset="-120"/>
+              </a:rPr>
+              <a:t>SWR – Andy Borg</a:t>
+            </a:r>
+            <a:endParaRPr lang="en-US" sz="1100" dirty="0"/>
+          </a:p>
+        </p:txBody>
+      </p:sp>
+      <p:sp>
+        <p:nvSpPr>
+          <p:cNvPr id="41" name="Text 38"/>
+          <p:cNvSpPr txBox="1"/>
+          <p:nvPr/>
+        </p:nvSpPr>
+        <p:spPr>
+          <a:xfrm>
+            <a:off x="5242438" y="4608576"/>
+            <a:ext cx="1706819" cy="228600"/>
+          </a:xfrm>
+          <a:prstGeom prst="rect">
+            <a:avLst/>
+          </a:prstGeom>
+          <a:noFill/>
+          <a:ln/>
+        </p:spPr>
+        <p:txBody>
+          <a:bodyPr wrap="square" lIns="0" tIns="0" rIns="0" bIns="0" rtlCol="0" anchor="ctr"/>
+          <a:lstStyle/>
+          <a:p>
+            <a:pPr indent="0" marL="0">
+              <a:buNone/>
+            </a:pPr>
+            <a:r>
+              <a:rPr lang="en-US" sz="900" b="1" spc="100" kern="0" dirty="0">
+                <a:solidFill>
+                  <a:srgbClr val="A8884F"/>
+                </a:solidFill>
+                <a:latin typeface="Helvetica" pitchFamily="34" charset="0"/>
+                <a:ea typeface="Helvetica" pitchFamily="34" charset="-122"/>
+                <a:cs typeface="Helvetica" pitchFamily="34" charset="-120"/>
+              </a:rPr>
+              <a:t>26-0033</a:t>
+            </a:r>
+            <a:endParaRPr lang="en-US" sz="900" dirty="0"/>
+          </a:p>
+        </p:txBody>
+      </p:sp>
+      <p:sp>
+        <p:nvSpPr>
+          <p:cNvPr id="42" name="Text 39"/>
+          <p:cNvSpPr txBox="1"/>
+          <p:nvPr/>
+        </p:nvSpPr>
+        <p:spPr>
+          <a:xfrm>
+            <a:off x="5242438" y="4828032"/>
+            <a:ext cx="1706819" cy="384048"/>
+          </a:xfrm>
+          <a:prstGeom prst="rect">
+            <a:avLst/>
+          </a:prstGeom>
+          <a:noFill/>
+          <a:ln/>
+        </p:spPr>
+        <p:txBody>
+          <a:bodyPr wrap="square" lIns="0" tIns="0" rIns="0" bIns="0" rtlCol="0" anchor="t"/>
+          <a:lstStyle/>
+          <a:p>
+            <a:pPr indent="0" marL="0">
+              <a:buNone/>
+            </a:pPr>
+            <a:r>
+              <a:rPr lang="en-US" sz="1100" b="1" dirty="0">
+                <a:solidFill>
+                  <a:srgbClr val="3D3D3D"/>
+                </a:solidFill>
+                <a:latin typeface="Helvetica" pitchFamily="34" charset="0"/>
+                <a:ea typeface="Helvetica" pitchFamily="34" charset="-122"/>
+                <a:cs typeface="Helvetica" pitchFamily="34" charset="-120"/>
+              </a:rPr>
+              <a:t>Festspielhaus Bayreuth · Alle Farben</a:t>
+            </a:r>
+            <a:endParaRPr lang="en-US" sz="1100" dirty="0"/>
+          </a:p>
+        </p:txBody>
+      </p:sp>
+      <p:sp>
+        <p:nvSpPr>
+          <p:cNvPr id="43" name="Shape 40"/>
+          <p:cNvSpPr/>
+          <p:nvPr/>
+        </p:nvSpPr>
+        <p:spPr>
+          <a:xfrm>
+            <a:off x="8232435" y="2066544"/>
+            <a:ext cx="164592" cy="164592"/>
+          </a:xfrm>
+          <a:prstGeom prst="ellipse">
+            <a:avLst/>
+          </a:prstGeom>
+          <a:solidFill>
+            <a:srgbClr val="A8884F"/>
+          </a:solidFill>
+          <a:ln w="12700">
+            <a:solidFill>
+              <a:srgbClr val="A8884F"/>
+            </a:solidFill>
+            <a:prstDash val="solid"/>
+          </a:ln>
+        </p:spPr>
+      </p:sp>
+      <p:sp>
+        <p:nvSpPr>
+          <p:cNvPr id="44" name="Text 41"/>
+          <p:cNvSpPr txBox="1"/>
+          <p:nvPr/>
+        </p:nvSpPr>
+        <p:spPr>
+          <a:xfrm>
+            <a:off x="7205289" y="1645920"/>
+            <a:ext cx="2218883" cy="320040"/>
+          </a:xfrm>
+          <a:prstGeom prst="rect">
+            <a:avLst/>
+          </a:prstGeom>
+          <a:noFill/>
+          <a:ln/>
+        </p:spPr>
+        <p:txBody>
+          <a:bodyPr wrap="square" lIns="0" tIns="0" rIns="0" bIns="0" rtlCol="0" anchor="ctr"/>
+          <a:lstStyle/>
+          <a:p>
+            <a:pPr algn="ctr" indent="0" marL="0">
+              <a:buNone/>
+            </a:pPr>
+            <a:r>
               <a:rPr lang="en-US" sz="1200" b="1" dirty="0">
                 <a:solidFill>
                   <a:srgbClr val="3D3D3D"/>
@@ -7704,7 +9076,7 @@
                 <a:ea typeface="Helvetica" pitchFamily="34" charset="-122"/>
                 <a:cs typeface="Helvetica" pitchFamily="34" charset="-120"/>
               </a:rPr>
-              <a:t>80er Live Hamburg</a:t>
+              <a:t>August 2026</a:t>
             </a:r>
             <a:endParaRPr lang="en-US" sz="1200" dirty="0"/>
           </a:p>
@@ -7712,57 +9084,18 @@
       </p:sp>
       <p:sp>
         <p:nvSpPr>
-          <p:cNvPr id="28" name="Text 25"/>
-          <p:cNvSpPr txBox="1"/>
-          <p:nvPr/>
-        </p:nvSpPr>
-        <p:spPr>
-          <a:xfrm>
-            <a:off x="5260726" y="3218688"/>
-            <a:ext cx="1670243" cy="731520"/>
-          </a:xfrm>
-          <a:prstGeom prst="rect">
-            <a:avLst/>
-          </a:prstGeom>
-          <a:noFill/>
-          <a:ln/>
-        </p:spPr>
-        <p:txBody>
-          <a:bodyPr wrap="square" lIns="0" tIns="0" rIns="0" bIns="0" rtlCol="0" anchor="t"/>
-          <a:lstStyle/>
-          <a:p>
-            <a:pPr indent="0" marL="0">
-              <a:buNone/>
-            </a:pPr>
-            <a:r>
-              <a:rPr lang="en-US" sz="950" dirty="0">
-                <a:solidFill>
-                  <a:srgbClr val="6A6A6A"/>
-                </a:solidFill>
-                <a:latin typeface="Helvetica" pitchFamily="34" charset="0"/>
-                <a:ea typeface="Helvetica" pitchFamily="34" charset="-122"/>
-                <a:cs typeface="Helvetica" pitchFamily="34" charset="-120"/>
-              </a:rPr>
-              <a:t>26-0007.01 · Audio, Backline, Zusätze</a:t>
-            </a:r>
-            <a:endParaRPr lang="en-US" sz="950" dirty="0"/>
-          </a:p>
-        </p:txBody>
-      </p:sp>
-      <p:sp>
-        <p:nvSpPr>
-          <p:cNvPr id="29" name="Shape 26"/>
+          <p:cNvPr id="45" name="Shape 42"/>
           <p:cNvSpPr/>
           <p:nvPr/>
         </p:nvSpPr>
         <p:spPr>
           <a:xfrm>
-            <a:off x="5096134" y="4206240"/>
-            <a:ext cx="1999427" cy="1371600"/>
+            <a:off x="7296729" y="2468880"/>
+            <a:ext cx="2036003" cy="886968"/>
           </a:xfrm>
           <a:prstGeom prst="roundRect">
             <a:avLst>
-              <a:gd name="adj" fmla="val 8000"/>
+              <a:gd name="adj" fmla="val 12371"/>
             </a:avLst>
           </a:prstGeom>
           <a:solidFill>
@@ -7785,14 +9118,53 @@
       </p:sp>
       <p:sp>
         <p:nvSpPr>
-          <p:cNvPr id="30" name="Text 27"/>
-          <p:cNvSpPr txBox="1"/>
-          <p:nvPr/>
-        </p:nvSpPr>
-        <p:spPr>
-          <a:xfrm>
-            <a:off x="5260726" y="4343400"/>
-            <a:ext cx="1670243" cy="411480"/>
+          <p:cNvPr id="46" name="Text 43"/>
+          <p:cNvSpPr txBox="1"/>
+          <p:nvPr/>
+        </p:nvSpPr>
+        <p:spPr>
+          <a:xfrm>
+            <a:off x="7461321" y="2633472"/>
+            <a:ext cx="1706819" cy="228600"/>
+          </a:xfrm>
+          <a:prstGeom prst="rect">
+            <a:avLst/>
+          </a:prstGeom>
+          <a:noFill/>
+          <a:ln/>
+        </p:spPr>
+        <p:txBody>
+          <a:bodyPr wrap="square" lIns="0" tIns="0" rIns="0" bIns="0" rtlCol="0" anchor="ctr"/>
+          <a:lstStyle/>
+          <a:p>
+            <a:pPr indent="0" marL="0">
+              <a:buNone/>
+            </a:pPr>
+            <a:r>
+              <a:rPr lang="en-US" sz="900" b="1" spc="100" kern="0" dirty="0">
+                <a:solidFill>
+                  <a:srgbClr val="A8884F"/>
+                </a:solidFill>
+                <a:latin typeface="Helvetica" pitchFamily="34" charset="0"/>
+                <a:ea typeface="Helvetica" pitchFamily="34" charset="-122"/>
+                <a:cs typeface="Helvetica" pitchFamily="34" charset="-120"/>
+              </a:rPr>
+              <a:t>26-0014</a:t>
+            </a:r>
+            <a:endParaRPr lang="en-US" sz="900" dirty="0"/>
+          </a:p>
+        </p:txBody>
+      </p:sp>
+      <p:sp>
+        <p:nvSpPr>
+          <p:cNvPr id="47" name="Text 44"/>
+          <p:cNvSpPr txBox="1"/>
+          <p:nvPr/>
+        </p:nvSpPr>
+        <p:spPr>
+          <a:xfrm>
+            <a:off x="7461321" y="2852928"/>
+            <a:ext cx="1706819" cy="384048"/>
           </a:xfrm>
           <a:prstGeom prst="rect">
             <a:avLst/>
@@ -7808,6 +9180,70 @@
               <a:buNone/>
             </a:pPr>
             <a:r>
+              <a:rPr lang="en-US" sz="1100" b="1" dirty="0">
+                <a:solidFill>
+                  <a:srgbClr val="3D3D3D"/>
+                </a:solidFill>
+                <a:latin typeface="Helvetica" pitchFamily="34" charset="0"/>
+                <a:ea typeface="Helvetica" pitchFamily="34" charset="-122"/>
+                <a:cs typeface="Helvetica" pitchFamily="34" charset="-120"/>
+              </a:rPr>
+              <a:t>Shutdown Festival</a:t>
+            </a:r>
+            <a:endParaRPr lang="en-US" sz="1100" dirty="0"/>
+          </a:p>
+        </p:txBody>
+      </p:sp>
+      <p:sp>
+        <p:nvSpPr>
+          <p:cNvPr id="48" name="Shape 45"/>
+          <p:cNvSpPr/>
+          <p:nvPr/>
+        </p:nvSpPr>
+        <p:spPr>
+          <a:xfrm>
+            <a:off x="10451318" y="2066544"/>
+            <a:ext cx="164592" cy="164592"/>
+          </a:xfrm>
+          <a:prstGeom prst="ellipse">
+            <a:avLst/>
+          </a:prstGeom>
+          <a:solidFill>
+            <a:srgbClr val="A8884F"/>
+          </a:solidFill>
+          <a:ln w="12700">
+            <a:solidFill>
+              <a:srgbClr val="A8884F"/>
+            </a:solidFill>
+            <a:prstDash val="solid"/>
+          </a:ln>
+        </p:spPr>
+      </p:sp>
+      <p:sp>
+        <p:nvSpPr>
+          <p:cNvPr id="49" name="Text 46"/>
+          <p:cNvSpPr txBox="1"/>
+          <p:nvPr/>
+        </p:nvSpPr>
+        <p:spPr>
+          <a:xfrm>
+            <a:off x="9424172" y="1645920"/>
+            <a:ext cx="2218883" cy="320040"/>
+          </a:xfrm>
+          <a:prstGeom prst="rect">
+            <a:avLst/>
+          </a:prstGeom>
+          <a:noFill/>
+          <a:ln/>
+        </p:spPr>
+        <p:txBody>
+          <a:bodyPr wrap="square" lIns="0" tIns="0" rIns="0" bIns="0" rtlCol="0" anchor="ctr"/>
+          <a:lstStyle/>
+          <a:p>
+            <a:pPr algn="ctr" indent="0" marL="0">
+              <a:buNone/>
+            </a:pPr>
+            <a:r>
               <a:rPr lang="en-US" sz="1200" b="1" dirty="0">
                 <a:solidFill>
                   <a:srgbClr val="3D3D3D"/>
@@ -7816,7 +9252,7 @@
                 <a:ea typeface="Helvetica" pitchFamily="34" charset="-122"/>
                 <a:cs typeface="Helvetica" pitchFamily="34" charset="-120"/>
               </a:rPr>
-              <a:t>80er Live Schalke</a:t>
+              <a:t>September 2026</a:t>
             </a:r>
             <a:endParaRPr lang="en-US" sz="1200" dirty="0"/>
           </a:p>
@@ -7824,57 +9260,18 @@
       </p:sp>
       <p:sp>
         <p:nvSpPr>
-          <p:cNvPr id="31" name="Text 28"/>
-          <p:cNvSpPr txBox="1"/>
-          <p:nvPr/>
-        </p:nvSpPr>
-        <p:spPr>
-          <a:xfrm>
-            <a:off x="5260726" y="4773168"/>
-            <a:ext cx="1670243" cy="731520"/>
-          </a:xfrm>
-          <a:prstGeom prst="rect">
-            <a:avLst/>
-          </a:prstGeom>
-          <a:noFill/>
-          <a:ln/>
-        </p:spPr>
-        <p:txBody>
-          <a:bodyPr wrap="square" lIns="0" tIns="0" rIns="0" bIns="0" rtlCol="0" anchor="t"/>
-          <a:lstStyle/>
-          <a:p>
-            <a:pPr indent="0" marL="0">
-              <a:buNone/>
-            </a:pPr>
-            <a:r>
-              <a:rPr lang="en-US" sz="950" dirty="0">
-                <a:solidFill>
-                  <a:srgbClr val="6A6A6A"/>
-                </a:solidFill>
-                <a:latin typeface="Helvetica" pitchFamily="34" charset="0"/>
-                <a:ea typeface="Helvetica" pitchFamily="34" charset="-122"/>
-                <a:cs typeface="Helvetica" pitchFamily="34" charset="-120"/>
-              </a:rPr>
-              <a:t>26-0007 · Backline Zusätze</a:t>
-            </a:r>
-            <a:endParaRPr lang="en-US" sz="950" dirty="0"/>
-          </a:p>
-        </p:txBody>
-      </p:sp>
-      <p:sp>
-        <p:nvSpPr>
-          <p:cNvPr id="32" name="Shape 29"/>
+          <p:cNvPr id="50" name="Shape 47"/>
           <p:cNvSpPr/>
           <p:nvPr/>
         </p:nvSpPr>
         <p:spPr>
           <a:xfrm>
-            <a:off x="7315017" y="2651760"/>
-            <a:ext cx="1999427" cy="1371600"/>
+            <a:off x="9515612" y="2468880"/>
+            <a:ext cx="2036003" cy="3520440"/>
           </a:xfrm>
           <a:prstGeom prst="roundRect">
             <a:avLst>
-              <a:gd name="adj" fmla="val 8000"/>
+              <a:gd name="adj" fmla="val 5389"/>
             </a:avLst>
           </a:prstGeom>
           <a:solidFill>
@@ -7897,14 +9294,53 @@
       </p:sp>
       <p:sp>
         <p:nvSpPr>
-          <p:cNvPr id="33" name="Text 30"/>
-          <p:cNvSpPr txBox="1"/>
-          <p:nvPr/>
-        </p:nvSpPr>
-        <p:spPr>
-          <a:xfrm>
-            <a:off x="7479609" y="2788920"/>
-            <a:ext cx="1670243" cy="411480"/>
+          <p:cNvPr id="51" name="Text 48"/>
+          <p:cNvSpPr txBox="1"/>
+          <p:nvPr/>
+        </p:nvSpPr>
+        <p:spPr>
+          <a:xfrm>
+            <a:off x="9680204" y="2633472"/>
+            <a:ext cx="1706819" cy="228600"/>
+          </a:xfrm>
+          <a:prstGeom prst="rect">
+            <a:avLst/>
+          </a:prstGeom>
+          <a:noFill/>
+          <a:ln/>
+        </p:spPr>
+        <p:txBody>
+          <a:bodyPr wrap="square" lIns="0" tIns="0" rIns="0" bIns="0" rtlCol="0" anchor="ctr"/>
+          <a:lstStyle/>
+          <a:p>
+            <a:pPr indent="0" marL="0">
+              <a:buNone/>
+            </a:pPr>
+            <a:r>
+              <a:rPr lang="en-US" sz="900" b="1" spc="100" kern="0" dirty="0">
+                <a:solidFill>
+                  <a:srgbClr val="A8884F"/>
+                </a:solidFill>
+                <a:latin typeface="Helvetica" pitchFamily="34" charset="0"/>
+                <a:ea typeface="Helvetica" pitchFamily="34" charset="-122"/>
+                <a:cs typeface="Helvetica" pitchFamily="34" charset="-120"/>
+              </a:rPr>
+              <a:t>26-0005</a:t>
+            </a:r>
+            <a:endParaRPr lang="en-US" sz="900" dirty="0"/>
+          </a:p>
+        </p:txBody>
+      </p:sp>
+      <p:sp>
+        <p:nvSpPr>
+          <p:cNvPr id="52" name="Text 49"/>
+          <p:cNvSpPr txBox="1"/>
+          <p:nvPr/>
+        </p:nvSpPr>
+        <p:spPr>
+          <a:xfrm>
+            <a:off x="9680204" y="2852928"/>
+            <a:ext cx="1706819" cy="384048"/>
           </a:xfrm>
           <a:prstGeom prst="rect">
             <a:avLst/>
@@ -7920,7 +9356,7 @@
               <a:buNone/>
             </a:pPr>
             <a:r>
-              <a:rPr lang="en-US" sz="1200" b="1" dirty="0">
+              <a:rPr lang="en-US" sz="1100" b="1" dirty="0">
                 <a:solidFill>
                   <a:srgbClr val="3D3D3D"/>
                 </a:solidFill>
@@ -7928,22 +9364,61 @@
                 <a:ea typeface="Helvetica" pitchFamily="34" charset="-122"/>
                 <a:cs typeface="Helvetica" pitchFamily="34" charset="-120"/>
               </a:rPr>
-              <a:t>80er Live Frankfurt</a:t>
-            </a:r>
-            <a:endParaRPr lang="en-US" sz="1200" dirty="0"/>
-          </a:p>
-        </p:txBody>
-      </p:sp>
-      <p:sp>
-        <p:nvSpPr>
-          <p:cNvPr id="34" name="Text 31"/>
-          <p:cNvSpPr txBox="1"/>
-          <p:nvPr/>
-        </p:nvSpPr>
-        <p:spPr>
-          <a:xfrm>
-            <a:off x="7479609" y="3218688"/>
-            <a:ext cx="1670243" cy="731520"/>
+              <a:t>Sven Väth Bayreuth</a:t>
+            </a:r>
+            <a:endParaRPr lang="en-US" sz="1100" dirty="0"/>
+          </a:p>
+        </p:txBody>
+      </p:sp>
+      <p:sp>
+        <p:nvSpPr>
+          <p:cNvPr id="53" name="Text 50"/>
+          <p:cNvSpPr txBox="1"/>
+          <p:nvPr/>
+        </p:nvSpPr>
+        <p:spPr>
+          <a:xfrm>
+            <a:off x="9680204" y="3291840"/>
+            <a:ext cx="1706819" cy="228600"/>
+          </a:xfrm>
+          <a:prstGeom prst="rect">
+            <a:avLst/>
+          </a:prstGeom>
+          <a:noFill/>
+          <a:ln/>
+        </p:spPr>
+        <p:txBody>
+          <a:bodyPr wrap="square" lIns="0" tIns="0" rIns="0" bIns="0" rtlCol="0" anchor="ctr"/>
+          <a:lstStyle/>
+          <a:p>
+            <a:pPr indent="0" marL="0">
+              <a:buNone/>
+            </a:pPr>
+            <a:r>
+              <a:rPr lang="en-US" sz="900" b="1" spc="100" kern="0" dirty="0">
+                <a:solidFill>
+                  <a:srgbClr val="A8884F"/>
+                </a:solidFill>
+                <a:latin typeface="Helvetica" pitchFamily="34" charset="0"/>
+                <a:ea typeface="Helvetica" pitchFamily="34" charset="-122"/>
+                <a:cs typeface="Helvetica" pitchFamily="34" charset="-120"/>
+              </a:rPr>
+              <a:t>26-0032</a:t>
+            </a:r>
+            <a:endParaRPr lang="en-US" sz="900" dirty="0"/>
+          </a:p>
+        </p:txBody>
+      </p:sp>
+      <p:sp>
+        <p:nvSpPr>
+          <p:cNvPr id="54" name="Text 51"/>
+          <p:cNvSpPr txBox="1"/>
+          <p:nvPr/>
+        </p:nvSpPr>
+        <p:spPr>
+          <a:xfrm>
+            <a:off x="9680204" y="3511296"/>
+            <a:ext cx="1706819" cy="384048"/>
           </a:xfrm>
           <a:prstGeom prst="rect">
             <a:avLst/>
@@ -7959,64 +9434,69 @@
               <a:buNone/>
             </a:pPr>
             <a:r>
-              <a:rPr lang="en-US" sz="950" dirty="0">
-                <a:solidFill>
-                  <a:srgbClr val="6A6A6A"/>
-                </a:solidFill>
-                <a:latin typeface="Helvetica" pitchFamily="34" charset="0"/>
-                <a:ea typeface="Helvetica" pitchFamily="34" charset="-122"/>
-                <a:cs typeface="Helvetica" pitchFamily="34" charset="-120"/>
-              </a:rPr>
-              <a:t>26-0007.03 · Abschlussrechnung 26.08.</a:t>
-            </a:r>
-            <a:endParaRPr lang="en-US" sz="950" dirty="0"/>
-          </a:p>
-        </p:txBody>
-      </p:sp>
-      <p:sp>
-        <p:nvSpPr>
-          <p:cNvPr id="35" name="Shape 32"/>
-          <p:cNvSpPr/>
-          <p:nvPr/>
-        </p:nvSpPr>
-        <p:spPr>
-          <a:xfrm>
-            <a:off x="7315017" y="4206240"/>
-            <a:ext cx="1999427" cy="1371600"/>
-          </a:xfrm>
-          <a:prstGeom prst="roundRect">
-            <a:avLst>
-              <a:gd name="adj" fmla="val 8000"/>
-            </a:avLst>
-          </a:prstGeom>
-          <a:solidFill>
-            <a:srgbClr val="FFFFFF"/>
-          </a:solidFill>
-          <a:ln w="9525">
-            <a:solidFill>
-              <a:srgbClr val="E4E1DB"/>
-            </a:solidFill>
-            <a:prstDash val="solid"/>
-          </a:ln>
-          <a:effectLst>
-            <a:outerShdw sx="100000" sy="100000" kx="0" ky="0" algn="bl" rotWithShape="0" blurRad="76200" dist="25400" dir="5400000">
-              <a:srgbClr val="000000">
-                <a:alpha val="6000"/>
-              </a:srgbClr>
-            </a:outerShdw>
-          </a:effectLst>
-        </p:spPr>
-      </p:sp>
-      <p:sp>
-        <p:nvSpPr>
-          <p:cNvPr id="36" name="Text 33"/>
-          <p:cNvSpPr txBox="1"/>
-          <p:nvPr/>
-        </p:nvSpPr>
-        <p:spPr>
-          <a:xfrm>
-            <a:off x="7479609" y="4343400"/>
-            <a:ext cx="1670243" cy="411480"/>
+              <a:rPr lang="en-US" sz="1100" b="1" dirty="0">
+                <a:solidFill>
+                  <a:srgbClr val="3D3D3D"/>
+                </a:solidFill>
+                <a:latin typeface="Helvetica" pitchFamily="34" charset="0"/>
+                <a:ea typeface="Helvetica" pitchFamily="34" charset="-122"/>
+                <a:cs typeface="Helvetica" pitchFamily="34" charset="-120"/>
+              </a:rPr>
+              <a:t>Glücksgefühle</a:t>
+            </a:r>
+            <a:endParaRPr lang="en-US" sz="1100" dirty="0"/>
+          </a:p>
+        </p:txBody>
+      </p:sp>
+      <p:sp>
+        <p:nvSpPr>
+          <p:cNvPr id="55" name="Text 52"/>
+          <p:cNvSpPr txBox="1"/>
+          <p:nvPr/>
+        </p:nvSpPr>
+        <p:spPr>
+          <a:xfrm>
+            <a:off x="9680204" y="3950208"/>
+            <a:ext cx="1706819" cy="228600"/>
+          </a:xfrm>
+          <a:prstGeom prst="rect">
+            <a:avLst/>
+          </a:prstGeom>
+          <a:noFill/>
+          <a:ln/>
+        </p:spPr>
+        <p:txBody>
+          <a:bodyPr wrap="square" lIns="0" tIns="0" rIns="0" bIns="0" rtlCol="0" anchor="ctr"/>
+          <a:lstStyle/>
+          <a:p>
+            <a:pPr indent="0" marL="0">
+              <a:buNone/>
+            </a:pPr>
+            <a:r>
+              <a:rPr lang="en-US" sz="900" b="1" spc="100" kern="0" dirty="0">
+                <a:solidFill>
+                  <a:srgbClr val="A8884F"/>
+                </a:solidFill>
+                <a:latin typeface="Helvetica" pitchFamily="34" charset="0"/>
+                <a:ea typeface="Helvetica" pitchFamily="34" charset="-122"/>
+                <a:cs typeface="Helvetica" pitchFamily="34" charset="-120"/>
+              </a:rPr>
+              <a:t>26-0037</a:t>
+            </a:r>
+            <a:endParaRPr lang="en-US" sz="900" dirty="0"/>
+          </a:p>
+        </p:txBody>
+      </p:sp>
+      <p:sp>
+        <p:nvSpPr>
+          <p:cNvPr id="56" name="Text 53"/>
+          <p:cNvSpPr txBox="1"/>
+          <p:nvPr/>
+        </p:nvSpPr>
+        <p:spPr>
+          <a:xfrm>
+            <a:off x="9680204" y="4169664"/>
+            <a:ext cx="1706819" cy="384048"/>
           </a:xfrm>
           <a:prstGeom prst="rect">
             <a:avLst/>
@@ -8032,7 +9512,7 @@
               <a:buNone/>
             </a:pPr>
             <a:r>
-              <a:rPr lang="en-US" sz="1200" b="1" dirty="0">
+              <a:rPr lang="en-US" sz="1100" b="1" dirty="0">
                 <a:solidFill>
                   <a:srgbClr val="3D3D3D"/>
                 </a:solidFill>
@@ -8040,22 +9520,61 @@
                 <a:ea typeface="Helvetica" pitchFamily="34" charset="-122"/>
                 <a:cs typeface="Helvetica" pitchFamily="34" charset="-120"/>
               </a:rPr>
-              <a:t>Weitere Projekte</a:t>
-            </a:r>
-            <a:endParaRPr lang="en-US" sz="1200" dirty="0"/>
-          </a:p>
-        </p:txBody>
-      </p:sp>
-      <p:sp>
-        <p:nvSpPr>
-          <p:cNvPr id="37" name="Text 34"/>
-          <p:cNvSpPr txBox="1"/>
-          <p:nvPr/>
-        </p:nvSpPr>
-        <p:spPr>
-          <a:xfrm>
-            <a:off x="7479609" y="4773168"/>
-            <a:ext cx="1670243" cy="731520"/>
+              <a:t>Red Bull @ GG · Energy Station</a:t>
+            </a:r>
+            <a:endParaRPr lang="en-US" sz="1100" dirty="0"/>
+          </a:p>
+        </p:txBody>
+      </p:sp>
+      <p:sp>
+        <p:nvSpPr>
+          <p:cNvPr id="57" name="Text 54"/>
+          <p:cNvSpPr txBox="1"/>
+          <p:nvPr/>
+        </p:nvSpPr>
+        <p:spPr>
+          <a:xfrm>
+            <a:off x="9680204" y="4608576"/>
+            <a:ext cx="1706819" cy="228600"/>
+          </a:xfrm>
+          <a:prstGeom prst="rect">
+            <a:avLst/>
+          </a:prstGeom>
+          <a:noFill/>
+          <a:ln/>
+        </p:spPr>
+        <p:txBody>
+          <a:bodyPr wrap="square" lIns="0" tIns="0" rIns="0" bIns="0" rtlCol="0" anchor="ctr"/>
+          <a:lstStyle/>
+          <a:p>
+            <a:pPr indent="0" marL="0">
+              <a:buNone/>
+            </a:pPr>
+            <a:r>
+              <a:rPr lang="en-US" sz="900" b="1" spc="100" kern="0" dirty="0">
+                <a:solidFill>
+                  <a:srgbClr val="A8884F"/>
+                </a:solidFill>
+                <a:latin typeface="Helvetica" pitchFamily="34" charset="0"/>
+                <a:ea typeface="Helvetica" pitchFamily="34" charset="-122"/>
+                <a:cs typeface="Helvetica" pitchFamily="34" charset="-120"/>
+              </a:rPr>
+              <a:t>26-0043</a:t>
+            </a:r>
+            <a:endParaRPr lang="en-US" sz="900" dirty="0"/>
+          </a:p>
+        </p:txBody>
+      </p:sp>
+      <p:sp>
+        <p:nvSpPr>
+          <p:cNvPr id="58" name="Text 55"/>
+          <p:cNvSpPr txBox="1"/>
+          <p:nvPr/>
+        </p:nvSpPr>
+        <p:spPr>
+          <a:xfrm>
+            <a:off x="9680204" y="4828032"/>
+            <a:ext cx="1706819" cy="384048"/>
           </a:xfrm>
           <a:prstGeom prst="rect">
             <a:avLst/>
@@ -8071,64 +9590,69 @@
               <a:buNone/>
             </a:pPr>
             <a:r>
-              <a:rPr lang="en-US" sz="950" dirty="0">
-                <a:solidFill>
-                  <a:srgbClr val="6A6A6A"/>
-                </a:solidFill>
-                <a:latin typeface="Helvetica" pitchFamily="34" charset="0"/>
-                <a:ea typeface="Helvetica" pitchFamily="34" charset="-122"/>
-                <a:cs typeface="Helvetica" pitchFamily="34" charset="-120"/>
-              </a:rPr>
-              <a:t>SWR NPF 2026 · Ina Müller &amp; Band · Red Bull Energy Station</a:t>
-            </a:r>
-            <a:endParaRPr lang="en-US" sz="950" dirty="0"/>
-          </a:p>
-        </p:txBody>
-      </p:sp>
-      <p:sp>
-        <p:nvSpPr>
-          <p:cNvPr id="38" name="Shape 35"/>
-          <p:cNvSpPr/>
-          <p:nvPr/>
-        </p:nvSpPr>
-        <p:spPr>
-          <a:xfrm>
-            <a:off x="9533900" y="2651760"/>
-            <a:ext cx="1999427" cy="1371600"/>
-          </a:xfrm>
-          <a:prstGeom prst="roundRect">
-            <a:avLst>
-              <a:gd name="adj" fmla="val 8000"/>
-            </a:avLst>
-          </a:prstGeom>
-          <a:solidFill>
-            <a:srgbClr val="FFFFFF"/>
-          </a:solidFill>
-          <a:ln w="9525">
-            <a:solidFill>
-              <a:srgbClr val="E4E1DB"/>
-            </a:solidFill>
-            <a:prstDash val="solid"/>
-          </a:ln>
-          <a:effectLst>
-            <a:outerShdw sx="100000" sy="100000" kx="0" ky="0" algn="bl" rotWithShape="0" blurRad="76200" dist="25400" dir="5400000">
-              <a:srgbClr val="000000">
-                <a:alpha val="6000"/>
-              </a:srgbClr>
-            </a:outerShdw>
-          </a:effectLst>
-        </p:spPr>
-      </p:sp>
-      <p:sp>
-        <p:nvSpPr>
-          <p:cNvPr id="39" name="Text 36"/>
-          <p:cNvSpPr txBox="1"/>
-          <p:nvPr/>
-        </p:nvSpPr>
-        <p:spPr>
-          <a:xfrm>
-            <a:off x="9698492" y="2788920"/>
-            <a:ext cx="1670243" cy="411480"/>
+              <a:rPr lang="en-US" sz="1100" b="1" dirty="0">
+                <a:solidFill>
+                  <a:srgbClr val="3D3D3D"/>
+                </a:solidFill>
+                <a:latin typeface="Helvetica" pitchFamily="34" charset="0"/>
+                <a:ea typeface="Helvetica" pitchFamily="34" charset="-122"/>
+                <a:cs typeface="Helvetica" pitchFamily="34" charset="-120"/>
+              </a:rPr>
+              <a:t>Laser Mainz–Berlin</a:t>
+            </a:r>
+            <a:endParaRPr lang="en-US" sz="1100" dirty="0"/>
+          </a:p>
+        </p:txBody>
+      </p:sp>
+      <p:sp>
+        <p:nvSpPr>
+          <p:cNvPr id="59" name="Text 56"/>
+          <p:cNvSpPr txBox="1"/>
+          <p:nvPr/>
+        </p:nvSpPr>
+        <p:spPr>
+          <a:xfrm>
+            <a:off x="9680204" y="5266944"/>
+            <a:ext cx="1706819" cy="228600"/>
+          </a:xfrm>
+          <a:prstGeom prst="rect">
+            <a:avLst/>
+          </a:prstGeom>
+          <a:noFill/>
+          <a:ln/>
+        </p:spPr>
+        <p:txBody>
+          <a:bodyPr wrap="square" lIns="0" tIns="0" rIns="0" bIns="0" rtlCol="0" anchor="ctr"/>
+          <a:lstStyle/>
+          <a:p>
+            <a:pPr indent="0" marL="0">
+              <a:buNone/>
+            </a:pPr>
+            <a:r>
+              <a:rPr lang="en-US" sz="900" b="1" spc="100" kern="0" dirty="0">
+                <a:solidFill>
+                  <a:srgbClr val="A8884F"/>
+                </a:solidFill>
+                <a:latin typeface="Helvetica" pitchFamily="34" charset="0"/>
+                <a:ea typeface="Helvetica" pitchFamily="34" charset="-122"/>
+                <a:cs typeface="Helvetica" pitchFamily="34" charset="-120"/>
+              </a:rPr>
+              <a:t>26-0047</a:t>
+            </a:r>
+            <a:endParaRPr lang="en-US" sz="900" dirty="0"/>
+          </a:p>
+        </p:txBody>
+      </p:sp>
+      <p:sp>
+        <p:nvSpPr>
+          <p:cNvPr id="60" name="Text 57"/>
+          <p:cNvSpPr txBox="1"/>
+          <p:nvPr/>
+        </p:nvSpPr>
+        <p:spPr>
+          <a:xfrm>
+            <a:off x="9680204" y="5486400"/>
+            <a:ext cx="1706819" cy="384048"/>
           </a:xfrm>
           <a:prstGeom prst="rect">
             <a:avLst/>
@@ -8144,7 +9668,7 @@
               <a:buNone/>
             </a:pPr>
             <a:r>
-              <a:rPr lang="en-US" sz="1200" b="1" dirty="0">
+              <a:rPr lang="en-US" sz="1100" b="1" dirty="0">
                 <a:solidFill>
                   <a:srgbClr val="3D3D3D"/>
                 </a:solidFill>
@@ -8152,177 +9676,9 @@
                 <a:ea typeface="Helvetica" pitchFamily="34" charset="-122"/>
                 <a:cs typeface="Helvetica" pitchFamily="34" charset="-120"/>
               </a:rPr>
-              <a:t>Nova Works App</a:t>
-            </a:r>
-            <a:endParaRPr lang="en-US" sz="1200" dirty="0"/>
-          </a:p>
-        </p:txBody>
-      </p:sp>
-      <p:sp>
-        <p:nvSpPr>
-          <p:cNvPr id="40" name="Text 37"/>
-          <p:cNvSpPr txBox="1"/>
-          <p:nvPr/>
-        </p:nvSpPr>
-        <p:spPr>
-          <a:xfrm>
-            <a:off x="9698492" y="3218688"/>
-            <a:ext cx="1670243" cy="731520"/>
-          </a:xfrm>
-          <a:prstGeom prst="rect">
-            <a:avLst/>
-          </a:prstGeom>
-          <a:noFill/>
-          <a:ln/>
-        </p:spPr>
-        <p:txBody>
-          <a:bodyPr wrap="square" lIns="0" tIns="0" rIns="0" bIns="0" rtlCol="0" anchor="t"/>
-          <a:lstStyle/>
-          <a:p>
-            <a:pPr indent="0" marL="0">
-              <a:buNone/>
-            </a:pPr>
-            <a:r>
-              <a:rPr lang="en-US" sz="950" dirty="0">
-                <a:solidFill>
-                  <a:srgbClr val="6A6A6A"/>
-                </a:solidFill>
-                <a:latin typeface="Helvetica" pitchFamily="34" charset="0"/>
-                <a:ea typeface="Helvetica" pitchFamily="34" charset="-122"/>
-                <a:cs typeface="Helvetica" pitchFamily="34" charset="-120"/>
-              </a:rPr>
-              <a:t>Forecast, Deal-Auswertung, Kalkulations-Assistent, Messen</a:t>
-            </a:r>
-            <a:endParaRPr lang="en-US" sz="950" dirty="0"/>
-          </a:p>
-        </p:txBody>
-      </p:sp>
-      <p:sp>
-        <p:nvSpPr>
-          <p:cNvPr id="41" name="Shape 38"/>
-          <p:cNvSpPr/>
-          <p:nvPr/>
-        </p:nvSpPr>
-        <p:spPr>
-          <a:xfrm>
-            <a:off x="9533900" y="4206240"/>
-            <a:ext cx="1999427" cy="1371600"/>
-          </a:xfrm>
-          <a:prstGeom prst="roundRect">
-            <a:avLst>
-              <a:gd name="adj" fmla="val 8000"/>
-            </a:avLst>
-          </a:prstGeom>
-          <a:solidFill>
-            <a:srgbClr val="FFFFFF"/>
-          </a:solidFill>
-          <a:ln w="9525">
-            <a:solidFill>
-              <a:srgbClr val="E4E1DB"/>
-            </a:solidFill>
-            <a:prstDash val="solid"/>
-          </a:ln>
-          <a:effectLst>
-            <a:outerShdw sx="100000" sy="100000" kx="0" ky="0" algn="bl" rotWithShape="0" blurRad="76200" dist="25400" dir="5400000">
-              <a:srgbClr val="000000">
-                <a:alpha val="6000"/>
-              </a:srgbClr>
-            </a:outerShdw>
-          </a:effectLst>
-        </p:spPr>
-      </p:sp>
-      <p:sp>
-        <p:nvSpPr>
-          <p:cNvPr id="42" name="Text 39"/>
-          <p:cNvSpPr txBox="1"/>
-          <p:nvPr/>
-        </p:nvSpPr>
-        <p:spPr>
-          <a:xfrm>
-            <a:off x="9698492" y="4343400"/>
-            <a:ext cx="1670243" cy="411480"/>
-          </a:xfrm>
-          <a:prstGeom prst="rect">
-            <a:avLst/>
-          </a:prstGeom>
-          <a:noFill/>
-          <a:ln/>
-        </p:spPr>
-        <p:txBody>
-          <a:bodyPr wrap="square" lIns="0" tIns="0" rIns="0" bIns="0" rtlCol="0" anchor="t"/>
-          <a:lstStyle/>
-          <a:p>
-            <a:pPr indent="0" marL="0">
-              <a:buNone/>
-            </a:pPr>
-            <a:r>
-              <a:rPr lang="en-US" sz="1200" b="1" dirty="0">
-                <a:solidFill>
-                  <a:srgbClr val="3D3D3D"/>
-                </a:solidFill>
-                <a:latin typeface="Helvetica" pitchFamily="34" charset="0"/>
-                <a:ea typeface="Helvetica" pitchFamily="34" charset="-122"/>
-                <a:cs typeface="Helvetica" pitchFamily="34" charset="-120"/>
-              </a:rPr>
-              <a:t>Gesellschafter-</a:t>
-            </a:r>
-            <a:endParaRPr lang="en-US" sz="1200" dirty="0"/>
-          </a:p>
-          <a:p>
-            <a:pPr indent="0" marL="0">
-              <a:buNone/>
-            </a:pPr>
-            <a:r>
-              <a:rPr lang="en-US" sz="1200" b="1" dirty="0">
-                <a:solidFill>
-                  <a:srgbClr val="3D3D3D"/>
-                </a:solidFill>
-                <a:latin typeface="Helvetica" pitchFamily="34" charset="0"/>
-                <a:ea typeface="Helvetica" pitchFamily="34" charset="-122"/>
-                <a:cs typeface="Helvetica" pitchFamily="34" charset="-120"/>
-              </a:rPr>
-              <a:t>versammlung</a:t>
-            </a:r>
-            <a:endParaRPr lang="en-US" sz="1200" dirty="0"/>
-          </a:p>
-        </p:txBody>
-      </p:sp>
-      <p:sp>
-        <p:nvSpPr>
-          <p:cNvPr id="43" name="Text 40"/>
-          <p:cNvSpPr txBox="1"/>
-          <p:nvPr/>
-        </p:nvSpPr>
-        <p:spPr>
-          <a:xfrm>
-            <a:off x="9698492" y="4773168"/>
-            <a:ext cx="1670243" cy="731520"/>
-          </a:xfrm>
-          <a:prstGeom prst="rect">
-            <a:avLst/>
-          </a:prstGeom>
-          <a:noFill/>
-          <a:ln/>
-        </p:spPr>
-        <p:txBody>
-          <a:bodyPr wrap="square" lIns="0" tIns="0" rIns="0" bIns="0" rtlCol="0" anchor="t"/>
-          <a:lstStyle/>
-          <a:p>
-            <a:pPr indent="0" marL="0">
-              <a:buNone/>
-            </a:pPr>
-            <a:r>
-              <a:rPr lang="en-US" sz="950" dirty="0">
-                <a:solidFill>
-                  <a:srgbClr val="6A6A6A"/>
-                </a:solidFill>
-                <a:latin typeface="Helvetica" pitchFamily="34" charset="0"/>
-                <a:ea typeface="Helvetica" pitchFamily="34" charset="-122"/>
-                <a:cs typeface="Helvetica" pitchFamily="34" charset="-120"/>
-              </a:rPr>
-              <a:t>23.09. Denkendorf</a:t>
-            </a:r>
-            <a:endParaRPr lang="en-US" sz="950" dirty="0"/>
+              <a:t>FR Veranstaltungsleiter</a:t>
+            </a:r>
+            <a:endParaRPr lang="en-US" sz="1100" dirty="0"/>
           </a:p>
         </p:txBody>
       </p:sp>
@@ -8358,9 +9714,48 @@
           <a:chExt cx="0" cy="0"/>
         </a:xfrm>
       </p:grpSpPr>
+      <p:sp>
+        <p:nvSpPr>
+          <p:cNvPr id="2" name="Text 0"/>
+          <p:cNvSpPr txBox="1"/>
+          <p:nvPr/>
+        </p:nvSpPr>
+        <p:spPr>
+          <a:xfrm>
+            <a:off x="7802575" y="914400"/>
+            <a:ext cx="3840480" cy="256032"/>
+          </a:xfrm>
+          <a:prstGeom prst="rect">
+            <a:avLst/>
+          </a:prstGeom>
+          <a:noFill/>
+          <a:ln/>
+        </p:spPr>
+        <p:txBody>
+          <a:bodyPr wrap="square" lIns="0" tIns="0" rIns="0" bIns="0" rtlCol="0" anchor="ctr"/>
+          <a:lstStyle/>
+          <a:p>
+            <a:pPr algn="r" indent="0" marL="0">
+              <a:buNone/>
+            </a:pPr>
+            <a:r>
+              <a:rPr lang="en-US" sz="850" b="1" spc="200" kern="0" dirty="0">
+                <a:solidFill>
+                  <a:srgbClr val="A8884F"/>
+                </a:solidFill>
+                <a:latin typeface="Helvetica" pitchFamily="34" charset="0"/>
+                <a:ea typeface="Helvetica" pitchFamily="34" charset="-122"/>
+                <a:cs typeface="Helvetica" pitchFamily="34" charset="-120"/>
+              </a:rPr>
+              <a:t>TOP 2  ·  FOLIE 2 von 2</a:t>
+            </a:r>
+            <a:endParaRPr lang="en-US" sz="850" dirty="0"/>
+          </a:p>
+        </p:txBody>
+      </p:sp>
       <p:pic>
         <p:nvPicPr>
-          <p:cNvPr id="2" name="Image 0" descr="/home/user/nova-works-app/scripts/assets/nova-works-logo.png">    </p:cNvPr>
+          <p:cNvPr id="3" name="Image 0" descr="/home/user/nova-works-app/scripts/assets/nova-works-logo.png">    </p:cNvPr>
           <p:cNvPicPr>
             <a:picLocks noChangeAspect="1"/>
           </p:cNvPicPr>
@@ -8384,7 +9779,7 @@
       </p:pic>
       <p:sp>
         <p:nvSpPr>
-          <p:cNvPr id="3" name="Text 0"/>
+          <p:cNvPr id="4" name="Text 1"/>
           <p:cNvSpPr txBox="1"/>
           <p:nvPr/>
         </p:nvSpPr>
@@ -8423,7 +9818,7 @@
       </p:sp>
       <p:sp>
         <p:nvSpPr>
-          <p:cNvPr id="4" name="Text 1"/>
+          <p:cNvPr id="5" name="Text 2"/>
           <p:cNvSpPr txBox="1"/>
           <p:nvPr/>
         </p:nvSpPr>
@@ -8462,7 +9857,7 @@
       </p:sp>
       <p:sp>
         <p:nvSpPr>
-          <p:cNvPr id="5" name="Shape 2"/>
+          <p:cNvPr id="6" name="Shape 3"/>
           <p:cNvSpPr/>
           <p:nvPr/>
         </p:nvSpPr>
@@ -8487,7 +9882,7 @@
       </p:sp>
       <p:sp>
         <p:nvSpPr>
-          <p:cNvPr id="6" name="Text 3"/>
+          <p:cNvPr id="7" name="Text 4"/>
           <p:cNvSpPr txBox="1"/>
           <p:nvPr/>
         </p:nvSpPr>
@@ -8526,7 +9921,7 @@
       </p:sp>
       <p:sp>
         <p:nvSpPr>
-          <p:cNvPr id="7" name="Text 4"/>
+          <p:cNvPr id="8" name="Text 5"/>
           <p:cNvSpPr txBox="1"/>
           <p:nvPr/>
         </p:nvSpPr>
@@ -8565,7 +9960,7 @@
       </p:sp>
       <p:sp>
         <p:nvSpPr>
-          <p:cNvPr id="8" name="Text 5"/>
+          <p:cNvPr id="9" name="Text 6"/>
           <p:cNvSpPr txBox="1"/>
           <p:nvPr/>
         </p:nvSpPr>
@@ -8604,7 +9999,7 @@
       </p:sp>
       <p:sp>
         <p:nvSpPr>
-          <p:cNvPr id="9" name="Shape 6"/>
+          <p:cNvPr id="10" name="Shape 7"/>
           <p:cNvSpPr/>
           <p:nvPr/>
         </p:nvSpPr>
@@ -8638,7 +10033,7 @@
       </p:sp>
       <p:sp>
         <p:nvSpPr>
-          <p:cNvPr id="10" name="Shape 7"/>
+          <p:cNvPr id="11" name="Shape 8"/>
           <p:cNvSpPr/>
           <p:nvPr/>
         </p:nvSpPr>
@@ -8663,7 +10058,7 @@
       </p:sp>
       <p:sp>
         <p:nvSpPr>
-          <p:cNvPr id="11" name="Text 8"/>
+          <p:cNvPr id="12" name="Text 9"/>
           <p:cNvSpPr txBox="1"/>
           <p:nvPr/>
         </p:nvSpPr>
@@ -8702,7 +10097,7 @@
       </p:sp>
       <p:sp>
         <p:nvSpPr>
-          <p:cNvPr id="12" name="Text 9"/>
+          <p:cNvPr id="13" name="Text 10"/>
           <p:cNvSpPr txBox="1"/>
           <p:nvPr/>
         </p:nvSpPr>
@@ -8741,7 +10136,7 @@
       </p:sp>
       <p:sp>
         <p:nvSpPr>
-          <p:cNvPr id="13" name="Text 10"/>
+          <p:cNvPr id="14" name="Text 11"/>
           <p:cNvSpPr txBox="1"/>
           <p:nvPr/>
         </p:nvSpPr>
@@ -8868,7 +10263,7 @@
       </p:sp>
       <p:sp>
         <p:nvSpPr>
-          <p:cNvPr id="14" name="Shape 11"/>
+          <p:cNvPr id="15" name="Shape 12"/>
           <p:cNvSpPr/>
           <p:nvPr/>
         </p:nvSpPr>
@@ -8902,7 +10297,7 @@
       </p:sp>
       <p:sp>
         <p:nvSpPr>
-          <p:cNvPr id="15" name="Shape 12"/>
+          <p:cNvPr id="16" name="Shape 13"/>
           <p:cNvSpPr/>
           <p:nvPr/>
         </p:nvSpPr>
@@ -8927,7 +10322,7 @@
       </p:sp>
       <p:sp>
         <p:nvSpPr>
-          <p:cNvPr id="16" name="Text 13"/>
+          <p:cNvPr id="17" name="Text 14"/>
           <p:cNvSpPr txBox="1"/>
           <p:nvPr/>
         </p:nvSpPr>
@@ -8966,7 +10361,7 @@
       </p:sp>
       <p:sp>
         <p:nvSpPr>
-          <p:cNvPr id="17" name="Text 14"/>
+          <p:cNvPr id="18" name="Text 15"/>
           <p:cNvSpPr txBox="1"/>
           <p:nvPr/>
         </p:nvSpPr>
@@ -9005,7 +10400,7 @@
       </p:sp>
       <p:sp>
         <p:nvSpPr>
-          <p:cNvPr id="18" name="Text 15"/>
+          <p:cNvPr id="19" name="Text 16"/>
           <p:cNvSpPr txBox="1"/>
           <p:nvPr/>
         </p:nvSpPr>
@@ -9132,7 +10527,7 @@
       </p:sp>
       <p:sp>
         <p:nvSpPr>
-          <p:cNvPr id="19" name="Shape 16"/>
+          <p:cNvPr id="20" name="Shape 17"/>
           <p:cNvSpPr/>
           <p:nvPr/>
         </p:nvSpPr>
@@ -9166,7 +10561,7 @@
       </p:sp>
       <p:sp>
         <p:nvSpPr>
-          <p:cNvPr id="20" name="Shape 17"/>
+          <p:cNvPr id="21" name="Shape 18"/>
           <p:cNvSpPr/>
           <p:nvPr/>
         </p:nvSpPr>
@@ -9191,7 +10586,7 @@
       </p:sp>
       <p:sp>
         <p:nvSpPr>
-          <p:cNvPr id="21" name="Text 18"/>
+          <p:cNvPr id="22" name="Text 19"/>
           <p:cNvSpPr txBox="1"/>
           <p:nvPr/>
         </p:nvSpPr>
@@ -9230,7 +10625,7 @@
       </p:sp>
       <p:sp>
         <p:nvSpPr>
-          <p:cNvPr id="22" name="Text 19"/>
+          <p:cNvPr id="23" name="Text 20"/>
           <p:cNvSpPr txBox="1"/>
           <p:nvPr/>
         </p:nvSpPr>
@@ -9269,7 +10664,7 @@
       </p:sp>
       <p:sp>
         <p:nvSpPr>
-          <p:cNvPr id="23" name="Text 20"/>
+          <p:cNvPr id="24" name="Text 21"/>
           <p:cNvSpPr txBox="1"/>
           <p:nvPr/>
         </p:nvSpPr>
@@ -9426,9 +10821,48 @@
           <a:chExt cx="0" cy="0"/>
         </a:xfrm>
       </p:grpSpPr>
+      <p:sp>
+        <p:nvSpPr>
+          <p:cNvPr id="2" name="Text 0"/>
+          <p:cNvSpPr txBox="1"/>
+          <p:nvPr/>
+        </p:nvSpPr>
+        <p:spPr>
+          <a:xfrm>
+            <a:off x="7802575" y="914400"/>
+            <a:ext cx="3840480" cy="256032"/>
+          </a:xfrm>
+          <a:prstGeom prst="rect">
+            <a:avLst/>
+          </a:prstGeom>
+          <a:noFill/>
+          <a:ln/>
+        </p:spPr>
+        <p:txBody>
+          <a:bodyPr wrap="square" lIns="0" tIns="0" rIns="0" bIns="0" rtlCol="0" anchor="ctr"/>
+          <a:lstStyle/>
+          <a:p>
+            <a:pPr algn="r" indent="0" marL="0">
+              <a:buNone/>
+            </a:pPr>
+            <a:r>
+              <a:rPr lang="en-US" sz="850" b="1" spc="200" kern="0" dirty="0">
+                <a:solidFill>
+                  <a:srgbClr val="A8884F"/>
+                </a:solidFill>
+                <a:latin typeface="Helvetica" pitchFamily="34" charset="0"/>
+                <a:ea typeface="Helvetica" pitchFamily="34" charset="-122"/>
+                <a:cs typeface="Helvetica" pitchFamily="34" charset="-120"/>
+              </a:rPr>
+              <a:t>TOP 3  ·  FOLIE 1 von 2</a:t>
+            </a:r>
+            <a:endParaRPr lang="en-US" sz="850" dirty="0"/>
+          </a:p>
+        </p:txBody>
+      </p:sp>
       <p:pic>
         <p:nvPicPr>
-          <p:cNvPr id="2" name="Image 0" descr="/home/user/nova-works-app/scripts/assets/nova-works-logo.png">    </p:cNvPr>
+          <p:cNvPr id="3" name="Image 0" descr="/home/user/nova-works-app/scripts/assets/nova-works-logo.png">    </p:cNvPr>
           <p:cNvPicPr>
             <a:picLocks noChangeAspect="1"/>
           </p:cNvPicPr>
@@ -9452,7 +10886,7 @@
       </p:pic>
       <p:sp>
         <p:nvSpPr>
-          <p:cNvPr id="3" name="Text 0"/>
+          <p:cNvPr id="4" name="Text 1"/>
           <p:cNvSpPr txBox="1"/>
           <p:nvPr/>
         </p:nvSpPr>
@@ -9491,7 +10925,7 @@
       </p:sp>
       <p:sp>
         <p:nvSpPr>
-          <p:cNvPr id="4" name="Text 1"/>
+          <p:cNvPr id="5" name="Text 2"/>
           <p:cNvSpPr txBox="1"/>
           <p:nvPr/>
         </p:nvSpPr>
@@ -9530,7 +10964,7 @@
       </p:sp>
       <p:sp>
         <p:nvSpPr>
-          <p:cNvPr id="5" name="Shape 2"/>
+          <p:cNvPr id="6" name="Shape 3"/>
           <p:cNvSpPr/>
           <p:nvPr/>
         </p:nvSpPr>
@@ -9555,7 +10989,7 @@
       </p:sp>
       <p:sp>
         <p:nvSpPr>
-          <p:cNvPr id="6" name="Text 3"/>
+          <p:cNvPr id="7" name="Text 4"/>
           <p:cNvSpPr txBox="1"/>
           <p:nvPr/>
         </p:nvSpPr>
@@ -9594,7 +11028,7 @@
       </p:sp>
       <p:sp>
         <p:nvSpPr>
-          <p:cNvPr id="7" name="Text 4"/>
+          <p:cNvPr id="8" name="Text 5"/>
           <p:cNvSpPr txBox="1"/>
           <p:nvPr/>
         </p:nvSpPr>
@@ -9633,7 +11067,7 @@
       </p:sp>
       <p:sp>
         <p:nvSpPr>
-          <p:cNvPr id="8" name="Text 5"/>
+          <p:cNvPr id="9" name="Text 6"/>
           <p:cNvSpPr txBox="1"/>
           <p:nvPr/>
         </p:nvSpPr>
@@ -11795,7 +13229,7 @@
       </p:graphicFrame>
       <p:graphicFrame>
         <p:nvGraphicFramePr>
-          <p:cNvPr id="10" name="Chart 0" descr=""/>
+          <p:cNvPr id="11" name="Chart 0" descr=""/>
           <p:cNvGraphicFramePr/>
           <p:nvPr/>
         </p:nvGraphicFramePr>
@@ -11811,7 +13245,7 @@
       </p:graphicFrame>
       <p:sp>
         <p:nvSpPr>
-          <p:cNvPr id="11" name="Shape 6"/>
+          <p:cNvPr id="12" name="Shape 7"/>
           <p:cNvSpPr/>
           <p:nvPr/>
         </p:nvSpPr>
@@ -11845,7 +13279,7 @@
       </p:sp>
       <p:sp>
         <p:nvSpPr>
-          <p:cNvPr id="12" name="Text 7"/>
+          <p:cNvPr id="13" name="Text 8"/>
           <p:cNvSpPr txBox="1"/>
           <p:nvPr/>
         </p:nvSpPr>
@@ -11884,7 +13318,7 @@
       </p:sp>
       <p:sp>
         <p:nvSpPr>
-          <p:cNvPr id="13" name="Text 8"/>
+          <p:cNvPr id="14" name="Text 9"/>
           <p:cNvSpPr txBox="1"/>
           <p:nvPr/>
         </p:nvSpPr>
@@ -11923,7 +13357,7 @@
       </p:sp>
       <p:sp>
         <p:nvSpPr>
-          <p:cNvPr id="14" name="Text 9"/>
+          <p:cNvPr id="15" name="Text 10"/>
           <p:cNvSpPr txBox="1"/>
           <p:nvPr/>
         </p:nvSpPr>
@@ -11962,7 +13396,7 @@
       </p:sp>
       <p:sp>
         <p:nvSpPr>
-          <p:cNvPr id="15" name="Shape 10"/>
+          <p:cNvPr id="16" name="Shape 11"/>
           <p:cNvSpPr/>
           <p:nvPr/>
         </p:nvSpPr>
@@ -11996,7 +13430,7 @@
       </p:sp>
       <p:sp>
         <p:nvSpPr>
-          <p:cNvPr id="16" name="Text 11"/>
+          <p:cNvPr id="17" name="Text 12"/>
           <p:cNvSpPr txBox="1"/>
           <p:nvPr/>
         </p:nvSpPr>
@@ -12035,7 +13469,7 @@
       </p:sp>
       <p:sp>
         <p:nvSpPr>
-          <p:cNvPr id="17" name="Text 12"/>
+          <p:cNvPr id="18" name="Text 13"/>
           <p:cNvSpPr txBox="1"/>
           <p:nvPr/>
         </p:nvSpPr>
@@ -12074,7 +13508,7 @@
       </p:sp>
       <p:sp>
         <p:nvSpPr>
-          <p:cNvPr id="18" name="Text 13"/>
+          <p:cNvPr id="19" name="Text 14"/>
           <p:cNvSpPr txBox="1"/>
           <p:nvPr/>
         </p:nvSpPr>
@@ -12113,7 +13547,7 @@
       </p:sp>
       <p:sp>
         <p:nvSpPr>
-          <p:cNvPr id="19" name="Shape 14"/>
+          <p:cNvPr id="20" name="Shape 15"/>
           <p:cNvSpPr/>
           <p:nvPr/>
         </p:nvSpPr>
@@ -12147,7 +13581,7 @@
       </p:sp>
       <p:sp>
         <p:nvSpPr>
-          <p:cNvPr id="20" name="Text 15"/>
+          <p:cNvPr id="21" name="Text 16"/>
           <p:cNvSpPr txBox="1"/>
           <p:nvPr/>
         </p:nvSpPr>
@@ -12216,9 +13650,48 @@
           <a:chExt cx="0" cy="0"/>
         </a:xfrm>
       </p:grpSpPr>
+      <p:sp>
+        <p:nvSpPr>
+          <p:cNvPr id="2" name="Text 0"/>
+          <p:cNvSpPr txBox="1"/>
+          <p:nvPr/>
+        </p:nvSpPr>
+        <p:spPr>
+          <a:xfrm>
+            <a:off x="7802575" y="914400"/>
+            <a:ext cx="3840480" cy="256032"/>
+          </a:xfrm>
+          <a:prstGeom prst="rect">
+            <a:avLst/>
+          </a:prstGeom>
+          <a:noFill/>
+          <a:ln/>
+        </p:spPr>
+        <p:txBody>
+          <a:bodyPr wrap="square" lIns="0" tIns="0" rIns="0" bIns="0" rtlCol="0" anchor="ctr"/>
+          <a:lstStyle/>
+          <a:p>
+            <a:pPr algn="r" indent="0" marL="0">
+              <a:buNone/>
+            </a:pPr>
+            <a:r>
+              <a:rPr lang="en-US" sz="850" b="1" spc="200" kern="0" dirty="0">
+                <a:solidFill>
+                  <a:srgbClr val="A8884F"/>
+                </a:solidFill>
+                <a:latin typeface="Helvetica" pitchFamily="34" charset="0"/>
+                <a:ea typeface="Helvetica" pitchFamily="34" charset="-122"/>
+                <a:cs typeface="Helvetica" pitchFamily="34" charset="-120"/>
+              </a:rPr>
+              <a:t>TOP 3  ·  FOLIE 2 von 2</a:t>
+            </a:r>
+            <a:endParaRPr lang="en-US" sz="850" dirty="0"/>
+          </a:p>
+        </p:txBody>
+      </p:sp>
       <p:pic>
         <p:nvPicPr>
-          <p:cNvPr id="2" name="Image 0" descr="/home/user/nova-works-app/scripts/assets/nova-works-logo.png">    </p:cNvPr>
+          <p:cNvPr id="3" name="Image 0" descr="/home/user/nova-works-app/scripts/assets/nova-works-logo.png">    </p:cNvPr>
           <p:cNvPicPr>
             <a:picLocks noChangeAspect="1"/>
           </p:cNvPicPr>
@@ -12242,7 +13715,7 @@
       </p:pic>
       <p:sp>
         <p:nvSpPr>
-          <p:cNvPr id="3" name="Text 0"/>
+          <p:cNvPr id="4" name="Text 1"/>
           <p:cNvSpPr txBox="1"/>
           <p:nvPr/>
         </p:nvSpPr>
@@ -12281,7 +13754,7 @@
       </p:sp>
       <p:sp>
         <p:nvSpPr>
-          <p:cNvPr id="4" name="Text 1"/>
+          <p:cNvPr id="5" name="Text 2"/>
           <p:cNvSpPr txBox="1"/>
           <p:nvPr/>
         </p:nvSpPr>
@@ -12320,7 +13793,7 @@
       </p:sp>
       <p:sp>
         <p:nvSpPr>
-          <p:cNvPr id="5" name="Shape 2"/>
+          <p:cNvPr id="6" name="Shape 3"/>
           <p:cNvSpPr/>
           <p:nvPr/>
         </p:nvSpPr>
@@ -12345,7 +13818,7 @@
       </p:sp>
       <p:sp>
         <p:nvSpPr>
-          <p:cNvPr id="6" name="Text 3"/>
+          <p:cNvPr id="7" name="Text 4"/>
           <p:cNvSpPr txBox="1"/>
           <p:nvPr/>
         </p:nvSpPr>
@@ -12384,7 +13857,7 @@
       </p:sp>
       <p:sp>
         <p:nvSpPr>
-          <p:cNvPr id="7" name="Text 4"/>
+          <p:cNvPr id="8" name="Text 5"/>
           <p:cNvSpPr txBox="1"/>
           <p:nvPr/>
         </p:nvSpPr>
@@ -12423,7 +13896,7 @@
       </p:sp>
       <p:sp>
         <p:nvSpPr>
-          <p:cNvPr id="8" name="Text 5"/>
+          <p:cNvPr id="9" name="Text 6"/>
           <p:cNvSpPr txBox="1"/>
           <p:nvPr/>
         </p:nvSpPr>
@@ -12462,7 +13935,7 @@
       </p:sp>
       <p:sp>
         <p:nvSpPr>
-          <p:cNvPr id="9" name="Shape 6"/>
+          <p:cNvPr id="10" name="Shape 7"/>
           <p:cNvSpPr/>
           <p:nvPr/>
         </p:nvSpPr>
@@ -12496,7 +13969,7 @@
       </p:sp>
       <p:sp>
         <p:nvSpPr>
-          <p:cNvPr id="10" name="Text 7"/>
+          <p:cNvPr id="11" name="Text 8"/>
           <p:cNvSpPr txBox="1"/>
           <p:nvPr/>
         </p:nvSpPr>
@@ -12535,7 +14008,7 @@
       </p:sp>
       <p:sp>
         <p:nvSpPr>
-          <p:cNvPr id="11" name="Text 8"/>
+          <p:cNvPr id="12" name="Text 9"/>
           <p:cNvSpPr txBox="1"/>
           <p:nvPr/>
         </p:nvSpPr>
@@ -12574,7 +14047,7 @@
       </p:sp>
       <p:sp>
         <p:nvSpPr>
-          <p:cNvPr id="12" name="Text 9"/>
+          <p:cNvPr id="13" name="Text 10"/>
           <p:cNvSpPr txBox="1"/>
           <p:nvPr/>
         </p:nvSpPr>
@@ -12613,7 +14086,7 @@
       </p:sp>
       <p:sp>
         <p:nvSpPr>
-          <p:cNvPr id="13" name="Shape 10"/>
+          <p:cNvPr id="14" name="Shape 11"/>
           <p:cNvSpPr/>
           <p:nvPr/>
         </p:nvSpPr>
@@ -12647,7 +14120,7 @@
       </p:sp>
       <p:sp>
         <p:nvSpPr>
-          <p:cNvPr id="14" name="Text 11"/>
+          <p:cNvPr id="15" name="Text 12"/>
           <p:cNvSpPr txBox="1"/>
           <p:nvPr/>
         </p:nvSpPr>
@@ -12686,7 +14159,7 @@
       </p:sp>
       <p:sp>
         <p:nvSpPr>
-          <p:cNvPr id="15" name="Text 12"/>
+          <p:cNvPr id="16" name="Text 13"/>
           <p:cNvSpPr txBox="1"/>
           <p:nvPr/>
         </p:nvSpPr>
@@ -12725,7 +14198,7 @@
       </p:sp>
       <p:sp>
         <p:nvSpPr>
-          <p:cNvPr id="16" name="Text 13"/>
+          <p:cNvPr id="17" name="Text 14"/>
           <p:cNvSpPr txBox="1"/>
           <p:nvPr/>
         </p:nvSpPr>
@@ -12764,7 +14237,7 @@
       </p:sp>
       <p:sp>
         <p:nvSpPr>
-          <p:cNvPr id="17" name="Shape 14"/>
+          <p:cNvPr id="18" name="Shape 15"/>
           <p:cNvSpPr/>
           <p:nvPr/>
         </p:nvSpPr>
@@ -12798,7 +14271,7 @@
       </p:sp>
       <p:sp>
         <p:nvSpPr>
-          <p:cNvPr id="18" name="Text 15"/>
+          <p:cNvPr id="19" name="Text 16"/>
           <p:cNvSpPr txBox="1"/>
           <p:nvPr/>
         </p:nvSpPr>
@@ -12837,7 +14310,7 @@
       </p:sp>
       <p:sp>
         <p:nvSpPr>
-          <p:cNvPr id="19" name="Text 16"/>
+          <p:cNvPr id="20" name="Text 17"/>
           <p:cNvSpPr txBox="1"/>
           <p:nvPr/>
         </p:nvSpPr>
@@ -12876,7 +14349,7 @@
       </p:sp>
       <p:sp>
         <p:nvSpPr>
-          <p:cNvPr id="20" name="Text 17"/>
+          <p:cNvPr id="21" name="Text 18"/>
           <p:cNvSpPr txBox="1"/>
           <p:nvPr/>
         </p:nvSpPr>
@@ -12915,7 +14388,7 @@
       </p:sp>
       <p:graphicFrame>
         <p:nvGraphicFramePr>
-          <p:cNvPr id="21" name="Chart 0" descr=""/>
+          <p:cNvPr id="22" name="Chart 0" descr=""/>
           <p:cNvGraphicFramePr/>
           <p:nvPr/>
         </p:nvGraphicFramePr>
@@ -12931,7 +14404,7 @@
       </p:graphicFrame>
       <p:sp>
         <p:nvSpPr>
-          <p:cNvPr id="22" name="Shape 18"/>
+          <p:cNvPr id="23" name="Shape 19"/>
           <p:cNvSpPr/>
           <p:nvPr/>
         </p:nvSpPr>
@@ -12965,7 +14438,7 @@
       </p:sp>
       <p:sp>
         <p:nvSpPr>
-          <p:cNvPr id="23" name="Text 19"/>
+          <p:cNvPr id="24" name="Text 20"/>
           <p:cNvSpPr txBox="1"/>
           <p:nvPr/>
         </p:nvSpPr>
@@ -13004,7 +14477,7 @@
       </p:sp>
       <p:sp>
         <p:nvSpPr>
-          <p:cNvPr id="24" name="Text 20"/>
+          <p:cNvPr id="25" name="Text 21"/>
           <p:cNvSpPr txBox="1"/>
           <p:nvPr/>
         </p:nvSpPr>
@@ -13043,7 +14516,7 @@
       </p:sp>
       <p:sp>
         <p:nvSpPr>
-          <p:cNvPr id="25" name="Text 21"/>
+          <p:cNvPr id="26" name="Text 22"/>
           <p:cNvSpPr txBox="1"/>
           <p:nvPr/>
         </p:nvSpPr>

</xml_diff>

<commit_message>
Gesellschafterversammlung: Projekt 26-0031 SWR NPF 2026 im September ergänzt
Co-Authored-By: Claude Fable 5.1 <noreply@anthropic.com>
Claude-Session: https://claude.ai/code/session_0118VeQCFGC8WVSdKpLNkHCn
</commit_message>
<xml_diff>
--- a/praesentationen/Gesellschafterversammlung_2026-09-23.pptx
+++ b/praesentationen/Gesellschafterversammlung_2026-09-23.pptx
@@ -117,45 +117,45 @@
   <p:extLst>
     <p:ext uri="{521415D9-36F7-43E2-AB2F-B90AF26B5E84}">
       <p14:sectionLst xmlns:p14="http://schemas.microsoft.com/office/powerpoint/2010/main">
-        <p14:section name="Einstieg" id="{ca132568-6624-3ee9-3f95-5e0ae2375e09}">
+        <p14:section name="Einstieg" id="{354ca6cf-3b83-29c9-e917-fc865fdd704b}">
           <p14:sldIdLst>
             <p14:sldId id="256"/>
             <p14:sldId id="257"/>
           </p14:sldIdLst>
         </p14:section>
-        <p14:section name="TOP 1 · Kurze Zusammenfassung und IST-Zustand" id="{1677242e-35a7-b6db-211c-2da4457cd85e}">
+        <p14:section name="TOP 1 · Kurze Zusammenfassung und IST-Zustand" id="{a15b4471-b6d1-bd1a-9bd6-9d13785e9fd5}">
           <p14:sldIdLst>
             <p14:sldId id="258"/>
           </p14:sldIdLst>
         </p14:section>
-        <p14:section name="TOP 2 · Überblick der letzten 4 Monate" id="{97032db0-3c11-6f3f-5a2d-aafd3c92e556}">
+        <p14:section name="TOP 2 · Überblick der letzten 4 Monate" id="{64d39a15-3fe6-2b01-9bc8-53ae14a21e7d}">
           <p14:sldIdLst>
             <p14:sldId id="259"/>
             <p14:sldId id="260"/>
           </p14:sldIdLst>
         </p14:section>
-        <p14:section name="TOP 3 · 80er im Detail und Zukunft Kunde MK?" id="{f22165a2-f4b7-5029-8535-4ae7f5e68773}">
+        <p14:section name="TOP 3 · 80er im Detail und Zukunft Kunde MK?" id="{c76b8fc9-2309-332d-60bb-9d134b6eb41a}">
           <p14:sldIdLst>
             <p14:sldId id="261"/>
             <p14:sldId id="262"/>
           </p14:sldIdLst>
         </p14:section>
-        <p14:section name="TOP 4 · Messeauftritt" id="{86a873c1-8002-dfc8-7e9a-f960192a8078}">
+        <p14:section name="TOP 4 · Messeauftritt" id="{a12dac5b-8247-9366-4380-2b575dab7b19}">
           <p14:sldIdLst>
             <p14:sldId id="263"/>
           </p14:sldIdLst>
         </p14:section>
-        <p14:section name="TOP 5 · Forecast und Ausblick" id="{456d17fd-d8cc-181e-2e71-5ed8db7204e8}">
+        <p14:section name="TOP 5 · Forecast und Ausblick" id="{b4f09c9e-09e0-1d42-e625-66b46b848e7b}">
           <p14:sldIdLst>
             <p14:sldId id="264"/>
           </p14:sldIdLst>
         </p14:section>
-        <p14:section name="TOP 6 · Sonstiges" id="{4e61fdda-bfab-5427-0241-2cd88527019c}">
+        <p14:section name="TOP 6 · Sonstiges" id="{b3c3aae3-b41a-57bd-d9a2-b8391d71189c}">
           <p14:sldIdLst>
             <p14:sldId id="265"/>
           </p14:sldIdLst>
         </p14:section>
-        <p14:section name="Abschluss" id="{3b6fa6bd-af9f-1b2d-2b4f-d8522a7d4424}">
+        <p14:section name="Abschluss" id="{b109adc6-6b3a-0521-7709-c28dd2e41d56}">
           <p14:sldIdLst>
             <p14:sldId id="266"/>
           </p14:sldIdLst>
@@ -7860,7 +7860,7 @@
                 <a:ea typeface="Helvetica" pitchFamily="34" charset="-122"/>
                 <a:cs typeface="Helvetica" pitchFamily="34" charset="-120"/>
               </a:rPr>
-              <a:t>17 Projekte in fünf Monaten</a:t>
+              <a:t>18 Projekte in fünf Monaten</a:t>
             </a:r>
             <a:endParaRPr lang="en-US" sz="1250" dirty="0"/>
           </a:p>
@@ -7939,11 +7939,11 @@
         <p:spPr>
           <a:xfrm>
             <a:off x="640080" y="2468880"/>
-            <a:ext cx="2036003" cy="2203704"/>
+            <a:ext cx="2036003" cy="1984248"/>
           </a:xfrm>
           <a:prstGeom prst="roundRect">
             <a:avLst>
-              <a:gd name="adj" fmla="val 5389"/>
+              <a:gd name="adj" fmla="val 5530"/>
             </a:avLst>
           </a:prstGeom>
           <a:solidFill>
@@ -8050,7 +8050,7 @@
         </p:nvSpPr>
         <p:spPr>
           <a:xfrm>
-            <a:off x="804672" y="3291840"/>
+            <a:off x="804672" y="3218688"/>
             <a:ext cx="1706819" cy="228600"/>
           </a:xfrm>
           <a:prstGeom prst="rect">
@@ -8089,7 +8089,7 @@
         </p:nvSpPr>
         <p:spPr>
           <a:xfrm>
-            <a:off x="804672" y="3511296"/>
+            <a:off x="804672" y="3438144"/>
             <a:ext cx="1706819" cy="384048"/>
           </a:xfrm>
           <a:prstGeom prst="rect">
@@ -8128,7 +8128,7 @@
         </p:nvSpPr>
         <p:spPr>
           <a:xfrm>
-            <a:off x="804672" y="3950208"/>
+            <a:off x="804672" y="3803904"/>
             <a:ext cx="1706819" cy="228600"/>
           </a:xfrm>
           <a:prstGeom prst="rect">
@@ -8167,7 +8167,7 @@
         </p:nvSpPr>
         <p:spPr>
           <a:xfrm>
-            <a:off x="804672" y="4169664"/>
+            <a:off x="804672" y="4023360"/>
             <a:ext cx="1706819" cy="384048"/>
           </a:xfrm>
           <a:prstGeom prst="rect">
@@ -8271,7 +8271,7 @@
         <p:spPr>
           <a:xfrm>
             <a:off x="2858963" y="2468880"/>
-            <a:ext cx="2036003" cy="2862072"/>
+            <a:ext cx="2036003" cy="2569464"/>
           </a:xfrm>
           <a:prstGeom prst="roundRect">
             <a:avLst>
@@ -8382,7 +8382,7 @@
         </p:nvSpPr>
         <p:spPr>
           <a:xfrm>
-            <a:off x="3023555" y="3291840"/>
+            <a:off x="3023555" y="3218688"/>
             <a:ext cx="1706819" cy="228600"/>
           </a:xfrm>
           <a:prstGeom prst="rect">
@@ -8421,7 +8421,7 @@
         </p:nvSpPr>
         <p:spPr>
           <a:xfrm>
-            <a:off x="3023555" y="3511296"/>
+            <a:off x="3023555" y="3438144"/>
             <a:ext cx="1706819" cy="384048"/>
           </a:xfrm>
           <a:prstGeom prst="rect">
@@ -8460,7 +8460,7 @@
         </p:nvSpPr>
         <p:spPr>
           <a:xfrm>
-            <a:off x="3023555" y="3950208"/>
+            <a:off x="3023555" y="3803904"/>
             <a:ext cx="1706819" cy="228600"/>
           </a:xfrm>
           <a:prstGeom prst="rect">
@@ -8499,7 +8499,7 @@
         </p:nvSpPr>
         <p:spPr>
           <a:xfrm>
-            <a:off x="3023555" y="4169664"/>
+            <a:off x="3023555" y="4023360"/>
             <a:ext cx="1706819" cy="384048"/>
           </a:xfrm>
           <a:prstGeom prst="rect">
@@ -8538,46 +8538,46 @@
         </p:nvSpPr>
         <p:spPr>
           <a:xfrm>
+            <a:off x="3023555" y="4389120"/>
+            <a:ext cx="1706819" cy="228600"/>
+          </a:xfrm>
+          <a:prstGeom prst="rect">
+            <a:avLst/>
+          </a:prstGeom>
+          <a:noFill/>
+          <a:ln/>
+        </p:spPr>
+        <p:txBody>
+          <a:bodyPr wrap="square" lIns="0" tIns="0" rIns="0" bIns="0" rtlCol="0" anchor="ctr"/>
+          <a:lstStyle/>
+          <a:p>
+            <a:pPr indent="0" marL="0">
+              <a:buNone/>
+            </a:pPr>
+            <a:r>
+              <a:rPr lang="en-US" sz="900" b="1" spc="100" kern="0" dirty="0">
+                <a:solidFill>
+                  <a:srgbClr val="A8884F"/>
+                </a:solidFill>
+                <a:latin typeface="Helvetica" pitchFamily="34" charset="0"/>
+                <a:ea typeface="Helvetica" pitchFamily="34" charset="-122"/>
+                <a:cs typeface="Helvetica" pitchFamily="34" charset="-120"/>
+              </a:rPr>
+              <a:t>26-0016</a:t>
+            </a:r>
+            <a:endParaRPr lang="en-US" sz="900" dirty="0"/>
+          </a:p>
+        </p:txBody>
+      </p:sp>
+      <p:sp>
+        <p:nvSpPr>
+          <p:cNvPr id="31" name="Text 28"/>
+          <p:cNvSpPr txBox="1"/>
+          <p:nvPr/>
+        </p:nvSpPr>
+        <p:spPr>
+          <a:xfrm>
             <a:off x="3023555" y="4608576"/>
-            <a:ext cx="1706819" cy="228600"/>
-          </a:xfrm>
-          <a:prstGeom prst="rect">
-            <a:avLst/>
-          </a:prstGeom>
-          <a:noFill/>
-          <a:ln/>
-        </p:spPr>
-        <p:txBody>
-          <a:bodyPr wrap="square" lIns="0" tIns="0" rIns="0" bIns="0" rtlCol="0" anchor="ctr"/>
-          <a:lstStyle/>
-          <a:p>
-            <a:pPr indent="0" marL="0">
-              <a:buNone/>
-            </a:pPr>
-            <a:r>
-              <a:rPr lang="en-US" sz="900" b="1" spc="100" kern="0" dirty="0">
-                <a:solidFill>
-                  <a:srgbClr val="A8884F"/>
-                </a:solidFill>
-                <a:latin typeface="Helvetica" pitchFamily="34" charset="0"/>
-                <a:ea typeface="Helvetica" pitchFamily="34" charset="-122"/>
-                <a:cs typeface="Helvetica" pitchFamily="34" charset="-120"/>
-              </a:rPr>
-              <a:t>26-0016</a:t>
-            </a:r>
-            <a:endParaRPr lang="en-US" sz="900" dirty="0"/>
-          </a:p>
-        </p:txBody>
-      </p:sp>
-      <p:sp>
-        <p:nvSpPr>
-          <p:cNvPr id="31" name="Text 28"/>
-          <p:cNvSpPr txBox="1"/>
-          <p:nvPr/>
-        </p:nvSpPr>
-        <p:spPr>
-          <a:xfrm>
-            <a:off x="3023555" y="4828032"/>
             <a:ext cx="1706819" cy="384048"/>
           </a:xfrm>
           <a:prstGeom prst="rect">
@@ -8681,7 +8681,7 @@
         <p:spPr>
           <a:xfrm>
             <a:off x="5077846" y="2468880"/>
-            <a:ext cx="2036003" cy="2862072"/>
+            <a:ext cx="2036003" cy="2569464"/>
           </a:xfrm>
           <a:prstGeom prst="roundRect">
             <a:avLst>
@@ -8792,7 +8792,7 @@
         </p:nvSpPr>
         <p:spPr>
           <a:xfrm>
-            <a:off x="5242438" y="3291840"/>
+            <a:off x="5242438" y="3218688"/>
             <a:ext cx="1706819" cy="228600"/>
           </a:xfrm>
           <a:prstGeom prst="rect">
@@ -8831,7 +8831,7 @@
         </p:nvSpPr>
         <p:spPr>
           <a:xfrm>
-            <a:off x="5242438" y="3511296"/>
+            <a:off x="5242438" y="3438144"/>
             <a:ext cx="1706819" cy="384048"/>
           </a:xfrm>
           <a:prstGeom prst="rect">
@@ -8870,7 +8870,7 @@
         </p:nvSpPr>
         <p:spPr>
           <a:xfrm>
-            <a:off x="5242438" y="3950208"/>
+            <a:off x="5242438" y="3803904"/>
             <a:ext cx="1706819" cy="228600"/>
           </a:xfrm>
           <a:prstGeom prst="rect">
@@ -8909,7 +8909,7 @@
         </p:nvSpPr>
         <p:spPr>
           <a:xfrm>
-            <a:off x="5242438" y="4169664"/>
+            <a:off x="5242438" y="4023360"/>
             <a:ext cx="1706819" cy="384048"/>
           </a:xfrm>
           <a:prstGeom prst="rect">
@@ -8948,46 +8948,46 @@
         </p:nvSpPr>
         <p:spPr>
           <a:xfrm>
+            <a:off x="5242438" y="4389120"/>
+            <a:ext cx="1706819" cy="228600"/>
+          </a:xfrm>
+          <a:prstGeom prst="rect">
+            <a:avLst/>
+          </a:prstGeom>
+          <a:noFill/>
+          <a:ln/>
+        </p:spPr>
+        <p:txBody>
+          <a:bodyPr wrap="square" lIns="0" tIns="0" rIns="0" bIns="0" rtlCol="0" anchor="ctr"/>
+          <a:lstStyle/>
+          <a:p>
+            <a:pPr indent="0" marL="0">
+              <a:buNone/>
+            </a:pPr>
+            <a:r>
+              <a:rPr lang="en-US" sz="900" b="1" spc="100" kern="0" dirty="0">
+                <a:solidFill>
+                  <a:srgbClr val="A8884F"/>
+                </a:solidFill>
+                <a:latin typeface="Helvetica" pitchFamily="34" charset="0"/>
+                <a:ea typeface="Helvetica" pitchFamily="34" charset="-122"/>
+                <a:cs typeface="Helvetica" pitchFamily="34" charset="-120"/>
+              </a:rPr>
+              <a:t>26-0033</a:t>
+            </a:r>
+            <a:endParaRPr lang="en-US" sz="900" dirty="0"/>
+          </a:p>
+        </p:txBody>
+      </p:sp>
+      <p:sp>
+        <p:nvSpPr>
+          <p:cNvPr id="42" name="Text 39"/>
+          <p:cNvSpPr txBox="1"/>
+          <p:nvPr/>
+        </p:nvSpPr>
+        <p:spPr>
+          <a:xfrm>
             <a:off x="5242438" y="4608576"/>
-            <a:ext cx="1706819" cy="228600"/>
-          </a:xfrm>
-          <a:prstGeom prst="rect">
-            <a:avLst/>
-          </a:prstGeom>
-          <a:noFill/>
-          <a:ln/>
-        </p:spPr>
-        <p:txBody>
-          <a:bodyPr wrap="square" lIns="0" tIns="0" rIns="0" bIns="0" rtlCol="0" anchor="ctr"/>
-          <a:lstStyle/>
-          <a:p>
-            <a:pPr indent="0" marL="0">
-              <a:buNone/>
-            </a:pPr>
-            <a:r>
-              <a:rPr lang="en-US" sz="900" b="1" spc="100" kern="0" dirty="0">
-                <a:solidFill>
-                  <a:srgbClr val="A8884F"/>
-                </a:solidFill>
-                <a:latin typeface="Helvetica" pitchFamily="34" charset="0"/>
-                <a:ea typeface="Helvetica" pitchFamily="34" charset="-122"/>
-                <a:cs typeface="Helvetica" pitchFamily="34" charset="-120"/>
-              </a:rPr>
-              <a:t>26-0033</a:t>
-            </a:r>
-            <a:endParaRPr lang="en-US" sz="900" dirty="0"/>
-          </a:p>
-        </p:txBody>
-      </p:sp>
-      <p:sp>
-        <p:nvSpPr>
-          <p:cNvPr id="42" name="Text 39"/>
-          <p:cNvSpPr txBox="1"/>
-          <p:nvPr/>
-        </p:nvSpPr>
-        <p:spPr>
-          <a:xfrm>
-            <a:off x="5242438" y="4828032"/>
             <a:ext cx="1706819" cy="384048"/>
           </a:xfrm>
           <a:prstGeom prst="rect">
@@ -9091,11 +9091,11 @@
         <p:spPr>
           <a:xfrm>
             <a:off x="7296729" y="2468880"/>
-            <a:ext cx="2036003" cy="886968"/>
+            <a:ext cx="2036003" cy="813816"/>
           </a:xfrm>
           <a:prstGeom prst="roundRect">
             <a:avLst>
-              <a:gd name="adj" fmla="val 12371"/>
+              <a:gd name="adj" fmla="val 13483"/>
             </a:avLst>
           </a:prstGeom>
           <a:solidFill>
@@ -9267,7 +9267,7 @@
         <p:spPr>
           <a:xfrm>
             <a:off x="9515612" y="2468880"/>
-            <a:ext cx="2036003" cy="3520440"/>
+            <a:ext cx="2036003" cy="3739896"/>
           </a:xfrm>
           <a:prstGeom prst="roundRect">
             <a:avLst>
@@ -9378,7 +9378,7 @@
         </p:nvSpPr>
         <p:spPr>
           <a:xfrm>
-            <a:off x="9680204" y="3291840"/>
+            <a:off x="9680204" y="3218688"/>
             <a:ext cx="1706819" cy="228600"/>
           </a:xfrm>
           <a:prstGeom prst="rect">
@@ -9417,7 +9417,7 @@
         </p:nvSpPr>
         <p:spPr>
           <a:xfrm>
-            <a:off x="9680204" y="3511296"/>
+            <a:off x="9680204" y="3438144"/>
             <a:ext cx="1706819" cy="384048"/>
           </a:xfrm>
           <a:prstGeom prst="rect">
@@ -9456,7 +9456,7 @@
         </p:nvSpPr>
         <p:spPr>
           <a:xfrm>
-            <a:off x="9680204" y="3950208"/>
+            <a:off x="9680204" y="3803904"/>
             <a:ext cx="1706819" cy="228600"/>
           </a:xfrm>
           <a:prstGeom prst="rect">
@@ -9495,7 +9495,7 @@
         </p:nvSpPr>
         <p:spPr>
           <a:xfrm>
-            <a:off x="9680204" y="4169664"/>
+            <a:off x="9680204" y="4023360"/>
             <a:ext cx="1706819" cy="384048"/>
           </a:xfrm>
           <a:prstGeom prst="rect">
@@ -9534,7 +9534,85 @@
         </p:nvSpPr>
         <p:spPr>
           <a:xfrm>
+            <a:off x="9680204" y="4389120"/>
+            <a:ext cx="1706819" cy="228600"/>
+          </a:xfrm>
+          <a:prstGeom prst="rect">
+            <a:avLst/>
+          </a:prstGeom>
+          <a:noFill/>
+          <a:ln/>
+        </p:spPr>
+        <p:txBody>
+          <a:bodyPr wrap="square" lIns="0" tIns="0" rIns="0" bIns="0" rtlCol="0" anchor="ctr"/>
+          <a:lstStyle/>
+          <a:p>
+            <a:pPr indent="0" marL="0">
+              <a:buNone/>
+            </a:pPr>
+            <a:r>
+              <a:rPr lang="en-US" sz="900" b="1" spc="100" kern="0" dirty="0">
+                <a:solidFill>
+                  <a:srgbClr val="A8884F"/>
+                </a:solidFill>
+                <a:latin typeface="Helvetica" pitchFamily="34" charset="0"/>
+                <a:ea typeface="Helvetica" pitchFamily="34" charset="-122"/>
+                <a:cs typeface="Helvetica" pitchFamily="34" charset="-120"/>
+              </a:rPr>
+              <a:t>26-0031</a:t>
+            </a:r>
+            <a:endParaRPr lang="en-US" sz="900" dirty="0"/>
+          </a:p>
+        </p:txBody>
+      </p:sp>
+      <p:sp>
+        <p:nvSpPr>
+          <p:cNvPr id="58" name="Text 55"/>
+          <p:cNvSpPr txBox="1"/>
+          <p:nvPr/>
+        </p:nvSpPr>
+        <p:spPr>
+          <a:xfrm>
             <a:off x="9680204" y="4608576"/>
+            <a:ext cx="1706819" cy="384048"/>
+          </a:xfrm>
+          <a:prstGeom prst="rect">
+            <a:avLst/>
+          </a:prstGeom>
+          <a:noFill/>
+          <a:ln/>
+        </p:spPr>
+        <p:txBody>
+          <a:bodyPr wrap="square" lIns="0" tIns="0" rIns="0" bIns="0" rtlCol="0" anchor="t"/>
+          <a:lstStyle/>
+          <a:p>
+            <a:pPr indent="0" marL="0">
+              <a:buNone/>
+            </a:pPr>
+            <a:r>
+              <a:rPr lang="en-US" sz="1100" b="1" dirty="0">
+                <a:solidFill>
+                  <a:srgbClr val="3D3D3D"/>
+                </a:solidFill>
+                <a:latin typeface="Helvetica" pitchFamily="34" charset="0"/>
+                <a:ea typeface="Helvetica" pitchFamily="34" charset="-122"/>
+                <a:cs typeface="Helvetica" pitchFamily="34" charset="-120"/>
+              </a:rPr>
+              <a:t>SWR NPF 2026</a:t>
+            </a:r>
+            <a:endParaRPr lang="en-US" sz="1100" dirty="0"/>
+          </a:p>
+        </p:txBody>
+      </p:sp>
+      <p:sp>
+        <p:nvSpPr>
+          <p:cNvPr id="59" name="Text 56"/>
+          <p:cNvSpPr txBox="1"/>
+          <p:nvPr/>
+        </p:nvSpPr>
+        <p:spPr>
+          <a:xfrm>
+            <a:off x="9680204" y="4974336"/>
             <a:ext cx="1706819" cy="228600"/>
           </a:xfrm>
           <a:prstGeom prst="rect">
@@ -9567,13 +9645,13 @@
       </p:sp>
       <p:sp>
         <p:nvSpPr>
-          <p:cNvPr id="58" name="Text 55"/>
-          <p:cNvSpPr txBox="1"/>
-          <p:nvPr/>
-        </p:nvSpPr>
-        <p:spPr>
-          <a:xfrm>
-            <a:off x="9680204" y="4828032"/>
+          <p:cNvPr id="60" name="Text 57"/>
+          <p:cNvSpPr txBox="1"/>
+          <p:nvPr/>
+        </p:nvSpPr>
+        <p:spPr>
+          <a:xfrm>
+            <a:off x="9680204" y="5193792"/>
             <a:ext cx="1706819" cy="384048"/>
           </a:xfrm>
           <a:prstGeom prst="rect">
@@ -9606,13 +9684,13 @@
       </p:sp>
       <p:sp>
         <p:nvSpPr>
-          <p:cNvPr id="59" name="Text 56"/>
-          <p:cNvSpPr txBox="1"/>
-          <p:nvPr/>
-        </p:nvSpPr>
-        <p:spPr>
-          <a:xfrm>
-            <a:off x="9680204" y="5266944"/>
+          <p:cNvPr id="61" name="Text 58"/>
+          <p:cNvSpPr txBox="1"/>
+          <p:nvPr/>
+        </p:nvSpPr>
+        <p:spPr>
+          <a:xfrm>
+            <a:off x="9680204" y="5559552"/>
             <a:ext cx="1706819" cy="228600"/>
           </a:xfrm>
           <a:prstGeom prst="rect">
@@ -9645,13 +9723,13 @@
       </p:sp>
       <p:sp>
         <p:nvSpPr>
-          <p:cNvPr id="60" name="Text 57"/>
-          <p:cNvSpPr txBox="1"/>
-          <p:nvPr/>
-        </p:nvSpPr>
-        <p:spPr>
-          <a:xfrm>
-            <a:off x="9680204" y="5486400"/>
+          <p:cNvPr id="62" name="Text 59"/>
+          <p:cNvSpPr txBox="1"/>
+          <p:nvPr/>
+        </p:nvSpPr>
+        <p:spPr>
+          <a:xfrm>
+            <a:off x="9680204" y="5779008"/>
             <a:ext cx="1706819" cy="384048"/>
           </a:xfrm>
           <a:prstGeom prst="rect">

</xml_diff>

<commit_message>
Gesellschafterversammlung: Projektname Red Bull gekürzt, damit die September-Karte nicht umbricht
Co-Authored-By: Claude Fable 5.1 <noreply@anthropic.com>
Claude-Session: https://claude.ai/code/session_0118VeQCFGC8WVSdKpLNkHCn
</commit_message>
<xml_diff>
--- a/praesentationen/Gesellschafterversammlung_2026-09-23.pptx
+++ b/praesentationen/Gesellschafterversammlung_2026-09-23.pptx
@@ -117,45 +117,45 @@
   <p:extLst>
     <p:ext uri="{521415D9-36F7-43E2-AB2F-B90AF26B5E84}">
       <p14:sectionLst xmlns:p14="http://schemas.microsoft.com/office/powerpoint/2010/main">
-        <p14:section name="Einstieg" id="{354ca6cf-3b83-29c9-e917-fc865fdd704b}">
+        <p14:section name="Einstieg" id="{a2058ac2-9a6e-f857-e92d-e41fbbcb5604}">
           <p14:sldIdLst>
             <p14:sldId id="256"/>
             <p14:sldId id="257"/>
           </p14:sldIdLst>
         </p14:section>
-        <p14:section name="TOP 1 · Kurze Zusammenfassung und IST-Zustand" id="{a15b4471-b6d1-bd1a-9bd6-9d13785e9fd5}">
+        <p14:section name="TOP 1 · Kurze Zusammenfassung und IST-Zustand" id="{61b822ce-8946-2a23-6825-77aa10e1c4c1}">
           <p14:sldIdLst>
             <p14:sldId id="258"/>
           </p14:sldIdLst>
         </p14:section>
-        <p14:section name="TOP 2 · Überblick der letzten 4 Monate" id="{64d39a15-3fe6-2b01-9bc8-53ae14a21e7d}">
+        <p14:section name="TOP 2 · Überblick der letzten 4 Monate" id="{2ced9060-c3c6-88c6-91aa-690330555d56}">
           <p14:sldIdLst>
             <p14:sldId id="259"/>
             <p14:sldId id="260"/>
           </p14:sldIdLst>
         </p14:section>
-        <p14:section name="TOP 3 · 80er im Detail und Zukunft Kunde MK?" id="{c76b8fc9-2309-332d-60bb-9d134b6eb41a}">
+        <p14:section name="TOP 3 · 80er im Detail und Zukunft Kunde MK?" id="{b4db0946-4114-6a84-2bfc-b4874b21a7a6}">
           <p14:sldIdLst>
             <p14:sldId id="261"/>
             <p14:sldId id="262"/>
           </p14:sldIdLst>
         </p14:section>
-        <p14:section name="TOP 4 · Messeauftritt" id="{a12dac5b-8247-9366-4380-2b575dab7b19}">
+        <p14:section name="TOP 4 · Messeauftritt" id="{ebceccc6-994e-f041-ef8e-a00276f81307}">
           <p14:sldIdLst>
             <p14:sldId id="263"/>
           </p14:sldIdLst>
         </p14:section>
-        <p14:section name="TOP 5 · Forecast und Ausblick" id="{b4f09c9e-09e0-1d42-e625-66b46b848e7b}">
+        <p14:section name="TOP 5 · Forecast und Ausblick" id="{5c997ca7-aa97-1c7a-d99a-b8a8e4c769e0}">
           <p14:sldIdLst>
             <p14:sldId id="264"/>
           </p14:sldIdLst>
         </p14:section>
-        <p14:section name="TOP 6 · Sonstiges" id="{b3c3aae3-b41a-57bd-d9a2-b8391d71189c}">
+        <p14:section name="TOP 6 · Sonstiges" id="{d295dbb3-789e-0de2-1344-c8186f9f61b4}">
           <p14:sldIdLst>
             <p14:sldId id="265"/>
           </p14:sldIdLst>
         </p14:section>
-        <p14:section name="Abschluss" id="{b109adc6-6b3a-0521-7709-c28dd2e41d56}">
+        <p14:section name="Abschluss" id="{7905478a-4b79-fec4-a1c5-df412faab88e}">
           <p14:sldIdLst>
             <p14:sldId id="266"/>
           </p14:sldIdLst>
@@ -9520,7 +9520,7 @@
                 <a:ea typeface="Helvetica" pitchFamily="34" charset="-122"/>
                 <a:cs typeface="Helvetica" pitchFamily="34" charset="-120"/>
               </a:rPr>
-              <a:t>Red Bull @ GG · Energy Station</a:t>
+              <a:t>Red Bull Energy Station</a:t>
             </a:r>
             <a:endParaRPr lang="en-US" sz="1100" dirty="0"/>
           </a:p>

</xml_diff>

<commit_message>
Gesellschafterversammlung: Kennzahlen aus der Datensicherung der App (Stand 18.09.2026)
Neues Skript daten-aus-backup.js lädt angebote.html headless mit einer
Datensicherung und schreibt daten.json: Summe Bestätigt der Auswertung
(TOP 1), Deal-Auswertung mit Kostensplit und Rechnungsstand (TOP 3),
Forecast für 12 Monate und Kalenderjahre 2026/2027 (TOP 5). Die
Präsentation liest daten.json; Kachelwerte passen ihre Schriftgröße an
die Breite an.

Co-Authored-By: Claude Fable 5.1 <noreply@anthropic.com>
Claude-Session: https://claude.ai/code/session_0118VeQCFGC8WVSdKpLNkHCn
</commit_message>
<xml_diff>
--- a/praesentationen/Gesellschafterversammlung_2026-09-23.pptx
+++ b/praesentationen/Gesellschafterversammlung_2026-09-23.pptx
@@ -117,45 +117,45 @@
   <p:extLst>
     <p:ext uri="{521415D9-36F7-43E2-AB2F-B90AF26B5E84}">
       <p14:sectionLst xmlns:p14="http://schemas.microsoft.com/office/powerpoint/2010/main">
-        <p14:section name="Einstieg" id="{a2058ac2-9a6e-f857-e92d-e41fbbcb5604}">
+        <p14:section name="Einstieg" id="{e1699406-e4d7-222f-cc5a-77e509046243}">
           <p14:sldIdLst>
             <p14:sldId id="256"/>
             <p14:sldId id="257"/>
           </p14:sldIdLst>
         </p14:section>
-        <p14:section name="TOP 1 · Kurze Zusammenfassung und IST-Zustand" id="{61b822ce-8946-2a23-6825-77aa10e1c4c1}">
+        <p14:section name="TOP 1 · Kurze Zusammenfassung und IST-Zustand" id="{fc5062d2-5e5c-a39d-14b3-9f7dcd028bd2}">
           <p14:sldIdLst>
             <p14:sldId id="258"/>
           </p14:sldIdLst>
         </p14:section>
-        <p14:section name="TOP 2 · Überblick der letzten 4 Monate" id="{2ced9060-c3c6-88c6-91aa-690330555d56}">
+        <p14:section name="TOP 2 · Überblick der letzten 4 Monate" id="{4d5fe321-9d25-bc1b-f2d3-3120543c2060}">
           <p14:sldIdLst>
             <p14:sldId id="259"/>
             <p14:sldId id="260"/>
           </p14:sldIdLst>
         </p14:section>
-        <p14:section name="TOP 3 · 80er im Detail und Zukunft Kunde MK?" id="{b4db0946-4114-6a84-2bfc-b4874b21a7a6}">
+        <p14:section name="TOP 3 · 80er im Detail und Zukunft Kunde MK?" id="{d540d21e-3d97-80b0-9138-52ad587fc4fb}">
           <p14:sldIdLst>
             <p14:sldId id="261"/>
             <p14:sldId id="262"/>
           </p14:sldIdLst>
         </p14:section>
-        <p14:section name="TOP 4 · Messeauftritt" id="{ebceccc6-994e-f041-ef8e-a00276f81307}">
+        <p14:section name="TOP 4 · Messeauftritt" id="{29066fe7-fb04-64ef-f1de-9bc3f67d07ef}">
           <p14:sldIdLst>
             <p14:sldId id="263"/>
           </p14:sldIdLst>
         </p14:section>
-        <p14:section name="TOP 5 · Forecast und Ausblick" id="{5c997ca7-aa97-1c7a-d99a-b8a8e4c769e0}">
+        <p14:section name="TOP 5 · Forecast und Ausblick" id="{ecf74539-b534-2022-4b42-dcb8750b66ca}">
           <p14:sldIdLst>
             <p14:sldId id="264"/>
           </p14:sldIdLst>
         </p14:section>
-        <p14:section name="TOP 6 · Sonstiges" id="{d295dbb3-789e-0de2-1344-c8186f9f61b4}">
+        <p14:section name="TOP 6 · Sonstiges" id="{5d4495d8-51fb-0fc5-68a3-25ce0ae95ba4}">
           <p14:sldIdLst>
             <p14:sldId id="265"/>
           </p14:sldIdLst>
         </p14:section>
-        <p14:section name="Abschluss" id="{7905478a-4b79-fec4-a1c5-df412faab88e}">
+        <p14:section name="Abschluss" id="{7d449268-ba34-b3be-5a12-3101a18a6bcc}">
           <p14:sldIdLst>
             <p14:sldId id="266"/>
           </p14:sldIdLst>
@@ -281,7 +281,7 @@
                   <c:v>412556</c:v>
                 </c:pt>
                 <c:pt idx="1">
-                  <c:v>114210</c:v>
+                  <c:v>144210</c:v>
                 </c:pt>
               </c:numCache>
             </c:numRef>
@@ -786,10 +786,10 @@
               <c:numCache>
                 <c:ptCount val="2"/>
                 <c:pt idx="0">
-                  <c:v>678993</c:v>
+                  <c:v>788473</c:v>
                 </c:pt>
                 <c:pt idx="1">
-                  <c:v>361760</c:v>
+                  <c:v>383349</c:v>
                 </c:pt>
               </c:numCache>
             </c:numRef>
@@ -798,6 +798,623 @@
         <c:firstSliceAng val="0"/>
         <c:holeSize val="60"/>
       </c:doughnutChart>
+      <c:spPr>
+        <a:noFill/>
+        <a:ln>
+          <a:noFill/>
+        </a:ln>
+        <a:effectLst/>
+      </c:spPr>
+    </c:plotArea>
+    <c:legend>
+      <c:legendPos val="b"/>
+      <c:overlay val="0"/>
+      <c:txPr>
+        <a:bodyPr/>
+        <a:lstStyle/>
+        <a:p>
+          <a:pPr>
+            <a:defRPr sz="900">
+              <a:solidFill>
+                <a:srgbClr val="6A6A6A"/>
+              </a:solidFill>
+              <a:latin typeface="Helvetica"/>
+              <a:cs typeface="Helvetica"/>
+            </a:defRPr>
+          </a:pPr>
+          <a:endParaRPr lang="en-US"/>
+        </a:p>
+      </c:txPr>
+    </c:legend>
+    <c:plotVisOnly val="1"/>
+    <c:dispBlanksAs val="span"/>
+  </c:chart>
+  <c:spPr>
+    <a:noFill/>
+    <a:ln>
+      <a:noFill/>
+    </a:ln>
+    <a:effectLst/>
+  </c:spPr>
+  <c:externalData r:id="rId1">
+    <c:autoUpdate val="0"/>
+  </c:externalData>
+</c:chartSpace>
+</file>
+
+<file path=ppt/charts/chart3.xml><?xml version="1.0" encoding="utf-8"?>
+<c:chartSpace xmlns:c="http://schemas.openxmlformats.org/drawingml/2006/chart" xmlns:a="http://schemas.openxmlformats.org/drawingml/2006/main" xmlns:r="http://schemas.openxmlformats.org/officeDocument/2006/relationships">
+  <c:date1904 val="0"/>
+  <c:roundedCorners val="1"/>
+  <c:chart>
+    <c:title>
+      <c:tx>
+        <c:rich>
+          <a:bodyPr/>
+          <a:lstStyle/>
+          <a:p>
+            <a:pPr>
+              <a:defRPr sz="1000" b="0" i="0" u="none" strike="noStrike">
+                <a:solidFill>
+                  <a:srgbClr val="6A6A6A"/>
+                </a:solidFill>
+                <a:latin typeface="Helvetica"/>
+              </a:defRPr>
+            </a:pPr>
+            <a:r>
+              <a:rPr sz="1000" b="0" i="0" u="none" strike="noStrike">
+                <a:solidFill>
+                  <a:srgbClr val="6A6A6A"/>
+                </a:solidFill>
+                <a:latin typeface="Helvetica"/>
+              </a:rPr>
+              <a:t>UMSATZ JE MONAT (€, NETTO)</a:t>
+            </a:r>
+          </a:p>
+        </c:rich>
+      </c:tx>
+      <c:layout/>
+      <c:overlay val="0"/>
+    </c:title>
+    <c:autoTitleDeleted val="0"/>
+    <c:plotArea>
+      <c:layout/>
+      <c:barChart>
+        <c:barDir val="col"/>
+        <c:grouping val="clustered"/>
+        <c:varyColors val="0"/>
+        <c:ser>
+          <c:idx val="0"/>
+          <c:order val="0"/>
+          <c:tx>
+            <c:strRef>
+              <c:f>Sheet1!$B$1</c:f>
+              <c:strCache>
+                <c:ptCount val="1"/>
+                <c:pt idx="0">
+                  <c:v>Bestätigt / fest</c:v>
+                </c:pt>
+              </c:strCache>
+            </c:strRef>
+          </c:tx>
+          <c:spPr>
+            <a:solidFill>
+              <a:srgbClr val="3D3D3D"/>
+            </a:solidFill>
+            <a:effectLst/>
+          </c:spPr>
+          <c:invertIfNegative val="0"/>
+          <c:dLbls>
+            <c:numFmt formatCode="#,##0" sourceLinked="0"/>
+            <c:txPr>
+              <a:bodyPr/>
+              <a:lstStyle/>
+              <a:p>
+                <a:pPr>
+                  <a:defRPr b="0" i="0" strike="noStrike" sz="1200" u="none">
+                    <a:solidFill>
+                      <a:srgbClr val="000000"/>
+                    </a:solidFill>
+                    <a:latin typeface="Helvetica"/>
+                  </a:defRPr>
+                </a:pPr>
+              </a:p>
+            </c:txPr>
+            <c:showLegendKey val="0"/>
+            <c:showVal val="0"/>
+            <c:showCatName val="0"/>
+            <c:showSerName val="0"/>
+            <c:showPercent val="0"/>
+            <c:showBubbleSize val="0"/>
+            <c:showLeaderLines val="0"/>
+          </c:dLbls>
+          <c:cat>
+            <c:multiLvlStrRef>
+              <c:f>Sheet1!$A$2:$A$13</c:f>
+              <c:multiLvlStrCache>
+                <c:ptCount val="12"/>
+                <c:lvl>
+                  <c:pt idx="0">
+                    <c:v>Sep 26</c:v>
+                  </c:pt>
+                  <c:pt idx="1">
+                    <c:v>Okt 26</c:v>
+                  </c:pt>
+                  <c:pt idx="2">
+                    <c:v>Nov 26</c:v>
+                  </c:pt>
+                  <c:pt idx="3">
+                    <c:v>Dez 26</c:v>
+                  </c:pt>
+                  <c:pt idx="4">
+                    <c:v>Jan 27</c:v>
+                  </c:pt>
+                  <c:pt idx="5">
+                    <c:v>Feb 27</c:v>
+                  </c:pt>
+                  <c:pt idx="6">
+                    <c:v>Mär 27</c:v>
+                  </c:pt>
+                  <c:pt idx="7">
+                    <c:v>Apr 27</c:v>
+                  </c:pt>
+                  <c:pt idx="8">
+                    <c:v>Mai 27</c:v>
+                  </c:pt>
+                  <c:pt idx="9">
+                    <c:v>Jun 27</c:v>
+                  </c:pt>
+                  <c:pt idx="10">
+                    <c:v>Jul 27</c:v>
+                  </c:pt>
+                  <c:pt idx="11">
+                    <c:v>Aug 27</c:v>
+                  </c:pt>
+                </c:lvl>
+              </c:multiLvlStrCache>
+            </c:multiLvlStrRef>
+          </c:cat>
+          <c:val>
+            <c:numRef>
+              <c:f>Sheet1!$B$2:$B$13</c:f>
+              <c:numCache>
+                <c:formatCode>General</c:formatCode>
+                <c:ptCount val="12"/>
+                <c:pt idx="0">
+                  <c:v>254446</c:v>
+                </c:pt>
+                <c:pt idx="1">
+                  <c:v>0</c:v>
+                </c:pt>
+                <c:pt idx="2">
+                  <c:v>46520</c:v>
+                </c:pt>
+                <c:pt idx="3">
+                  <c:v>0</c:v>
+                </c:pt>
+                <c:pt idx="4">
+                  <c:v>0</c:v>
+                </c:pt>
+                <c:pt idx="5">
+                  <c:v>0</c:v>
+                </c:pt>
+                <c:pt idx="6">
+                  <c:v>0</c:v>
+                </c:pt>
+                <c:pt idx="7">
+                  <c:v>0</c:v>
+                </c:pt>
+                <c:pt idx="8">
+                  <c:v>0</c:v>
+                </c:pt>
+                <c:pt idx="9">
+                  <c:v>0</c:v>
+                </c:pt>
+                <c:pt idx="10">
+                  <c:v>0</c:v>
+                </c:pt>
+                <c:pt idx="11">
+                  <c:v>0</c:v>
+                </c:pt>
+              </c:numCache>
+            </c:numRef>
+          </c:val>
+        </c:ser>
+        <c:ser>
+          <c:idx val="1"/>
+          <c:order val="1"/>
+          <c:tx>
+            <c:strRef>
+              <c:f>Sheet1!$C$1</c:f>
+              <c:strCache>
+                <c:ptCount val="1"/>
+                <c:pt idx="0">
+                  <c:v>Offen gewichtet</c:v>
+                </c:pt>
+              </c:strCache>
+            </c:strRef>
+          </c:tx>
+          <c:spPr>
+            <a:solidFill>
+              <a:srgbClr val="A8884F"/>
+            </a:solidFill>
+            <a:effectLst/>
+          </c:spPr>
+          <c:invertIfNegative val="0"/>
+          <c:dLbls>
+            <c:numFmt formatCode="#,##0" sourceLinked="0"/>
+            <c:txPr>
+              <a:bodyPr/>
+              <a:lstStyle/>
+              <a:p>
+                <a:pPr>
+                  <a:defRPr b="0" i="0" strike="noStrike" sz="1200" u="none">
+                    <a:solidFill>
+                      <a:srgbClr val="000000"/>
+                    </a:solidFill>
+                    <a:latin typeface="Helvetica"/>
+                  </a:defRPr>
+                </a:pPr>
+              </a:p>
+            </c:txPr>
+            <c:showLegendKey val="0"/>
+            <c:showVal val="0"/>
+            <c:showCatName val="0"/>
+            <c:showSerName val="0"/>
+            <c:showPercent val="0"/>
+            <c:showBubbleSize val="0"/>
+            <c:showLeaderLines val="0"/>
+          </c:dLbls>
+          <c:cat>
+            <c:multiLvlStrRef>
+              <c:f>Sheet1!$A$2:$A$13</c:f>
+              <c:multiLvlStrCache>
+                <c:ptCount val="12"/>
+                <c:lvl>
+                  <c:pt idx="0">
+                    <c:v>Sep 26</c:v>
+                  </c:pt>
+                  <c:pt idx="1">
+                    <c:v>Okt 26</c:v>
+                  </c:pt>
+                  <c:pt idx="2">
+                    <c:v>Nov 26</c:v>
+                  </c:pt>
+                  <c:pt idx="3">
+                    <c:v>Dez 26</c:v>
+                  </c:pt>
+                  <c:pt idx="4">
+                    <c:v>Jan 27</c:v>
+                  </c:pt>
+                  <c:pt idx="5">
+                    <c:v>Feb 27</c:v>
+                  </c:pt>
+                  <c:pt idx="6">
+                    <c:v>Mär 27</c:v>
+                  </c:pt>
+                  <c:pt idx="7">
+                    <c:v>Apr 27</c:v>
+                  </c:pt>
+                  <c:pt idx="8">
+                    <c:v>Mai 27</c:v>
+                  </c:pt>
+                  <c:pt idx="9">
+                    <c:v>Jun 27</c:v>
+                  </c:pt>
+                  <c:pt idx="10">
+                    <c:v>Jul 27</c:v>
+                  </c:pt>
+                  <c:pt idx="11">
+                    <c:v>Aug 27</c:v>
+                  </c:pt>
+                </c:lvl>
+              </c:multiLvlStrCache>
+            </c:multiLvlStrRef>
+          </c:cat>
+          <c:val>
+            <c:numRef>
+              <c:f>Sheet1!$C$2:$C$13</c:f>
+              <c:numCache>
+                <c:formatCode>General</c:formatCode>
+                <c:ptCount val="12"/>
+                <c:pt idx="0">
+                  <c:v>0</c:v>
+                </c:pt>
+                <c:pt idx="1">
+                  <c:v>130449</c:v>
+                </c:pt>
+                <c:pt idx="2">
+                  <c:v>141174</c:v>
+                </c:pt>
+                <c:pt idx="3">
+                  <c:v>57217</c:v>
+                </c:pt>
+                <c:pt idx="4">
+                  <c:v>4625</c:v>
+                </c:pt>
+                <c:pt idx="5">
+                  <c:v>2165</c:v>
+                </c:pt>
+                <c:pt idx="6">
+                  <c:v>11910</c:v>
+                </c:pt>
+                <c:pt idx="7">
+                  <c:v>98147</c:v>
+                </c:pt>
+                <c:pt idx="8">
+                  <c:v>0</c:v>
+                </c:pt>
+                <c:pt idx="9">
+                  <c:v>318263</c:v>
+                </c:pt>
+                <c:pt idx="10">
+                  <c:v>193185</c:v>
+                </c:pt>
+                <c:pt idx="11">
+                  <c:v>0</c:v>
+                </c:pt>
+              </c:numCache>
+            </c:numRef>
+          </c:val>
+        </c:ser>
+        <c:ser>
+          <c:idx val="2"/>
+          <c:order val="2"/>
+          <c:tx>
+            <c:strRef>
+              <c:f>Sheet1!$D$1</c:f>
+              <c:strCache>
+                <c:ptCount val="1"/>
+                <c:pt idx="0">
+                  <c:v>Abgerechnet</c:v>
+                </c:pt>
+              </c:strCache>
+            </c:strRef>
+          </c:tx>
+          <c:spPr>
+            <a:solidFill>
+              <a:srgbClr val="C8C8C8"/>
+            </a:solidFill>
+            <a:effectLst/>
+          </c:spPr>
+          <c:invertIfNegative val="0"/>
+          <c:dLbls>
+            <c:numFmt formatCode="#,##0" sourceLinked="0"/>
+            <c:txPr>
+              <a:bodyPr/>
+              <a:lstStyle/>
+              <a:p>
+                <a:pPr>
+                  <a:defRPr b="0" i="0" strike="noStrike" sz="1200" u="none">
+                    <a:solidFill>
+                      <a:srgbClr val="000000"/>
+                    </a:solidFill>
+                    <a:latin typeface="Helvetica"/>
+                  </a:defRPr>
+                </a:pPr>
+              </a:p>
+            </c:txPr>
+            <c:showLegendKey val="0"/>
+            <c:showVal val="0"/>
+            <c:showCatName val="0"/>
+            <c:showSerName val="0"/>
+            <c:showPercent val="0"/>
+            <c:showBubbleSize val="0"/>
+            <c:showLeaderLines val="0"/>
+          </c:dLbls>
+          <c:cat>
+            <c:multiLvlStrRef>
+              <c:f>Sheet1!$A$2:$A$13</c:f>
+              <c:multiLvlStrCache>
+                <c:ptCount val="12"/>
+                <c:lvl>
+                  <c:pt idx="0">
+                    <c:v>Sep 26</c:v>
+                  </c:pt>
+                  <c:pt idx="1">
+                    <c:v>Okt 26</c:v>
+                  </c:pt>
+                  <c:pt idx="2">
+                    <c:v>Nov 26</c:v>
+                  </c:pt>
+                  <c:pt idx="3">
+                    <c:v>Dez 26</c:v>
+                  </c:pt>
+                  <c:pt idx="4">
+                    <c:v>Jan 27</c:v>
+                  </c:pt>
+                  <c:pt idx="5">
+                    <c:v>Feb 27</c:v>
+                  </c:pt>
+                  <c:pt idx="6">
+                    <c:v>Mär 27</c:v>
+                  </c:pt>
+                  <c:pt idx="7">
+                    <c:v>Apr 27</c:v>
+                  </c:pt>
+                  <c:pt idx="8">
+                    <c:v>Mai 27</c:v>
+                  </c:pt>
+                  <c:pt idx="9">
+                    <c:v>Jun 27</c:v>
+                  </c:pt>
+                  <c:pt idx="10">
+                    <c:v>Jul 27</c:v>
+                  </c:pt>
+                  <c:pt idx="11">
+                    <c:v>Aug 27</c:v>
+                  </c:pt>
+                </c:lvl>
+              </c:multiLvlStrCache>
+            </c:multiLvlStrRef>
+          </c:cat>
+          <c:val>
+            <c:numRef>
+              <c:f>Sheet1!$D$2:$D$13</c:f>
+              <c:numCache>
+                <c:formatCode>General</c:formatCode>
+                <c:ptCount val="12"/>
+                <c:pt idx="0">
+                  <c:v>45738</c:v>
+                </c:pt>
+                <c:pt idx="1">
+                  <c:v>0</c:v>
+                </c:pt>
+                <c:pt idx="2">
+                  <c:v>0</c:v>
+                </c:pt>
+                <c:pt idx="3">
+                  <c:v>0</c:v>
+                </c:pt>
+                <c:pt idx="4">
+                  <c:v>0</c:v>
+                </c:pt>
+                <c:pt idx="5">
+                  <c:v>0</c:v>
+                </c:pt>
+                <c:pt idx="6">
+                  <c:v>0</c:v>
+                </c:pt>
+                <c:pt idx="7">
+                  <c:v>0</c:v>
+                </c:pt>
+                <c:pt idx="8">
+                  <c:v>0</c:v>
+                </c:pt>
+                <c:pt idx="9">
+                  <c:v>0</c:v>
+                </c:pt>
+                <c:pt idx="10">
+                  <c:v>0</c:v>
+                </c:pt>
+                <c:pt idx="11">
+                  <c:v>0</c:v>
+                </c:pt>
+              </c:numCache>
+            </c:numRef>
+          </c:val>
+        </c:ser>
+        <c:dLbls>
+          <c:numFmt formatCode="#,##0" sourceLinked="0"/>
+          <c:txPr>
+            <a:bodyPr/>
+            <a:lstStyle/>
+            <a:p>
+              <a:pPr>
+                <a:defRPr b="0" i="0" strike="noStrike" sz="1200" u="none">
+                  <a:solidFill>
+                    <a:srgbClr val="000000"/>
+                  </a:solidFill>
+                  <a:latin typeface="Helvetica"/>
+                </a:defRPr>
+              </a:pPr>
+            </a:p>
+          </c:txPr>
+          <c:showLegendKey val="0"/>
+          <c:showVal val="0"/>
+          <c:showCatName val="0"/>
+          <c:showSerName val="0"/>
+          <c:showPercent val="0"/>
+          <c:showBubbleSize val="0"/>
+          <c:showLeaderLines val="0"/>
+        </c:dLbls>
+        <c:gapWidth val="50"/>
+        <c:overlap val="0"/>
+        <c:axId val="2094734554"/>
+        <c:axId val="2094734552"/>
+        <c:axId val="2094734556"/>
+      </c:barChart>
+      <c:catAx>
+        <c:axId val="2094734554"/>
+        <c:scaling>
+          <c:orientation val="minMax"/>
+        </c:scaling>
+        <c:delete val="0"/>
+        <c:axPos val="b"/>
+        <c:numFmt formatCode="General" sourceLinked="1"/>
+        <c:majorTickMark val="out"/>
+        <c:minorTickMark val="none"/>
+        <c:tickLblPos val="low"/>
+        <c:spPr>
+          <a:ln w="12700" cap="flat">
+            <a:solidFill>
+              <a:srgbClr val="E4E1DB"/>
+            </a:solidFill>
+            <a:prstDash val="solid"/>
+            <a:round/>
+          </a:ln>
+        </c:spPr>
+        <c:txPr>
+          <a:bodyPr/>
+          <a:lstStyle/>
+          <a:p>
+            <a:pPr>
+              <a:defRPr sz="900" b="0" i="0" u="none" strike="noStrike">
+                <a:solidFill>
+                  <a:srgbClr val="6A6A6A"/>
+                </a:solidFill>
+                <a:latin typeface="Helvetica"/>
+              </a:defRPr>
+            </a:pPr>
+            <a:endParaRPr lang="en-US"/>
+          </a:p>
+        </c:txPr>
+        <c:crossAx val="2094734552"/>
+        <c:crosses val="autoZero"/>
+        <c:auto val="1"/>
+        <c:lblAlgn val="ctr"/>
+        <c:noMultiLvlLbl val="1"/>
+      </c:catAx>
+      <c:valAx>
+        <c:axId val="2094734552"/>
+        <c:scaling>
+          <c:orientation val="minMax"/>
+        </c:scaling>
+        <c:delete val="0"/>
+        <c:axPos val="l"/>
+        <c:majorGridlines>
+          <c:spPr>
+            <a:ln w="6350" cap="flat">
+              <a:solidFill>
+                <a:srgbClr val="EFECE7"/>
+              </a:solidFill>
+              <a:prstDash val="solid"/>
+              <a:round/>
+            </a:ln>
+          </c:spPr>
+        </c:majorGridlines>
+        <c:numFmt formatCode="#,##0" sourceLinked="0"/>
+        <c:majorTickMark val="out"/>
+        <c:minorTickMark val="none"/>
+        <c:tickLblPos val="nextTo"/>
+        <c:spPr>
+          <a:ln w="12700" cap="flat">
+            <a:solidFill>
+              <a:srgbClr val="E4E1DB"/>
+            </a:solidFill>
+            <a:prstDash val="solid"/>
+            <a:round/>
+          </a:ln>
+        </c:spPr>
+        <c:txPr>
+          <a:bodyPr/>
+          <a:lstStyle/>
+          <a:p>
+            <a:pPr>
+              <a:defRPr sz="800" b="0" i="0" u="none" strike="noStrike">
+                <a:solidFill>
+                  <a:srgbClr val="6A6A6A"/>
+                </a:solidFill>
+                <a:latin typeface="Helvetica"/>
+              </a:defRPr>
+            </a:pPr>
+            <a:endParaRPr lang="en-US"/>
+          </a:p>
+        </c:txPr>
+        <c:crossAx val="2094734554"/>
+        <c:crosses val="autoZero"/>
+        <c:crossBetween val="between"/>
+      </c:valAx>
       <c:spPr>
         <a:noFill/>
         <a:ln>
@@ -1853,7 +2470,7 @@
           <a:p>
             <a:r>
               <a:rPr lang="en-US" dirty="0"/>
-              <a:t>TOP 3 – Deal-Auswertung aus der Nova Works App (Auswertung → Deal-Auswertung), Stand 07.08.2026. Nova-Works-Umsatz = bestätigte Projektsumme, Partnerumsätze CGS/TCLG manuell erfasst, Kosten (NW) aus der Kostenkontrolle.</a:t>
+              <a:t>TOP 3 – Deal-Auswertung aus der Nova Works App (Auswertung → Deal-Auswertung), Stand 18.09.2026. Nova-Works-Umsatz = bestätigte Projektsumme, Partnerumsätze CGS/TCLG manuell erfasst, Kosten (NW) aus der Kostenkontrolle, Auszahlungen an Partner aus dem Kostensplit.</a:t>
             </a:r>
             <a:endParaRPr lang="en-US" dirty="0"/>
           </a:p>
@@ -1941,7 +2558,7 @@
           <a:p>
             <a:r>
               <a:rPr lang="en-US" dirty="0"/>
-              <a:t>TOP 3 – Rechnungsstand aus der Deal-Auswertung (Stand 07.08.2026). Diskussionspunkte zur Zukunft mit dem Kunden.</a:t>
+              <a:t>TOP 3 – Rechnungsstand aus der Deal-Auswertung (Stand 18.09.2026). Diskussionspunkte zur Zukunft mit dem Kunden.</a:t>
             </a:r>
             <a:endParaRPr lang="en-US" dirty="0"/>
           </a:p>
@@ -2117,7 +2734,7 @@
           <a:p>
             <a:r>
               <a:rPr lang="en-US" dirty="0"/>
-              <a:t>TOP 5 – Forecast und Ausblick. Zahlen aus Nova Works App → Forecast; dort PowerPoint-Export nutzen oder Werte in FORECAST im Build-Skript eintragen.</a:t>
+              <a:t>TOP 5 – Forecast und Ausblick. Zahlen aus Nova Works App → Forecast (Standard „nächste 12 Monate“, dazu Kalenderjahr 2026 und 2027), berechnet aus der Datensicherung vom 18.09.2026.</a:t>
             </a:r>
             <a:endParaRPr lang="en-US" dirty="0"/>
           </a:p>
@@ -5958,7 +6575,7 @@
                 <a:ea typeface="Helvetica" pitchFamily="34" charset="-122"/>
                 <a:cs typeface="Helvetica" pitchFamily="34" charset="-120"/>
               </a:rPr>
-              <a:t>Gesamt Nova Works · Auswertung der bestätigten Projekte · alle Beträge netto</a:t>
+              <a:t>Gesamt Nova Works · Auswertung der bestätigten Projekte · Stand 18.09.2026 · alle Beträge netto</a:t>
             </a:r>
             <a:endParaRPr lang="en-US" sz="1250" dirty="0"/>
           </a:p>
@@ -5997,7 +6614,7 @@
                 <a:ea typeface="Helvetica" pitchFamily="34" charset="-122"/>
                 <a:cs typeface="Helvetica" pitchFamily="34" charset="-120"/>
               </a:rPr>
-              <a:t>SUMME BESTÄTIGT</a:t>
+              <a:t>SUMME BESTÄTIGT · 19 PROJEKTE</a:t>
             </a:r>
             <a:endParaRPr lang="en-US" sz="900" dirty="0"/>
           </a:p>
@@ -6101,7 +6718,7 @@
               <a:buNone/>
             </a:pPr>
             <a:r>
-              <a:rPr lang="en-US" sz="2200" b="1" dirty="0">
+              <a:rPr lang="en-US" sz="1800" b="1" dirty="0">
                 <a:solidFill>
                   <a:srgbClr val="3D3D3D"/>
                 </a:solidFill>
@@ -6109,9 +6726,9 @@
                 <a:ea typeface="Helvetica" pitchFamily="34" charset="-122"/>
                 <a:cs typeface="Helvetica" pitchFamily="34" charset="-120"/>
               </a:rPr>
-              <a:t>–</a:t>
-            </a:r>
-            <a:endParaRPr lang="en-US" sz="2200" dirty="0"/>
+              <a:t>1.704.057 €</a:t>
+            </a:r>
+            <a:endParaRPr lang="en-US" sz="1800" dirty="0"/>
           </a:p>
         </p:txBody>
       </p:sp>
@@ -6252,7 +6869,7 @@
               <a:buNone/>
             </a:pPr>
             <a:r>
-              <a:rPr lang="en-US" sz="2200" b="1" dirty="0">
+              <a:rPr lang="en-US" sz="1800" b="1" dirty="0">
                 <a:solidFill>
                   <a:srgbClr val="5A7D52"/>
                 </a:solidFill>
@@ -6260,9 +6877,9 @@
                 <a:ea typeface="Helvetica" pitchFamily="34" charset="-122"/>
                 <a:cs typeface="Helvetica" pitchFamily="34" charset="-120"/>
               </a:rPr>
-              <a:t>–</a:t>
-            </a:r>
-            <a:endParaRPr lang="en-US" sz="2200" dirty="0"/>
+              <a:t>1.814.727 €</a:t>
+            </a:r>
+            <a:endParaRPr lang="en-US" sz="1800" dirty="0"/>
           </a:p>
         </p:txBody>
       </p:sp>
@@ -6403,7 +7020,7 @@
               <a:buNone/>
             </a:pPr>
             <a:r>
-              <a:rPr lang="en-US" sz="2200" b="1" dirty="0">
+              <a:rPr lang="en-US" sz="1800" b="1" dirty="0">
                 <a:solidFill>
                   <a:srgbClr val="3D3D3D"/>
                 </a:solidFill>
@@ -6411,9 +7028,9 @@
                 <a:ea typeface="Helvetica" pitchFamily="34" charset="-122"/>
                 <a:cs typeface="Helvetica" pitchFamily="34" charset="-120"/>
               </a:rPr>
-              <a:t>–</a:t>
-            </a:r>
-            <a:endParaRPr lang="en-US" sz="2200" dirty="0"/>
+              <a:t>1.572.556 €</a:t>
+            </a:r>
+            <a:endParaRPr lang="en-US" sz="1800" dirty="0"/>
           </a:p>
         </p:txBody>
       </p:sp>
@@ -6554,7 +7171,7 @@
               <a:buNone/>
             </a:pPr>
             <a:r>
-              <a:rPr lang="en-US" sz="2200" b="1" dirty="0">
+              <a:rPr lang="en-US" sz="1800" b="1" dirty="0">
                 <a:solidFill>
                   <a:srgbClr val="3D3D3D"/>
                 </a:solidFill>
@@ -6562,9 +7179,9 @@
                 <a:ea typeface="Helvetica" pitchFamily="34" charset="-122"/>
                 <a:cs typeface="Helvetica" pitchFamily="34" charset="-120"/>
               </a:rPr>
-              <a:t>–</a:t>
-            </a:r>
-            <a:endParaRPr lang="en-US" sz="2200" dirty="0"/>
+              <a:t>1.530.115 €</a:t>
+            </a:r>
+            <a:endParaRPr lang="en-US" sz="1800" dirty="0"/>
           </a:p>
         </p:txBody>
       </p:sp>
@@ -6705,7 +7322,7 @@
               <a:buNone/>
             </a:pPr>
             <a:r>
-              <a:rPr lang="en-US" sz="2200" b="1" dirty="0">
+              <a:rPr lang="en-US" sz="1900" b="1" dirty="0">
                 <a:solidFill>
                   <a:srgbClr val="5A7D52"/>
                 </a:solidFill>
@@ -6713,9 +7330,9 @@
                 <a:ea typeface="Helvetica" pitchFamily="34" charset="-122"/>
                 <a:cs typeface="Helvetica" pitchFamily="34" charset="-120"/>
               </a:rPr>
-              <a:t>–</a:t>
-            </a:r>
-            <a:endParaRPr lang="en-US" sz="2200" dirty="0"/>
+              <a:t>-123.644 €</a:t>
+            </a:r>
+            <a:endParaRPr lang="en-US" sz="1900" dirty="0"/>
           </a:p>
         </p:txBody>
       </p:sp>
@@ -6752,7 +7369,7 @@
                 <a:ea typeface="Helvetica" pitchFamily="34" charset="-122"/>
                 <a:cs typeface="Helvetica" pitchFamily="34" charset="-120"/>
               </a:rPr>
-              <a:t>Budget − geplante Kosten (Kalkulations-Soll)</a:t>
+              <a:t>-7 % · Budget − geplante Kosten</a:t>
             </a:r>
             <a:endParaRPr lang="en-US" sz="950" dirty="0"/>
           </a:p>
@@ -6856,7 +7473,7 @@
               <a:buNone/>
             </a:pPr>
             <a:r>
-              <a:rPr lang="en-US" sz="2200" b="1" dirty="0">
+              <a:rPr lang="en-US" sz="2100" b="1" dirty="0">
                 <a:solidFill>
                   <a:srgbClr val="5A7D52"/>
                 </a:solidFill>
@@ -6864,9 +7481,9 @@
                 <a:ea typeface="Helvetica" pitchFamily="34" charset="-122"/>
                 <a:cs typeface="Helvetica" pitchFamily="34" charset="-120"/>
               </a:rPr>
-              <a:t>–</a:t>
-            </a:r>
-            <a:endParaRPr lang="en-US" sz="2200" dirty="0"/>
+              <a:t>281.412 €</a:t>
+            </a:r>
+            <a:endParaRPr lang="en-US" sz="2100" dirty="0"/>
           </a:p>
         </p:txBody>
       </p:sp>
@@ -6903,7 +7520,7 @@
                 <a:ea typeface="Helvetica" pitchFamily="34" charset="-122"/>
                 <a:cs typeface="Helvetica" pitchFamily="34" charset="-120"/>
               </a:rPr>
-              <a:t>Budget − Kosten Ist</a:t>
+              <a:t>16 % · Budget − Kosten Ist</a:t>
             </a:r>
             <a:endParaRPr lang="en-US" sz="950" dirty="0"/>
           </a:p>
@@ -7007,7 +7624,7 @@
               <a:buNone/>
             </a:pPr>
             <a:r>
-              <a:rPr lang="en-US" sz="2200" b="1" dirty="0">
+              <a:rPr lang="en-US" sz="1800" b="1" dirty="0">
                 <a:solidFill>
                   <a:srgbClr val="3D3D3D"/>
                 </a:solidFill>
@@ -7015,9 +7632,9 @@
                 <a:ea typeface="Helvetica" pitchFamily="34" charset="-122"/>
                 <a:cs typeface="Helvetica" pitchFamily="34" charset="-120"/>
               </a:rPr>
-              <a:t>–</a:t>
-            </a:r>
-            <a:endParaRPr lang="en-US" sz="2200" dirty="0"/>
+              <a:t>1.536.144 €</a:t>
+            </a:r>
+            <a:endParaRPr lang="en-US" sz="1800" dirty="0"/>
           </a:p>
         </p:txBody>
       </p:sp>
@@ -7158,7 +7775,7 @@
               <a:buNone/>
             </a:pPr>
             <a:r>
-              <a:rPr lang="en-US" sz="2200" b="1" dirty="0">
+              <a:rPr lang="en-US" sz="2100" b="1" dirty="0">
                 <a:solidFill>
                   <a:srgbClr val="A8884F"/>
                 </a:solidFill>
@@ -7166,9 +7783,9 @@
                 <a:ea typeface="Helvetica" pitchFamily="34" charset="-122"/>
                 <a:cs typeface="Helvetica" pitchFamily="34" charset="-120"/>
               </a:rPr>
-              <a:t>–</a:t>
-            </a:r>
-            <a:endParaRPr lang="en-US" sz="2200" dirty="0"/>
+              <a:t>242.170 €</a:t>
+            </a:r>
+            <a:endParaRPr lang="en-US" sz="2100" dirty="0"/>
           </a:p>
         </p:txBody>
       </p:sp>
@@ -7213,46 +7830,7 @@
       </p:sp>
       <p:sp>
         <p:nvSpPr>
-          <p:cNvPr id="42" name="Text 39"/>
-          <p:cNvSpPr txBox="1"/>
-          <p:nvPr/>
-        </p:nvSpPr>
-        <p:spPr>
-          <a:xfrm>
-            <a:off x="548640" y="4892040"/>
-            <a:ext cx="7498080" cy="365760"/>
-          </a:xfrm>
-          <a:prstGeom prst="rect">
-            <a:avLst/>
-          </a:prstGeom>
-          <a:noFill/>
-          <a:ln/>
-        </p:spPr>
-        <p:txBody>
-          <a:bodyPr wrap="square" lIns="0" tIns="0" rIns="0" bIns="0" rtlCol="0" anchor="ctr"/>
-          <a:lstStyle/>
-          <a:p>
-            <a:pPr indent="0" marL="0">
-              <a:buNone/>
-            </a:pPr>
-            <a:r>
-              <a:rPr lang="en-US" sz="1000" i="1" dirty="0">
-                <a:solidFill>
-                  <a:srgbClr val="C7AB78"/>
-                </a:solidFill>
-                <a:latin typeface="Helvetica" pitchFamily="34" charset="0"/>
-                <a:ea typeface="Helvetica" pitchFamily="34" charset="-122"/>
-                <a:cs typeface="Helvetica" pitchFamily="34" charset="-120"/>
-              </a:rPr>
-              <a:t>Zahlen folgen aus der Nova Works App (Auswertung → Zeile „Summe Bestätigt“).</a:t>
-            </a:r>
-            <a:endParaRPr lang="en-US" sz="1000" dirty="0"/>
-          </a:p>
-        </p:txBody>
-      </p:sp>
-      <p:sp>
-        <p:nvSpPr>
-          <p:cNvPr id="43" name="Shape 40"/>
+          <p:cNvPr id="42" name="Shape 39"/>
           <p:cNvSpPr/>
           <p:nvPr/>
         </p:nvSpPr>
@@ -7286,7 +7864,7 @@
       </p:sp>
       <p:sp>
         <p:nvSpPr>
-          <p:cNvPr id="44" name="Text 41"/>
+          <p:cNvPr id="43" name="Text 40"/>
           <p:cNvSpPr txBox="1"/>
           <p:nvPr/>
         </p:nvSpPr>
@@ -7325,7 +7903,7 @@
       </p:sp>
       <p:sp>
         <p:nvSpPr>
-          <p:cNvPr id="45" name="Text 42"/>
+          <p:cNvPr id="44" name="Text 41"/>
           <p:cNvSpPr txBox="1"/>
           <p:nvPr/>
         </p:nvSpPr>
@@ -7452,7 +8030,7 @@
       </p:sp>
       <p:sp>
         <p:nvSpPr>
-          <p:cNvPr id="46" name="Text 43"/>
+          <p:cNvPr id="45" name="Text 42"/>
           <p:cNvSpPr txBox="1"/>
           <p:nvPr/>
         </p:nvSpPr>
@@ -11176,7 +11754,7 @@
                 <a:ea typeface="Helvetica" pitchFamily="34" charset="-122"/>
                 <a:cs typeface="Helvetica" pitchFamily="34" charset="-120"/>
               </a:rPr>
-              <a:t>Deal-Auswertung ProEvent 2026 · Stand 07.08.2026 · alle Beträge netto</a:t>
+              <a:t>Deal-Auswertung ProEvent 2026 · Stand 18.09.2026 · alle Beträge netto</a:t>
             </a:r>
             <a:endParaRPr lang="en-US" sz="1250" dirty="0"/>
           </a:p>
@@ -11920,7 +12498,7 @@
                           <a:ea typeface="Helvetica" pitchFamily="34" charset="-122"/>
                           <a:cs typeface="Helvetica" pitchFamily="34" charset="-120"/>
                         </a:rPr>
-                        <a:t>79 %</a:t>
+                        <a:t>77 %</a:t>
                       </a:r>
                       <a:endParaRPr lang="en-US" sz="1000" dirty="0">
                         <a:latin typeface="Helvetica" charset="0"/>
@@ -11967,7 +12545,7 @@
                           <a:ea typeface="Helvetica" pitchFamily="34" charset="-122"/>
                           <a:cs typeface="Helvetica" pitchFamily="34" charset="-120"/>
                         </a:rPr>
-                        <a:t>151.483 €</a:t>
+                        <a:t>458.040 €</a:t>
                       </a:r>
                       <a:endParaRPr lang="en-US" sz="1000" dirty="0">
                         <a:latin typeface="Helvetica" charset="0"/>
@@ -12014,7 +12592,7 @@
                           <a:ea typeface="Helvetica" pitchFamily="34" charset="-122"/>
                           <a:cs typeface="Helvetica" pitchFamily="34" charset="-120"/>
                         </a:rPr>
-                        <a:t>741.073 €</a:t>
+                        <a:t>434.516 €</a:t>
                       </a:r>
                       <a:endParaRPr lang="en-US" sz="1000" dirty="0">
                         <a:latin typeface="Helvetica" charset="0"/>
@@ -12055,13 +12633,13 @@
                       <a:r>
                         <a:rPr lang="en-US" sz="1000" b="1" dirty="0">
                           <a:solidFill>
-                            <a:srgbClr val="5A7D52"/>
+                            <a:srgbClr val="B4493F"/>
                           </a:solidFill>
                           <a:latin typeface="Helvetica" pitchFamily="34" charset="0"/>
                           <a:ea typeface="Helvetica" pitchFamily="34" charset="-122"/>
                           <a:cs typeface="Helvetica" pitchFamily="34" charset="-120"/>
                         </a:rPr>
-                        <a:t>261.073 €</a:t>
+                        <a:t>-45.484 €</a:t>
                       </a:r>
                       <a:endParaRPr lang="en-US" sz="1000" dirty="0">
                         <a:latin typeface="Helvetica" charset="0"/>
@@ -12157,7 +12735,7 @@
                           <a:ea typeface="Helvetica" pitchFamily="34" charset="-122"/>
                           <a:cs typeface="Helvetica" pitchFamily="34" charset="-120"/>
                         </a:rPr>
-                        <a:t>114.210 €</a:t>
+                        <a:t>144.210 €</a:t>
                       </a:r>
                       <a:endParaRPr lang="en-US" sz="1000" dirty="0">
                         <a:latin typeface="Helvetica" charset="0"/>
@@ -12298,7 +12876,7 @@
                           <a:ea typeface="Helvetica" pitchFamily="34" charset="-122"/>
                           <a:cs typeface="Helvetica" pitchFamily="34" charset="-120"/>
                         </a:rPr>
-                        <a:t>234.210 €</a:t>
+                        <a:t>264.210 €</a:t>
                       </a:r>
                       <a:endParaRPr lang="en-US" sz="1000" dirty="0">
                         <a:latin typeface="Helvetica" charset="0"/>
@@ -12345,7 +12923,7 @@
                           <a:ea typeface="Helvetica" pitchFamily="34" charset="-122"/>
                           <a:cs typeface="Helvetica" pitchFamily="34" charset="-120"/>
                         </a:rPr>
-                        <a:t>21 %</a:t>
+                        <a:t>23 %</a:t>
                       </a:r>
                       <a:endParaRPr lang="en-US" sz="1000" dirty="0">
                         <a:latin typeface="Helvetica" charset="0"/>
@@ -12439,7 +13017,7 @@
                           <a:ea typeface="Helvetica" pitchFamily="34" charset="-122"/>
                           <a:cs typeface="Helvetica" pitchFamily="34" charset="-120"/>
                         </a:rPr>
-                        <a:t>77.096 €</a:t>
+                        <a:t>107.096 €</a:t>
                       </a:r>
                       <a:endParaRPr lang="en-US" sz="1000" dirty="0">
                         <a:latin typeface="Helvetica" charset="0"/>
@@ -12486,7 +13064,7 @@
                           <a:ea typeface="Helvetica" pitchFamily="34" charset="-122"/>
                           <a:cs typeface="Helvetica" pitchFamily="34" charset="-120"/>
                         </a:rPr>
-                        <a:t>-42.904 €</a:t>
+                        <a:t>-12.904 €</a:t>
                       </a:r>
                       <a:endParaRPr lang="en-US" sz="1000" dirty="0">
                         <a:latin typeface="Helvetica" charset="0"/>
@@ -12582,7 +13160,7 @@
                           <a:ea typeface="Helvetica" pitchFamily="34" charset="-122"/>
                           <a:cs typeface="Helvetica" pitchFamily="34" charset="-120"/>
                         </a:rPr>
-                        <a:t>526.766 €</a:t>
+                        <a:t>556.766 €</a:t>
                       </a:r>
                       <a:endParaRPr lang="en-US" sz="1000" dirty="0">
                         <a:latin typeface="Helvetica" charset="0"/>
@@ -12723,7 +13301,7 @@
                           <a:ea typeface="Helvetica" pitchFamily="34" charset="-122"/>
                           <a:cs typeface="Helvetica" pitchFamily="34" charset="-120"/>
                         </a:rPr>
-                        <a:t>1.126.766 €</a:t>
+                        <a:t>1.156.766 €</a:t>
                       </a:r>
                       <a:endParaRPr lang="en-US" sz="1000" dirty="0">
                         <a:latin typeface="Helvetica" charset="0"/>
@@ -12806,7 +13384,7 @@
                           <a:ea typeface="Helvetica" pitchFamily="34" charset="-122"/>
                           <a:cs typeface="Helvetica" pitchFamily="34" charset="-120"/>
                         </a:rPr>
-                        <a:t>308.597 €</a:t>
+                        <a:t>615.154 €</a:t>
                       </a:r>
                       <a:endParaRPr lang="en-US" sz="1000" dirty="0">
                         <a:latin typeface="Helvetica" charset="0"/>
@@ -12853,7 +13431,7 @@
                           <a:ea typeface="Helvetica" pitchFamily="34" charset="-122"/>
                           <a:cs typeface="Helvetica" pitchFamily="34" charset="-120"/>
                         </a:rPr>
-                        <a:t>818.169 €</a:t>
+                        <a:t>541.612 €</a:t>
                       </a:r>
                       <a:endParaRPr lang="en-US" sz="1000" dirty="0">
                         <a:latin typeface="Helvetica" charset="0"/>
@@ -12894,13 +13472,13 @@
                       <a:r>
                         <a:rPr lang="en-US" sz="1000" b="1" dirty="0">
                           <a:solidFill>
-                            <a:srgbClr val="5A7D52"/>
+                            <a:srgbClr val="B4493F"/>
                           </a:solidFill>
                           <a:latin typeface="Helvetica" pitchFamily="34" charset="0"/>
                           <a:ea typeface="Helvetica" pitchFamily="34" charset="-122"/>
                           <a:cs typeface="Helvetica" pitchFamily="34" charset="-120"/>
                         </a:rPr>
-                        <a:t>218.169 €</a:t>
+                        <a:t>-58.388 €</a:t>
                       </a:r>
                       <a:endParaRPr lang="en-US" sz="1000" dirty="0">
                         <a:latin typeface="Helvetica" charset="0"/>
@@ -12996,7 +13574,7 @@
                           <a:ea typeface="Helvetica" pitchFamily="34" charset="-122"/>
                           <a:cs typeface="Helvetica" pitchFamily="34" charset="-120"/>
                         </a:rPr>
-                        <a:t>47 %</a:t>
+                        <a:t>48 %</a:t>
                       </a:r>
                       <a:endParaRPr lang="en-US" sz="900" dirty="0">
                         <a:latin typeface="Helvetica" charset="0"/>
@@ -13043,7 +13621,7 @@
                           <a:ea typeface="Helvetica" pitchFamily="34" charset="-122"/>
                           <a:cs typeface="Helvetica" pitchFamily="34" charset="-120"/>
                         </a:rPr>
-                        <a:t>27 %</a:t>
+                        <a:t>26 %</a:t>
                       </a:r>
                       <a:endParaRPr lang="en-US" sz="900" dirty="0">
                         <a:latin typeface="Helvetica" charset="0"/>
@@ -13090,7 +13668,7 @@
                           <a:ea typeface="Helvetica" pitchFamily="34" charset="-122"/>
                           <a:cs typeface="Helvetica" pitchFamily="34" charset="-120"/>
                         </a:rPr>
-                        <a:t>27 %</a:t>
+                        <a:t>26 %</a:t>
                       </a:r>
                       <a:endParaRPr lang="en-US" sz="900" dirty="0">
                         <a:latin typeface="Helvetica" charset="0"/>
@@ -13330,11 +13908,11 @@
         <p:spPr>
           <a:xfrm>
             <a:off x="6583680" y="3794760"/>
-            <a:ext cx="2423160" cy="1234440"/>
+            <a:ext cx="5056632" cy="2286000"/>
           </a:xfrm>
           <a:prstGeom prst="roundRect">
             <a:avLst>
-              <a:gd name="adj" fmla="val 8889"/>
+              <a:gd name="adj" fmla="val 4800"/>
             </a:avLst>
           </a:prstGeom>
           <a:solidFill>
@@ -13363,8 +13941,8 @@
         </p:nvSpPr>
         <p:spPr>
           <a:xfrm>
-            <a:off x="6812280" y="3959352"/>
-            <a:ext cx="1965960" cy="256032"/>
+            <a:off x="6812280" y="3931920"/>
+            <a:ext cx="4572000" cy="256032"/>
           </a:xfrm>
           <a:prstGeom prst="rect">
             <a:avLst/>
@@ -13388,7 +13966,7 @@
                 <a:ea typeface="Helvetica" pitchFamily="34" charset="-122"/>
                 <a:cs typeface="Helvetica" pitchFamily="34" charset="-120"/>
               </a:rPr>
-              <a:t>UMSATZ NOVA WORKS</a:t>
+              <a:t>KOSTENSPLIT · NETTO</a:t>
             </a:r>
             <a:endParaRPr lang="en-US" sz="900" dirty="0"/>
           </a:p>
@@ -13402,8 +13980,8 @@
         </p:nvSpPr>
         <p:spPr>
           <a:xfrm>
-            <a:off x="6812280" y="4206240"/>
-            <a:ext cx="1965960" cy="457200"/>
+            <a:off x="6812280" y="4251960"/>
+            <a:ext cx="2926080" cy="292608"/>
           </a:xfrm>
           <a:prstGeom prst="rect">
             <a:avLst/>
@@ -13419,7 +13997,7 @@
               <a:buNone/>
             </a:pPr>
             <a:r>
-              <a:rPr lang="en-US" sz="2200" b="1" dirty="0">
+              <a:rPr lang="en-US" sz="1100" dirty="0">
                 <a:solidFill>
                   <a:srgbClr val="3D3D3D"/>
                 </a:solidFill>
@@ -13427,9 +14005,9 @@
                 <a:ea typeface="Helvetica" pitchFamily="34" charset="-122"/>
                 <a:cs typeface="Helvetica" pitchFamily="34" charset="-120"/>
               </a:rPr>
-              <a:t>526.766 €</a:t>
-            </a:r>
-            <a:endParaRPr lang="en-US" sz="2200" dirty="0"/>
+              <a:t>Einnahmen alle Parteien</a:t>
+            </a:r>
+            <a:endParaRPr lang="en-US" sz="1100" dirty="0"/>
           </a:p>
         </p:txBody>
       </p:sp>
@@ -13441,8 +14019,8 @@
         </p:nvSpPr>
         <p:spPr>
           <a:xfrm>
-            <a:off x="6812280" y="4663440"/>
-            <a:ext cx="1965960" cy="256032"/>
+            <a:off x="9509760" y="4251960"/>
+            <a:ext cx="1920240" cy="292608"/>
           </a:xfrm>
           <a:prstGeom prst="rect">
             <a:avLst/>
@@ -13454,68 +14032,135 @@
           <a:bodyPr wrap="square" lIns="0" tIns="0" rIns="0" bIns="0" rtlCol="0" anchor="ctr"/>
           <a:lstStyle/>
           <a:p>
+            <a:pPr algn="r" indent="0" marL="0">
+              <a:buNone/>
+            </a:pPr>
+            <a:r>
+              <a:rPr lang="en-US" sz="1100" dirty="0">
+                <a:solidFill>
+                  <a:srgbClr val="3D3D3D"/>
+                </a:solidFill>
+                <a:latin typeface="Helvetica" pitchFamily="34" charset="0"/>
+                <a:ea typeface="Helvetica" pitchFamily="34" charset="-122"/>
+                <a:cs typeface="Helvetica" pitchFamily="34" charset="-120"/>
+              </a:rPr>
+              <a:t>1.156.766 €</a:t>
+            </a:r>
+            <a:endParaRPr lang="en-US" sz="1100" dirty="0"/>
+          </a:p>
+        </p:txBody>
+      </p:sp>
+      <p:sp>
+        <p:nvSpPr>
+          <p:cNvPr id="16" name="Text 11"/>
+          <p:cNvSpPr txBox="1"/>
+          <p:nvPr/>
+        </p:nvSpPr>
+        <p:spPr>
+          <a:xfrm>
+            <a:off x="6812280" y="4562856"/>
+            <a:ext cx="2926080" cy="292608"/>
+          </a:xfrm>
+          <a:prstGeom prst="rect">
+            <a:avLst/>
+          </a:prstGeom>
+          <a:noFill/>
+          <a:ln/>
+        </p:spPr>
+        <p:txBody>
+          <a:bodyPr wrap="square" lIns="0" tIns="0" rIns="0" bIns="0" rtlCol="0" anchor="ctr"/>
+          <a:lstStyle/>
+          <a:p>
             <a:pPr indent="0" marL="0">
               <a:buNone/>
             </a:pPr>
             <a:r>
-              <a:rPr lang="en-US" sz="950" dirty="0">
-                <a:solidFill>
-                  <a:srgbClr val="6A6A6A"/>
-                </a:solidFill>
-                <a:latin typeface="Helvetica" pitchFamily="34" charset="0"/>
-                <a:ea typeface="Helvetica" pitchFamily="34" charset="-122"/>
-                <a:cs typeface="Helvetica" pitchFamily="34" charset="-120"/>
-              </a:rPr>
-              <a:t>47 % des Deals</a:t>
-            </a:r>
-            <a:endParaRPr lang="en-US" sz="950" dirty="0"/>
-          </a:p>
-        </p:txBody>
-      </p:sp>
-      <p:sp>
-        <p:nvSpPr>
-          <p:cNvPr id="16" name="Shape 11"/>
+              <a:rPr lang="en-US" sz="1100" dirty="0">
+                <a:solidFill>
+                  <a:srgbClr val="3D3D3D"/>
+                </a:solidFill>
+                <a:latin typeface="Helvetica" pitchFamily="34" charset="0"/>
+                <a:ea typeface="Helvetica" pitchFamily="34" charset="-122"/>
+                <a:cs typeface="Helvetica" pitchFamily="34" charset="-120"/>
+              </a:rPr>
+              <a:t>− Kosten gesamt</a:t>
+            </a:r>
+            <a:endParaRPr lang="en-US" sz="1100" dirty="0"/>
+          </a:p>
+        </p:txBody>
+      </p:sp>
+      <p:sp>
+        <p:nvSpPr>
+          <p:cNvPr id="17" name="Text 12"/>
+          <p:cNvSpPr txBox="1"/>
+          <p:nvPr/>
+        </p:nvSpPr>
+        <p:spPr>
+          <a:xfrm>
+            <a:off x="9509760" y="4562856"/>
+            <a:ext cx="1920240" cy="292608"/>
+          </a:xfrm>
+          <a:prstGeom prst="rect">
+            <a:avLst/>
+          </a:prstGeom>
+          <a:noFill/>
+          <a:ln/>
+        </p:spPr>
+        <p:txBody>
+          <a:bodyPr wrap="square" lIns="0" tIns="0" rIns="0" bIns="0" rtlCol="0" anchor="ctr"/>
+          <a:lstStyle/>
+          <a:p>
+            <a:pPr algn="r" indent="0" marL="0">
+              <a:buNone/>
+            </a:pPr>
+            <a:r>
+              <a:rPr lang="en-US" sz="1100" dirty="0">
+                <a:solidFill>
+                  <a:srgbClr val="3D3D3D"/>
+                </a:solidFill>
+                <a:latin typeface="Helvetica" pitchFamily="34" charset="0"/>
+                <a:ea typeface="Helvetica" pitchFamily="34" charset="-122"/>
+                <a:cs typeface="Helvetica" pitchFamily="34" charset="-120"/>
+              </a:rPr>
+              <a:t>615.154 €</a:t>
+            </a:r>
+            <a:endParaRPr lang="en-US" sz="1100" dirty="0"/>
+          </a:p>
+        </p:txBody>
+      </p:sp>
+      <p:sp>
+        <p:nvSpPr>
+          <p:cNvPr id="18" name="Shape 13"/>
           <p:cNvSpPr/>
           <p:nvPr/>
         </p:nvSpPr>
         <p:spPr>
           <a:xfrm>
-            <a:off x="9217152" y="3794760"/>
-            <a:ext cx="2423160" cy="1234440"/>
-          </a:xfrm>
-          <a:prstGeom prst="roundRect">
-            <a:avLst>
-              <a:gd name="adj" fmla="val 8889"/>
-            </a:avLst>
-          </a:prstGeom>
-          <a:solidFill>
-            <a:srgbClr val="FFFFFF"/>
-          </a:solidFill>
+            <a:off x="6812280" y="4855464"/>
+            <a:ext cx="4617720" cy="0"/>
+          </a:xfrm>
+          <a:prstGeom prst="line">
+            <a:avLst/>
+          </a:prstGeom>
+          <a:noFill/>
           <a:ln w="9525">
             <a:solidFill>
               <a:srgbClr val="E4E1DB"/>
             </a:solidFill>
             <a:prstDash val="solid"/>
           </a:ln>
-          <a:effectLst>
-            <a:outerShdw sx="100000" sy="100000" kx="0" ky="0" algn="bl" rotWithShape="0" blurRad="76200" dist="25400" dir="5400000">
-              <a:srgbClr val="000000">
-                <a:alpha val="6000"/>
-              </a:srgbClr>
-            </a:outerShdw>
-          </a:effectLst>
-        </p:spPr>
-      </p:sp>
-      <p:sp>
-        <p:nvSpPr>
-          <p:cNvPr id="17" name="Text 12"/>
-          <p:cNvSpPr txBox="1"/>
-          <p:nvPr/>
-        </p:nvSpPr>
-        <p:spPr>
-          <a:xfrm>
-            <a:off x="9445752" y="3959352"/>
-            <a:ext cx="1965960" cy="256032"/>
+        </p:spPr>
+      </p:sp>
+      <p:sp>
+        <p:nvSpPr>
+          <p:cNvPr id="19" name="Text 14"/>
+          <p:cNvSpPr txBox="1"/>
+          <p:nvPr/>
+        </p:nvSpPr>
+        <p:spPr>
+          <a:xfrm>
+            <a:off x="6812280" y="4873752"/>
+            <a:ext cx="2926080" cy="292608"/>
           </a:xfrm>
           <a:prstGeom prst="rect">
             <a:avLst/>
@@ -13531,30 +14176,30 @@
               <a:buNone/>
             </a:pPr>
             <a:r>
-              <a:rPr lang="en-US" sz="900" spc="150" kern="0" dirty="0">
-                <a:solidFill>
-                  <a:srgbClr val="6A6A6A"/>
-                </a:solidFill>
-                <a:latin typeface="Helvetica" pitchFamily="34" charset="0"/>
-                <a:ea typeface="Helvetica" pitchFamily="34" charset="-122"/>
-                <a:cs typeface="Helvetica" pitchFamily="34" charset="-120"/>
-              </a:rPr>
-              <a:t>MARGE NW-SICHT</a:t>
-            </a:r>
-            <a:endParaRPr lang="en-US" sz="900" dirty="0"/>
-          </a:p>
-        </p:txBody>
-      </p:sp>
-      <p:sp>
-        <p:nvSpPr>
-          <p:cNvPr id="18" name="Text 13"/>
-          <p:cNvSpPr txBox="1"/>
-          <p:nvPr/>
-        </p:nvSpPr>
-        <p:spPr>
-          <a:xfrm>
-            <a:off x="9445752" y="4206240"/>
-            <a:ext cx="1965960" cy="457200"/>
+              <a:rPr lang="en-US" sz="1100" b="1" dirty="0">
+                <a:solidFill>
+                  <a:srgbClr val="3D3D3D"/>
+                </a:solidFill>
+                <a:latin typeface="Helvetica" pitchFamily="34" charset="0"/>
+                <a:ea typeface="Helvetica" pitchFamily="34" charset="-122"/>
+                <a:cs typeface="Helvetica" pitchFamily="34" charset="-120"/>
+              </a:rPr>
+              <a:t>= Ergebnis vor Split</a:t>
+            </a:r>
+            <a:endParaRPr lang="en-US" sz="1100" dirty="0"/>
+          </a:p>
+        </p:txBody>
+      </p:sp>
+      <p:sp>
+        <p:nvSpPr>
+          <p:cNvPr id="20" name="Text 15"/>
+          <p:cNvSpPr txBox="1"/>
+          <p:nvPr/>
+        </p:nvSpPr>
+        <p:spPr>
+          <a:xfrm>
+            <a:off x="9509760" y="4873752"/>
+            <a:ext cx="1920240" cy="292608"/>
           </a:xfrm>
           <a:prstGeom prst="rect">
             <a:avLst/>
@@ -13566,34 +14211,73 @@
           <a:bodyPr wrap="square" lIns="0" tIns="0" rIns="0" bIns="0" rtlCol="0" anchor="ctr"/>
           <a:lstStyle/>
           <a:p>
+            <a:pPr algn="r" indent="0" marL="0">
+              <a:buNone/>
+            </a:pPr>
+            <a:r>
+              <a:rPr lang="en-US" sz="1100" b="1" dirty="0">
+                <a:solidFill>
+                  <a:srgbClr val="5A7D52"/>
+                </a:solidFill>
+                <a:latin typeface="Helvetica" pitchFamily="34" charset="0"/>
+                <a:ea typeface="Helvetica" pitchFamily="34" charset="-122"/>
+                <a:cs typeface="Helvetica" pitchFamily="34" charset="-120"/>
+              </a:rPr>
+              <a:t>541.612 €</a:t>
+            </a:r>
+            <a:endParaRPr lang="en-US" sz="1100" dirty="0"/>
+          </a:p>
+        </p:txBody>
+      </p:sp>
+      <p:sp>
+        <p:nvSpPr>
+          <p:cNvPr id="21" name="Text 16"/>
+          <p:cNvSpPr txBox="1"/>
+          <p:nvPr/>
+        </p:nvSpPr>
+        <p:spPr>
+          <a:xfrm>
+            <a:off x="6812280" y="5184648"/>
+            <a:ext cx="2926080" cy="292608"/>
+          </a:xfrm>
+          <a:prstGeom prst="rect">
+            <a:avLst/>
+          </a:prstGeom>
+          <a:noFill/>
+          <a:ln/>
+        </p:spPr>
+        <p:txBody>
+          <a:bodyPr wrap="square" lIns="0" tIns="0" rIns="0" bIns="0" rtlCol="0" anchor="ctr"/>
+          <a:lstStyle/>
+          <a:p>
             <a:pPr indent="0" marL="0">
               <a:buNone/>
             </a:pPr>
             <a:r>
-              <a:rPr lang="en-US" sz="2200" b="1" dirty="0">
-                <a:solidFill>
-                  <a:srgbClr val="5A7D52"/>
-                </a:solidFill>
-                <a:latin typeface="Helvetica" pitchFamily="34" charset="0"/>
-                <a:ea typeface="Helvetica" pitchFamily="34" charset="-122"/>
-                <a:cs typeface="Helvetica" pitchFamily="34" charset="-120"/>
-              </a:rPr>
-              <a:t>218.169 €</a:t>
-            </a:r>
-            <a:endParaRPr lang="en-US" sz="2200" dirty="0"/>
-          </a:p>
-        </p:txBody>
-      </p:sp>
-      <p:sp>
-        <p:nvSpPr>
-          <p:cNvPr id="19" name="Text 14"/>
-          <p:cNvSpPr txBox="1"/>
-          <p:nvPr/>
-        </p:nvSpPr>
-        <p:spPr>
-          <a:xfrm>
-            <a:off x="9445752" y="4663440"/>
-            <a:ext cx="1965960" cy="256032"/>
+              <a:rPr lang="en-US" sz="1100" dirty="0">
+                <a:solidFill>
+                  <a:srgbClr val="3D3D3D"/>
+                </a:solidFill>
+                <a:latin typeface="Helvetica" pitchFamily="34" charset="0"/>
+                <a:ea typeface="Helvetica" pitchFamily="34" charset="-122"/>
+                <a:cs typeface="Helvetica" pitchFamily="34" charset="-120"/>
+              </a:rPr>
+              <a:t>− Auszahlungen Partner</a:t>
+            </a:r>
+            <a:endParaRPr lang="en-US" sz="1100" dirty="0"/>
+          </a:p>
+        </p:txBody>
+      </p:sp>
+      <p:sp>
+        <p:nvSpPr>
+          <p:cNvPr id="22" name="Text 17"/>
+          <p:cNvSpPr txBox="1"/>
+          <p:nvPr/>
+        </p:nvSpPr>
+        <p:spPr>
+          <a:xfrm>
+            <a:off x="9509760" y="5184648"/>
+            <a:ext cx="1920240" cy="292608"/>
           </a:xfrm>
           <a:prstGeom prst="rect">
             <a:avLst/>
@@ -13605,68 +14289,57 @@
           <a:bodyPr wrap="square" lIns="0" tIns="0" rIns="0" bIns="0" rtlCol="0" anchor="ctr"/>
           <a:lstStyle/>
           <a:p>
-            <a:pPr indent="0" marL="0">
-              <a:buNone/>
-            </a:pPr>
-            <a:r>
-              <a:rPr lang="en-US" sz="950" dirty="0">
-                <a:solidFill>
-                  <a:srgbClr val="6A6A6A"/>
-                </a:solidFill>
-                <a:latin typeface="Helvetica" pitchFamily="34" charset="0"/>
-                <a:ea typeface="Helvetica" pitchFamily="34" charset="-122"/>
-                <a:cs typeface="Helvetica" pitchFamily="34" charset="-120"/>
-              </a:rPr>
-              <a:t>41 % vom NW-Umsatz</a:t>
-            </a:r>
-            <a:endParaRPr lang="en-US" sz="950" dirty="0"/>
-          </a:p>
-        </p:txBody>
-      </p:sp>
-      <p:sp>
-        <p:nvSpPr>
-          <p:cNvPr id="20" name="Shape 15"/>
+            <a:pPr algn="r" indent="0" marL="0">
+              <a:buNone/>
+            </a:pPr>
+            <a:r>
+              <a:rPr lang="en-US" sz="1100" dirty="0">
+                <a:solidFill>
+                  <a:srgbClr val="3D3D3D"/>
+                </a:solidFill>
+                <a:latin typeface="Helvetica" pitchFamily="34" charset="0"/>
+                <a:ea typeface="Helvetica" pitchFamily="34" charset="-122"/>
+                <a:cs typeface="Helvetica" pitchFamily="34" charset="-120"/>
+              </a:rPr>
+              <a:t>350.000 €</a:t>
+            </a:r>
+            <a:endParaRPr lang="en-US" sz="1100" dirty="0"/>
+          </a:p>
+        </p:txBody>
+      </p:sp>
+      <p:sp>
+        <p:nvSpPr>
+          <p:cNvPr id="23" name="Shape 18"/>
           <p:cNvSpPr/>
           <p:nvPr/>
         </p:nvSpPr>
         <p:spPr>
           <a:xfrm>
-            <a:off x="6583680" y="5166360"/>
-            <a:ext cx="5056632" cy="914400"/>
-          </a:xfrm>
-          <a:prstGeom prst="roundRect">
-            <a:avLst>
-              <a:gd name="adj" fmla="val 12000"/>
-            </a:avLst>
-          </a:prstGeom>
-          <a:solidFill>
-            <a:srgbClr val="F4EEE2"/>
-          </a:solidFill>
+            <a:off x="6812280" y="5477256"/>
+            <a:ext cx="4617720" cy="0"/>
+          </a:xfrm>
+          <a:prstGeom prst="line">
+            <a:avLst/>
+          </a:prstGeom>
+          <a:noFill/>
           <a:ln w="9525">
             <a:solidFill>
               <a:srgbClr val="E4E1DB"/>
             </a:solidFill>
             <a:prstDash val="solid"/>
           </a:ln>
-          <a:effectLst>
-            <a:outerShdw sx="100000" sy="100000" kx="0" ky="0" algn="bl" rotWithShape="0" blurRad="76200" dist="25400" dir="5400000">
-              <a:srgbClr val="000000">
-                <a:alpha val="6000"/>
-              </a:srgbClr>
-            </a:outerShdw>
-          </a:effectLst>
-        </p:spPr>
-      </p:sp>
-      <p:sp>
-        <p:nvSpPr>
-          <p:cNvPr id="21" name="Text 16"/>
-          <p:cNvSpPr txBox="1"/>
-          <p:nvPr/>
-        </p:nvSpPr>
-        <p:spPr>
-          <a:xfrm>
-            <a:off x="6766560" y="5230368"/>
-            <a:ext cx="4709160" cy="786384"/>
+        </p:spPr>
+      </p:sp>
+      <p:sp>
+        <p:nvSpPr>
+          <p:cNvPr id="24" name="Text 19"/>
+          <p:cNvSpPr txBox="1"/>
+          <p:nvPr/>
+        </p:nvSpPr>
+        <p:spPr>
+          <a:xfrm>
+            <a:off x="6812280" y="5495544"/>
+            <a:ext cx="2926080" cy="292608"/>
           </a:xfrm>
           <a:prstGeom prst="rect">
             <a:avLst/>
@@ -13682,7 +14355,7 @@
               <a:buNone/>
             </a:pPr>
             <a:r>
-              <a:rPr lang="en-US" sz="1050" dirty="0">
+              <a:rPr lang="en-US" sz="1100" b="1" dirty="0">
                 <a:solidFill>
                   <a:srgbClr val="3D3D3D"/>
                 </a:solidFill>
@@ -13690,9 +14363,87 @@
                 <a:ea typeface="Helvetica" pitchFamily="34" charset="-122"/>
                 <a:cs typeface="Helvetica" pitchFamily="34" charset="-120"/>
               </a:rPr>
-              <a:t>80er Live trägt die Marge: 261.073 € aus Nova-Works-Sicht. Oberhausen liegt aus Nova-Works-Sicht bei -42.904 € (Kosten über dem eigenen Umsatzanteil).</a:t>
-            </a:r>
-            <a:endParaRPr lang="en-US" sz="1050" dirty="0"/>
+              <a:t>= verbleibt Nova Works</a:t>
+            </a:r>
+            <a:endParaRPr lang="en-US" sz="1100" dirty="0"/>
+          </a:p>
+        </p:txBody>
+      </p:sp>
+      <p:sp>
+        <p:nvSpPr>
+          <p:cNvPr id="25" name="Text 20"/>
+          <p:cNvSpPr txBox="1"/>
+          <p:nvPr/>
+        </p:nvSpPr>
+        <p:spPr>
+          <a:xfrm>
+            <a:off x="9509760" y="5495544"/>
+            <a:ext cx="1920240" cy="292608"/>
+          </a:xfrm>
+          <a:prstGeom prst="rect">
+            <a:avLst/>
+          </a:prstGeom>
+          <a:noFill/>
+          <a:ln/>
+        </p:spPr>
+        <p:txBody>
+          <a:bodyPr wrap="square" lIns="0" tIns="0" rIns="0" bIns="0" rtlCol="0" anchor="ctr"/>
+          <a:lstStyle/>
+          <a:p>
+            <a:pPr algn="r" indent="0" marL="0">
+              <a:buNone/>
+            </a:pPr>
+            <a:r>
+              <a:rPr lang="en-US" sz="1100" b="1" dirty="0">
+                <a:solidFill>
+                  <a:srgbClr val="5A7D52"/>
+                </a:solidFill>
+                <a:latin typeface="Helvetica" pitchFamily="34" charset="0"/>
+                <a:ea typeface="Helvetica" pitchFamily="34" charset="-122"/>
+                <a:cs typeface="Helvetica" pitchFamily="34" charset="-120"/>
+              </a:rPr>
+              <a:t>191.612 €</a:t>
+            </a:r>
+            <a:endParaRPr lang="en-US" sz="1100" dirty="0"/>
+          </a:p>
+        </p:txBody>
+      </p:sp>
+      <p:sp>
+        <p:nvSpPr>
+          <p:cNvPr id="26" name="Text 21"/>
+          <p:cNvSpPr txBox="1"/>
+          <p:nvPr/>
+        </p:nvSpPr>
+        <p:spPr>
+          <a:xfrm>
+            <a:off x="6812280" y="5815584"/>
+            <a:ext cx="4617720" cy="237744"/>
+          </a:xfrm>
+          <a:prstGeom prst="rect">
+            <a:avLst/>
+          </a:prstGeom>
+          <a:noFill/>
+          <a:ln/>
+        </p:spPr>
+        <p:txBody>
+          <a:bodyPr wrap="square" lIns="0" tIns="0" rIns="0" bIns="0" rtlCol="0" anchor="ctr"/>
+          <a:lstStyle/>
+          <a:p>
+            <a:pPr indent="0" marL="0">
+              <a:buNone/>
+            </a:pPr>
+            <a:r>
+              <a:rPr lang="en-US" sz="900" dirty="0">
+                <a:solidFill>
+                  <a:srgbClr val="6A6A6A"/>
+                </a:solidFill>
+                <a:latin typeface="Helvetica" pitchFamily="34" charset="0"/>
+                <a:ea typeface="Helvetica" pitchFamily="34" charset="-122"/>
+                <a:cs typeface="Helvetica" pitchFamily="34" charset="-120"/>
+              </a:rPr>
+              <a:t>Nova-Works-Sicht: Umsatz 556.766 € − Kosten 615.154 € = -58.388 € (-10 %)</a:t>
+            </a:r>
+            <a:endParaRPr lang="en-US" sz="900" dirty="0"/>
           </a:p>
         </p:txBody>
       </p:sp>
@@ -14005,7 +14756,7 @@
                 <a:ea typeface="Helvetica" pitchFamily="34" charset="-122"/>
                 <a:cs typeface="Helvetica" pitchFamily="34" charset="-120"/>
               </a:rPr>
-              <a:t>Rechnungen an den Kunden über alle Parteien · Stand 07.08.2026</a:t>
+              <a:t>Rechnungen an den Kunden über alle Parteien · Stand 18.09.2026</a:t>
             </a:r>
             <a:endParaRPr lang="en-US" sz="1250" dirty="0"/>
           </a:p>
@@ -14117,7 +14868,7 @@
                 <a:ea typeface="Helvetica" pitchFamily="34" charset="-122"/>
                 <a:cs typeface="Helvetica" pitchFamily="34" charset="-120"/>
               </a:rPr>
-              <a:t>874.624 €</a:t>
+              <a:t>1.047.766 €</a:t>
             </a:r>
             <a:endParaRPr lang="en-US" sz="2200" dirty="0"/>
           </a:p>
@@ -14156,7 +14907,7 @@
                 <a:ea typeface="Helvetica" pitchFamily="34" charset="-122"/>
                 <a:cs typeface="Helvetica" pitchFamily="34" charset="-120"/>
               </a:rPr>
-              <a:t>netto · 1.040.753 € brutto</a:t>
+              <a:t>27 Rechnungen · netto · 1.246.792 € brutto</a:t>
             </a:r>
             <a:endParaRPr lang="en-US" sz="950" dirty="0"/>
           </a:p>
@@ -14268,7 +15019,7 @@
                 <a:ea typeface="Helvetica" pitchFamily="34" charset="-122"/>
                 <a:cs typeface="Helvetica" pitchFamily="34" charset="-120"/>
               </a:rPr>
-              <a:t>678.993 €</a:t>
+              <a:t>788.473 €</a:t>
             </a:r>
             <a:endParaRPr lang="en-US" sz="2200" dirty="0"/>
           </a:p>
@@ -14307,7 +15058,7 @@
                 <a:ea typeface="Helvetica" pitchFamily="34" charset="-122"/>
                 <a:cs typeface="Helvetica" pitchFamily="34" charset="-120"/>
               </a:rPr>
-              <a:t>15 Rechnungen · brutto</a:t>
+              <a:t>18 Rechnungen · brutto</a:t>
             </a:r>
             <a:endParaRPr lang="en-US" sz="950" dirty="0"/>
           </a:p>
@@ -14419,7 +15170,7 @@
                 <a:ea typeface="Helvetica" pitchFamily="34" charset="-122"/>
                 <a:cs typeface="Helvetica" pitchFamily="34" charset="-120"/>
               </a:rPr>
-              <a:t>361.760 €</a:t>
+              <a:t>383.349 €</a:t>
             </a:r>
             <a:endParaRPr lang="en-US" sz="2200" dirty="0"/>
           </a:p>
@@ -14458,7 +15209,7 @@
                 <a:ea typeface="Helvetica" pitchFamily="34" charset="-122"/>
                 <a:cs typeface="Helvetica" pitchFamily="34" charset="-120"/>
               </a:rPr>
-              <a:t>7 Rechnungen · brutto · nur 80er Live</a:t>
+              <a:t>9 Rechnungen · brutto</a:t>
             </a:r>
             <a:endParaRPr lang="en-US" sz="950" dirty="0"/>
           </a:p>
@@ -16077,7 +16828,7 @@
                 <a:ea typeface="Helvetica" pitchFamily="34" charset="-122"/>
                 <a:cs typeface="Helvetica" pitchFamily="34" charset="-120"/>
               </a:rPr>
-              <a:t>Kennzahlen aus dem Forecast der Nova Works App · alle Beträge netto</a:t>
+              <a:t>Forecast · nächste 12 Monate (Sep 2026 – Aug 2027) · 19 Projekte, 4 Planeinträge · alle Beträge netto · Stand 18.09.2026</a:t>
             </a:r>
             <a:endParaRPr lang="en-US" sz="1250" dirty="0"/>
           </a:p>
@@ -16181,7 +16932,7 @@
               <a:buNone/>
             </a:pPr>
             <a:r>
-              <a:rPr lang="en-US" sz="2200" b="1" dirty="0">
+              <a:rPr lang="en-US" sz="2100" b="1" dirty="0">
                 <a:solidFill>
                   <a:srgbClr val="5A7D52"/>
                 </a:solidFill>
@@ -16189,9 +16940,9 @@
                 <a:ea typeface="Helvetica" pitchFamily="34" charset="-122"/>
                 <a:cs typeface="Helvetica" pitchFamily="34" charset="-120"/>
               </a:rPr>
-              <a:t>–</a:t>
-            </a:r>
-            <a:endParaRPr lang="en-US" sz="2200" dirty="0"/>
+              <a:t>300.966 €</a:t>
+            </a:r>
+            <a:endParaRPr lang="en-US" sz="2100" dirty="0"/>
           </a:p>
         </p:txBody>
       </p:sp>
@@ -16332,7 +17083,7 @@
               <a:buNone/>
             </a:pPr>
             <a:r>
-              <a:rPr lang="en-US" sz="2200" b="1" dirty="0">
+              <a:rPr lang="en-US" sz="2100" b="1" dirty="0">
                 <a:solidFill>
                   <a:srgbClr val="A8884F"/>
                 </a:solidFill>
@@ -16340,9 +17091,9 @@
                 <a:ea typeface="Helvetica" pitchFamily="34" charset="-122"/>
                 <a:cs typeface="Helvetica" pitchFamily="34" charset="-120"/>
               </a:rPr>
-              <a:t>–</a:t>
-            </a:r>
-            <a:endParaRPr lang="en-US" sz="2200" dirty="0"/>
+              <a:t>957.135 €</a:t>
+            </a:r>
+            <a:endParaRPr lang="en-US" sz="2100" dirty="0"/>
           </a:p>
         </p:txBody>
       </p:sp>
@@ -16379,7 +17130,7 @@
                 <a:ea typeface="Helvetica" pitchFamily="34" charset="-122"/>
                 <a:cs typeface="Helvetica" pitchFamily="34" charset="-120"/>
               </a:rPr>
-              <a:t>Angebote „auf Anfrage“ × Wahrscheinlichkeit</a:t>
+              <a:t>aus 1.707.495 € Angeboten „auf Anfrage“</a:t>
             </a:r>
             <a:endParaRPr lang="en-US" sz="950" dirty="0"/>
           </a:p>
@@ -16483,7 +17234,7 @@
               <a:buNone/>
             </a:pPr>
             <a:r>
-              <a:rPr lang="en-US" sz="2200" b="1" dirty="0">
+              <a:rPr lang="en-US" sz="1800" b="1" dirty="0">
                 <a:solidFill>
                   <a:srgbClr val="3D3D3D"/>
                 </a:solidFill>
@@ -16491,9 +17242,9 @@
                 <a:ea typeface="Helvetica" pitchFamily="34" charset="-122"/>
                 <a:cs typeface="Helvetica" pitchFamily="34" charset="-120"/>
               </a:rPr>
-              <a:t>–</a:t>
-            </a:r>
-            <a:endParaRPr lang="en-US" sz="2200" dirty="0"/>
+              <a:t>1.258.101 €</a:t>
+            </a:r>
+            <a:endParaRPr lang="en-US" sz="1800" dirty="0"/>
           </a:p>
         </p:txBody>
       </p:sp>
@@ -16642,7 +17393,7 @@
                 <a:ea typeface="Helvetica" pitchFamily="34" charset="-122"/>
                 <a:cs typeface="Helvetica" pitchFamily="34" charset="-120"/>
               </a:rPr>
-              <a:t>–</a:t>
+              <a:t>45.738 €</a:t>
             </a:r>
             <a:endParaRPr lang="en-US" sz="2200" dirty="0"/>
           </a:p>
@@ -16785,7 +17536,7 @@
               <a:buNone/>
             </a:pPr>
             <a:r>
-              <a:rPr lang="en-US" sz="2200" b="1" dirty="0">
+              <a:rPr lang="en-US" sz="2100" b="1" dirty="0">
                 <a:solidFill>
                   <a:srgbClr val="5A7D52"/>
                 </a:solidFill>
@@ -16793,9 +17544,9 @@
                 <a:ea typeface="Helvetica" pitchFamily="34" charset="-122"/>
                 <a:cs typeface="Helvetica" pitchFamily="34" charset="-120"/>
               </a:rPr>
-              <a:t>–</a:t>
-            </a:r>
-            <a:endParaRPr lang="en-US" sz="2200" dirty="0"/>
+              <a:t>279.150 €</a:t>
+            </a:r>
+            <a:endParaRPr lang="en-US" sz="2100" dirty="0"/>
           </a:p>
         </p:txBody>
       </p:sp>
@@ -16832,7 +17583,7 @@
                 <a:ea typeface="Helvetica" pitchFamily="34" charset="-122"/>
                 <a:cs typeface="Helvetica" pitchFamily="34" charset="-120"/>
               </a:rPr>
-              <a:t>Umsatz − geplante Kosten</a:t>
+              <a:t>22 % vom Forecast-Umsatz</a:t>
             </a:r>
             <a:endParaRPr lang="en-US" sz="950" dirty="0"/>
           </a:p>
@@ -16936,17 +17687,17 @@
               <a:buNone/>
             </a:pPr>
             <a:r>
-              <a:rPr lang="en-US" sz="2200" b="1" dirty="0">
-                <a:solidFill>
-                  <a:srgbClr val="3D3D3D"/>
-                </a:solidFill>
-                <a:latin typeface="Helvetica" pitchFamily="34" charset="0"/>
-                <a:ea typeface="Helvetica" pitchFamily="34" charset="-122"/>
-                <a:cs typeface="Helvetica" pitchFamily="34" charset="-120"/>
-              </a:rPr>
-              <a:t>–</a:t>
-            </a:r>
-            <a:endParaRPr lang="en-US" sz="2200" dirty="0"/>
+              <a:rPr lang="en-US" sz="2100" b="1" dirty="0">
+                <a:solidFill>
+                  <a:srgbClr val="5A7D52"/>
+                </a:solidFill>
+                <a:latin typeface="Helvetica" pitchFamily="34" charset="0"/>
+                <a:ea typeface="Helvetica" pitchFamily="34" charset="-122"/>
+                <a:cs typeface="Helvetica" pitchFamily="34" charset="-120"/>
+              </a:rPr>
+              <a:t>181.036 €</a:t>
+            </a:r>
+            <a:endParaRPr lang="en-US" sz="2100" dirty="0"/>
           </a:p>
         </p:txBody>
       </p:sp>
@@ -16983,26 +17734,42 @@
                 <a:ea typeface="Helvetica" pitchFamily="34" charset="-122"/>
                 <a:cs typeface="Helvetica" pitchFamily="34" charset="-120"/>
               </a:rPr>
-              <a:t>Marge − Fixkosten aus dem Overhead</a:t>
+              <a:t>Fixkosten 98.114 €</a:t>
             </a:r>
             <a:endParaRPr lang="en-US" sz="950" dirty="0"/>
           </a:p>
         </p:txBody>
       </p:sp>
-      <p:sp>
-        <p:nvSpPr>
-          <p:cNvPr id="33" name="Shape 30"/>
+      <p:graphicFrame>
+        <p:nvGraphicFramePr>
+          <p:cNvPr id="33" name="Chart 0" descr=""/>
+          <p:cNvGraphicFramePr/>
+          <p:nvPr/>
+        </p:nvGraphicFramePr>
+        <p:xfrm>
+          <a:off x="548640" y="3200400"/>
+          <a:ext cx="7315200" cy="2880360"/>
+        </p:xfrm>
+        <a:graphic xmlns:a="http://schemas.openxmlformats.org/drawingml/2006/main">
+          <a:graphicData uri="http://schemas.openxmlformats.org/drawingml/2006/chart">
+            <c:chart xmlns:c="http://schemas.openxmlformats.org/drawingml/2006/chart" r:id="rId2"/>
+          </a:graphicData>
+        </a:graphic>
+      </p:graphicFrame>
+      <p:sp>
+        <p:nvSpPr>
+          <p:cNvPr id="34" name="Shape 30"/>
           <p:cNvSpPr/>
           <p:nvPr/>
         </p:nvSpPr>
         <p:spPr>
           <a:xfrm>
-            <a:off x="548640" y="3200400"/>
-            <a:ext cx="11094415" cy="2834640"/>
+            <a:off x="8092440" y="3200400"/>
+            <a:ext cx="3547872" cy="2880360"/>
           </a:xfrm>
           <a:prstGeom prst="roundRect">
             <a:avLst>
-              <a:gd name="adj" fmla="val 3871"/>
+              <a:gd name="adj" fmla="val 3810"/>
             </a:avLst>
           </a:prstGeom>
           <a:solidFill>
@@ -17010,22 +17777,29 @@
           </a:solidFill>
           <a:ln w="9525">
             <a:solidFill>
-              <a:srgbClr val="C7AB78"/>
+              <a:srgbClr val="E4E1DB"/>
             </a:solidFill>
-            <a:prstDash val="dash"/>
+            <a:prstDash val="solid"/>
           </a:ln>
-        </p:spPr>
-      </p:sp>
-      <p:sp>
-        <p:nvSpPr>
-          <p:cNvPr id="34" name="Text 31"/>
-          <p:cNvSpPr txBox="1"/>
-          <p:nvPr/>
-        </p:nvSpPr>
-        <p:spPr>
-          <a:xfrm>
-            <a:off x="548640" y="3200400"/>
-            <a:ext cx="11094415" cy="2834640"/>
+          <a:effectLst>
+            <a:outerShdw sx="100000" sy="100000" kx="0" ky="0" algn="bl" rotWithShape="0" blurRad="76200" dist="25400" dir="5400000">
+              <a:srgbClr val="000000">
+                <a:alpha val="6000"/>
+              </a:srgbClr>
+            </a:outerShdw>
+          </a:effectLst>
+        </p:spPr>
+      </p:sp>
+      <p:sp>
+        <p:nvSpPr>
+          <p:cNvPr id="35" name="Text 31"/>
+          <p:cNvSpPr txBox="1"/>
+          <p:nvPr/>
+        </p:nvSpPr>
+        <p:spPr>
+          <a:xfrm>
+            <a:off x="8275320" y="3310128"/>
+            <a:ext cx="3200400" cy="256032"/>
           </a:xfrm>
           <a:prstGeom prst="rect">
             <a:avLst/>
@@ -17037,38 +17811,864 @@
           <a:bodyPr wrap="square" lIns="0" tIns="0" rIns="0" bIns="0" rtlCol="0" anchor="ctr"/>
           <a:lstStyle/>
           <a:p>
-            <a:pPr algn="ctr" indent="0" marL="0">
-              <a:buNone/>
-            </a:pPr>
-            <a:r>
-              <a:rPr lang="en-US" sz="1400" i="1" dirty="0">
-                <a:solidFill>
-                  <a:srgbClr val="C7AB78"/>
-                </a:solidFill>
-                <a:latin typeface="Helvetica" pitchFamily="34" charset="0"/>
-                <a:ea typeface="Helvetica" pitchFamily="34" charset="-122"/>
-                <a:cs typeface="Helvetica" pitchFamily="34" charset="-120"/>
-              </a:rPr>
-              <a:t>Umsatz je Monat (Bestätigt · Offen gewichtet · Abgerechnet)</a:t>
-            </a:r>
-            <a:endParaRPr lang="en-US" sz="1400" dirty="0"/>
-          </a:p>
-          <a:p>
-            <a:pPr algn="ctr" indent="0" marL="0">
-              <a:buNone/>
-            </a:pPr>
-            <a:r>
-              <a:rPr lang="en-US" sz="1400" i="1" dirty="0">
-                <a:solidFill>
-                  <a:srgbClr val="C7AB78"/>
-                </a:solidFill>
-                <a:latin typeface="Helvetica" pitchFamily="34" charset="0"/>
-                <a:ea typeface="Helvetica" pitchFamily="34" charset="-122"/>
-                <a:cs typeface="Helvetica" pitchFamily="34" charset="-120"/>
-              </a:rPr>
-              <a:t>Zahlen folgen aus dem Forecast der Nova Works App (Forecast → PowerPoint-Export)</a:t>
-            </a:r>
-            <a:endParaRPr lang="en-US" sz="1400" dirty="0"/>
+            <a:pPr indent="0" marL="0">
+              <a:buNone/>
+            </a:pPr>
+            <a:r>
+              <a:rPr lang="en-US" sz="900" spc="150" kern="0" dirty="0">
+                <a:solidFill>
+                  <a:srgbClr val="6A6A6A"/>
+                </a:solidFill>
+                <a:latin typeface="Helvetica" pitchFamily="34" charset="0"/>
+                <a:ea typeface="Helvetica" pitchFamily="34" charset="-122"/>
+                <a:cs typeface="Helvetica" pitchFamily="34" charset="-120"/>
+              </a:rPr>
+              <a:t>ÜBERSICHT NACH ZEITRAUM</a:t>
+            </a:r>
+            <a:endParaRPr lang="en-US" sz="900" dirty="0"/>
+          </a:p>
+        </p:txBody>
+      </p:sp>
+      <p:graphicFrame>
+        <p:nvGraphicFramePr>
+          <p:cNvPr id="10" name="Table 0"/>
+          <p:cNvGraphicFramePr>
+            <a:graphicFrameLocks noGrp="1"/>
+          </p:cNvGraphicFramePr>
+          <p:nvPr>
+            <p:extLst>
+              <p:ext uri="{D42A27DB-BD31-4B8C-83A1-F6EECF244321}">
+                <p14:modId xmlns:p14="http://schemas.microsoft.com/office/powerpoint/2010/main" val="1579011935"/>
+              </p:ext>
+            </p:extLst>
+          </p:nvPr>
+        </p:nvGraphicFramePr>
+        <p:xfrm>
+          <a:off x="8229600" y="3611880"/>
+          <a:ext cx="3291840" cy="914400"/>
+        </p:xfrm>
+        <a:graphic>
+          <a:graphicData uri="http://schemas.openxmlformats.org/drawingml/2006/table">
+            <a:tbl>
+              <a:tblPr/>
+              <a:tblGrid>
+                <a:gridCol w="1005840"/>
+                <a:gridCol w="822960"/>
+                <a:gridCol w="731520"/>
+                <a:gridCol w="731520"/>
+              </a:tblGrid>
+              <a:tr h="365760">
+                <a:tc>
+                  <a:txBody>
+                    <a:bodyPr/>
+                    <a:lstStyle/>
+                    <a:p>
+                      <a:pPr algn="l" indent="0" marL="0">
+                        <a:buNone/>
+                      </a:pPr>
+                      <a:r>
+                        <a:rPr lang="en-US" sz="850" b="1" spc="100" kern="0" dirty="0">
+                          <a:solidFill>
+                            <a:srgbClr val="6A6A6A"/>
+                          </a:solidFill>
+                          <a:latin typeface="Helvetica" pitchFamily="34" charset="0"/>
+                          <a:ea typeface="Helvetica" pitchFamily="34" charset="-122"/>
+                          <a:cs typeface="Helvetica" pitchFamily="34" charset="-120"/>
+                        </a:rPr>
+                        <a:t>Zeitraum</a:t>
+                      </a:r>
+                      <a:endParaRPr lang="en-US" sz="850" dirty="0">
+                        <a:latin typeface="Helvetica" charset="0"/>
+                        <a:ea typeface="Helvetica" charset="0"/>
+                        <a:cs typeface="Helvetica" charset="0"/>
+                      </a:endParaRPr>
+                    </a:p>
+                  </a:txBody>
+                  <a:tcPr marL="63500" marR="63500" marT="38100" marB="38100">
+                    <a:lnL w="0" cap="flat" cmpd="sng" algn="ctr">
+                      <a:noFill/>
+                    </a:lnL>
+                    <a:lnR w="0" cap="flat" cmpd="sng" algn="ctr">
+                      <a:noFill/>
+                    </a:lnR>
+                    <a:lnT w="0" cap="flat" cmpd="sng" algn="ctr">
+                      <a:noFill/>
+                    </a:lnT>
+                    <a:lnB w="9525" cap="flat" cmpd="sng" algn="ctr">
+                      <a:solidFill>
+                        <a:srgbClr val="E4E1DB"/>
+                      </a:solidFill>
+                      <a:prstDash val="solid"/>
+                      <a:round/>
+                      <a:headEnd type="none" w="med" len="med"/>
+                      <a:tailEnd type="none" w="med" len="med"/>
+                    </a:lnB>
+                    <a:solidFill>
+                      <a:srgbClr val="F4EEE2"/>
+                    </a:solidFill>
+                  </a:tcPr>
+                </a:tc>
+                <a:tc>
+                  <a:txBody>
+                    <a:bodyPr/>
+                    <a:lstStyle/>
+                    <a:p>
+                      <a:pPr algn="r" indent="0" marL="0">
+                        <a:buNone/>
+                      </a:pPr>
+                      <a:r>
+                        <a:rPr lang="en-US" sz="850" b="1" spc="100" kern="0" dirty="0">
+                          <a:solidFill>
+                            <a:srgbClr val="6A6A6A"/>
+                          </a:solidFill>
+                          <a:latin typeface="Helvetica" pitchFamily="34" charset="0"/>
+                          <a:ea typeface="Helvetica" pitchFamily="34" charset="-122"/>
+                          <a:cs typeface="Helvetica" pitchFamily="34" charset="-120"/>
+                        </a:rPr>
+                        <a:t>Forecast</a:t>
+                      </a:r>
+                      <a:endParaRPr lang="en-US" sz="850" dirty="0">
+                        <a:latin typeface="Helvetica" charset="0"/>
+                        <a:ea typeface="Helvetica" charset="0"/>
+                        <a:cs typeface="Helvetica" charset="0"/>
+                      </a:endParaRPr>
+                    </a:p>
+                  </a:txBody>
+                  <a:tcPr marL="63500" marR="63500" marT="38100" marB="38100">
+                    <a:lnL w="0" cap="flat" cmpd="sng" algn="ctr">
+                      <a:noFill/>
+                    </a:lnL>
+                    <a:lnR w="0" cap="flat" cmpd="sng" algn="ctr">
+                      <a:noFill/>
+                    </a:lnR>
+                    <a:lnT w="0" cap="flat" cmpd="sng" algn="ctr">
+                      <a:noFill/>
+                    </a:lnT>
+                    <a:lnB w="9525" cap="flat" cmpd="sng" algn="ctr">
+                      <a:solidFill>
+                        <a:srgbClr val="E4E1DB"/>
+                      </a:solidFill>
+                      <a:prstDash val="solid"/>
+                      <a:round/>
+                      <a:headEnd type="none" w="med" len="med"/>
+                      <a:tailEnd type="none" w="med" len="med"/>
+                    </a:lnB>
+                    <a:solidFill>
+                      <a:srgbClr val="F4EEE2"/>
+                    </a:solidFill>
+                  </a:tcPr>
+                </a:tc>
+                <a:tc>
+                  <a:txBody>
+                    <a:bodyPr/>
+                    <a:lstStyle/>
+                    <a:p>
+                      <a:pPr algn="r" indent="0" marL="0">
+                        <a:buNone/>
+                      </a:pPr>
+                      <a:r>
+                        <a:rPr lang="en-US" sz="850" b="1" spc="100" kern="0" dirty="0">
+                          <a:solidFill>
+                            <a:srgbClr val="6A6A6A"/>
+                          </a:solidFill>
+                          <a:latin typeface="Helvetica" pitchFamily="34" charset="0"/>
+                          <a:ea typeface="Helvetica" pitchFamily="34" charset="-122"/>
+                          <a:cs typeface="Helvetica" pitchFamily="34" charset="-120"/>
+                        </a:rPr>
+                        <a:t>Marge</a:t>
+                      </a:r>
+                      <a:endParaRPr lang="en-US" sz="850" dirty="0">
+                        <a:latin typeface="Helvetica" charset="0"/>
+                        <a:ea typeface="Helvetica" charset="0"/>
+                        <a:cs typeface="Helvetica" charset="0"/>
+                      </a:endParaRPr>
+                    </a:p>
+                  </a:txBody>
+                  <a:tcPr marL="63500" marR="63500" marT="38100" marB="38100">
+                    <a:lnL w="0" cap="flat" cmpd="sng" algn="ctr">
+                      <a:noFill/>
+                    </a:lnL>
+                    <a:lnR w="0" cap="flat" cmpd="sng" algn="ctr">
+                      <a:noFill/>
+                    </a:lnR>
+                    <a:lnT w="0" cap="flat" cmpd="sng" algn="ctr">
+                      <a:noFill/>
+                    </a:lnT>
+                    <a:lnB w="9525" cap="flat" cmpd="sng" algn="ctr">
+                      <a:solidFill>
+                        <a:srgbClr val="E4E1DB"/>
+                      </a:solidFill>
+                      <a:prstDash val="solid"/>
+                      <a:round/>
+                      <a:headEnd type="none" w="med" len="med"/>
+                      <a:tailEnd type="none" w="med" len="med"/>
+                    </a:lnB>
+                    <a:solidFill>
+                      <a:srgbClr val="F4EEE2"/>
+                    </a:solidFill>
+                  </a:tcPr>
+                </a:tc>
+                <a:tc>
+                  <a:txBody>
+                    <a:bodyPr/>
+                    <a:lstStyle/>
+                    <a:p>
+                      <a:pPr algn="r" indent="0" marL="0">
+                        <a:buNone/>
+                      </a:pPr>
+                      <a:r>
+                        <a:rPr lang="en-US" sz="850" b="1" spc="100" kern="0" dirty="0">
+                          <a:solidFill>
+                            <a:srgbClr val="6A6A6A"/>
+                          </a:solidFill>
+                          <a:latin typeface="Helvetica" pitchFamily="34" charset="0"/>
+                          <a:ea typeface="Helvetica" pitchFamily="34" charset="-122"/>
+                          <a:cs typeface="Helvetica" pitchFamily="34" charset="-120"/>
+                        </a:rPr>
+                        <a:t>Ergebnis</a:t>
+                      </a:r>
+                      <a:endParaRPr lang="en-US" sz="850" dirty="0">
+                        <a:latin typeface="Helvetica" charset="0"/>
+                        <a:ea typeface="Helvetica" charset="0"/>
+                        <a:cs typeface="Helvetica" charset="0"/>
+                      </a:endParaRPr>
+                    </a:p>
+                  </a:txBody>
+                  <a:tcPr marL="63500" marR="63500" marT="38100" marB="38100">
+                    <a:lnL w="0" cap="flat" cmpd="sng" algn="ctr">
+                      <a:noFill/>
+                    </a:lnL>
+                    <a:lnR w="0" cap="flat" cmpd="sng" algn="ctr">
+                      <a:noFill/>
+                    </a:lnR>
+                    <a:lnT w="0" cap="flat" cmpd="sng" algn="ctr">
+                      <a:noFill/>
+                    </a:lnT>
+                    <a:lnB w="9525" cap="flat" cmpd="sng" algn="ctr">
+                      <a:solidFill>
+                        <a:srgbClr val="E4E1DB"/>
+                      </a:solidFill>
+                      <a:prstDash val="solid"/>
+                      <a:round/>
+                      <a:headEnd type="none" w="med" len="med"/>
+                      <a:tailEnd type="none" w="med" len="med"/>
+                    </a:lnB>
+                    <a:solidFill>
+                      <a:srgbClr val="F4EEE2"/>
+                    </a:solidFill>
+                  </a:tcPr>
+                </a:tc>
+              </a:tr>
+              <a:tr h="365760">
+                <a:tc>
+                  <a:txBody>
+                    <a:bodyPr/>
+                    <a:lstStyle/>
+                    <a:p>
+                      <a:pPr algn="l" indent="0" marL="0">
+                        <a:buNone/>
+                      </a:pPr>
+                      <a:r>
+                        <a:rPr lang="en-US" sz="850" b="1" dirty="0">
+                          <a:solidFill>
+                            <a:srgbClr val="3D3D3D"/>
+                          </a:solidFill>
+                          <a:latin typeface="Helvetica" pitchFamily="34" charset="0"/>
+                          <a:ea typeface="Helvetica" pitchFamily="34" charset="-122"/>
+                          <a:cs typeface="Helvetica" pitchFamily="34" charset="-120"/>
+                        </a:rPr>
+                        <a:t>Kalenderjahr 2026</a:t>
+                      </a:r>
+                      <a:endParaRPr lang="en-US" sz="850" dirty="0">
+                        <a:latin typeface="Helvetica" charset="0"/>
+                        <a:ea typeface="Helvetica" charset="0"/>
+                        <a:cs typeface="Helvetica" charset="0"/>
+                      </a:endParaRPr>
+                    </a:p>
+                  </a:txBody>
+                  <a:tcPr marL="63500" marR="63500" marT="38100" marB="38100">
+                    <a:lnL w="0" cap="flat" cmpd="sng" algn="ctr">
+                      <a:noFill/>
+                    </a:lnL>
+                    <a:lnR w="0" cap="flat" cmpd="sng" algn="ctr">
+                      <a:noFill/>
+                    </a:lnR>
+                    <a:lnT w="0" cap="flat" cmpd="sng" algn="ctr">
+                      <a:noFill/>
+                    </a:lnT>
+                    <a:lnB w="6350" cap="flat" cmpd="sng" algn="ctr">
+                      <a:solidFill>
+                        <a:srgbClr val="EFECE7"/>
+                      </a:solidFill>
+                      <a:prstDash val="solid"/>
+                      <a:round/>
+                      <a:headEnd type="none" w="med" len="med"/>
+                      <a:tailEnd type="none" w="med" len="med"/>
+                    </a:lnB>
+                  </a:tcPr>
+                </a:tc>
+                <a:tc>
+                  <a:txBody>
+                    <a:bodyPr/>
+                    <a:lstStyle/>
+                    <a:p>
+                      <a:pPr algn="r" indent="0" marL="0">
+                        <a:buNone/>
+                      </a:pPr>
+                      <a:r>
+                        <a:rPr lang="en-US" sz="850" b="1" dirty="0">
+                          <a:solidFill>
+                            <a:srgbClr val="3D3D3D"/>
+                          </a:solidFill>
+                          <a:latin typeface="Helvetica" pitchFamily="34" charset="0"/>
+                          <a:ea typeface="Helvetica" pitchFamily="34" charset="-122"/>
+                          <a:cs typeface="Helvetica" pitchFamily="34" charset="-120"/>
+                        </a:rPr>
+                        <a:t>1.754.272 €</a:t>
+                      </a:r>
+                      <a:endParaRPr lang="en-US" sz="850" dirty="0">
+                        <a:latin typeface="Helvetica" charset="0"/>
+                        <a:ea typeface="Helvetica" charset="0"/>
+                        <a:cs typeface="Helvetica" charset="0"/>
+                      </a:endParaRPr>
+                    </a:p>
+                  </a:txBody>
+                  <a:tcPr marL="63500" marR="63500" marT="38100" marB="38100">
+                    <a:lnL w="0" cap="flat" cmpd="sng" algn="ctr">
+                      <a:noFill/>
+                    </a:lnL>
+                    <a:lnR w="0" cap="flat" cmpd="sng" algn="ctr">
+                      <a:noFill/>
+                    </a:lnR>
+                    <a:lnT w="0" cap="flat" cmpd="sng" algn="ctr">
+                      <a:noFill/>
+                    </a:lnT>
+                    <a:lnB w="6350" cap="flat" cmpd="sng" algn="ctr">
+                      <a:solidFill>
+                        <a:srgbClr val="EFECE7"/>
+                      </a:solidFill>
+                      <a:prstDash val="solid"/>
+                      <a:round/>
+                      <a:headEnd type="none" w="med" len="med"/>
+                      <a:tailEnd type="none" w="med" len="med"/>
+                    </a:lnB>
+                  </a:tcPr>
+                </a:tc>
+                <a:tc>
+                  <a:txBody>
+                    <a:bodyPr/>
+                    <a:lstStyle/>
+                    <a:p>
+                      <a:pPr algn="r" indent="0" marL="0">
+                        <a:buNone/>
+                      </a:pPr>
+                      <a:r>
+                        <a:rPr lang="en-US" sz="850" dirty="0">
+                          <a:solidFill>
+                            <a:srgbClr val="B4493F"/>
+                          </a:solidFill>
+                          <a:latin typeface="Helvetica" pitchFamily="34" charset="0"/>
+                          <a:ea typeface="Helvetica" pitchFamily="34" charset="-122"/>
+                          <a:cs typeface="Helvetica" pitchFamily="34" charset="-120"/>
+                        </a:rPr>
+                        <a:t>-26.778 €</a:t>
+                      </a:r>
+                      <a:endParaRPr lang="en-US" sz="850" dirty="0">
+                        <a:latin typeface="Helvetica" charset="0"/>
+                        <a:ea typeface="Helvetica" charset="0"/>
+                        <a:cs typeface="Helvetica" charset="0"/>
+                      </a:endParaRPr>
+                    </a:p>
+                  </a:txBody>
+                  <a:tcPr marL="63500" marR="63500" marT="38100" marB="38100">
+                    <a:lnL w="0" cap="flat" cmpd="sng" algn="ctr">
+                      <a:noFill/>
+                    </a:lnL>
+                    <a:lnR w="0" cap="flat" cmpd="sng" algn="ctr">
+                      <a:noFill/>
+                    </a:lnR>
+                    <a:lnT w="0" cap="flat" cmpd="sng" algn="ctr">
+                      <a:noFill/>
+                    </a:lnT>
+                    <a:lnB w="6350" cap="flat" cmpd="sng" algn="ctr">
+                      <a:solidFill>
+                        <a:srgbClr val="EFECE7"/>
+                      </a:solidFill>
+                      <a:prstDash val="solid"/>
+                      <a:round/>
+                      <a:headEnd type="none" w="med" len="med"/>
+                      <a:tailEnd type="none" w="med" len="med"/>
+                    </a:lnB>
+                  </a:tcPr>
+                </a:tc>
+                <a:tc>
+                  <a:txBody>
+                    <a:bodyPr/>
+                    <a:lstStyle/>
+                    <a:p>
+                      <a:pPr algn="r" indent="0" marL="0">
+                        <a:buNone/>
+                      </a:pPr>
+                      <a:r>
+                        <a:rPr lang="en-US" sz="850" b="1" dirty="0">
+                          <a:solidFill>
+                            <a:srgbClr val="B4493F"/>
+                          </a:solidFill>
+                          <a:latin typeface="Helvetica" pitchFamily="34" charset="0"/>
+                          <a:ea typeface="Helvetica" pitchFamily="34" charset="-122"/>
+                          <a:cs typeface="Helvetica" pitchFamily="34" charset="-120"/>
+                        </a:rPr>
+                        <a:t>-115.045 €</a:t>
+                      </a:r>
+                      <a:endParaRPr lang="en-US" sz="850" dirty="0">
+                        <a:latin typeface="Helvetica" charset="0"/>
+                        <a:ea typeface="Helvetica" charset="0"/>
+                        <a:cs typeface="Helvetica" charset="0"/>
+                      </a:endParaRPr>
+                    </a:p>
+                  </a:txBody>
+                  <a:tcPr marL="63500" marR="63500" marT="38100" marB="38100">
+                    <a:lnL w="0" cap="flat" cmpd="sng" algn="ctr">
+                      <a:noFill/>
+                    </a:lnL>
+                    <a:lnR w="0" cap="flat" cmpd="sng" algn="ctr">
+                      <a:noFill/>
+                    </a:lnR>
+                    <a:lnT w="0" cap="flat" cmpd="sng" algn="ctr">
+                      <a:noFill/>
+                    </a:lnT>
+                    <a:lnB w="6350" cap="flat" cmpd="sng" algn="ctr">
+                      <a:solidFill>
+                        <a:srgbClr val="EFECE7"/>
+                      </a:solidFill>
+                      <a:prstDash val="solid"/>
+                      <a:round/>
+                      <a:headEnd type="none" w="med" len="med"/>
+                      <a:tailEnd type="none" w="med" len="med"/>
+                    </a:lnB>
+                  </a:tcPr>
+                </a:tc>
+              </a:tr>
+              <a:tr h="365760">
+                <a:tc>
+                  <a:txBody>
+                    <a:bodyPr/>
+                    <a:lstStyle/>
+                    <a:p>
+                      <a:pPr algn="l" indent="0" marL="0">
+                        <a:buNone/>
+                      </a:pPr>
+                      <a:r>
+                        <a:rPr lang="en-US" sz="850" b="1" dirty="0">
+                          <a:solidFill>
+                            <a:srgbClr val="3D3D3D"/>
+                          </a:solidFill>
+                          <a:latin typeface="Helvetica" pitchFamily="34" charset="0"/>
+                          <a:ea typeface="Helvetica" pitchFamily="34" charset="-122"/>
+                          <a:cs typeface="Helvetica" pitchFamily="34" charset="-120"/>
+                        </a:rPr>
+                        <a:t>Kalenderjahr 2027</a:t>
+                      </a:r>
+                      <a:endParaRPr lang="en-US" sz="850" dirty="0">
+                        <a:latin typeface="Helvetica" charset="0"/>
+                        <a:ea typeface="Helvetica" charset="0"/>
+                        <a:cs typeface="Helvetica" charset="0"/>
+                      </a:endParaRPr>
+                    </a:p>
+                  </a:txBody>
+                  <a:tcPr marL="63500" marR="63500" marT="38100" marB="38100">
+                    <a:lnL w="0" cap="flat" cmpd="sng" algn="ctr">
+                      <a:noFill/>
+                    </a:lnL>
+                    <a:lnR w="0" cap="flat" cmpd="sng" algn="ctr">
+                      <a:noFill/>
+                    </a:lnR>
+                    <a:lnT w="0" cap="flat" cmpd="sng" algn="ctr">
+                      <a:noFill/>
+                    </a:lnT>
+                    <a:lnB w="6350" cap="flat" cmpd="sng" algn="ctr">
+                      <a:solidFill>
+                        <a:srgbClr val="EFECE7"/>
+                      </a:solidFill>
+                      <a:prstDash val="solid"/>
+                      <a:round/>
+                      <a:headEnd type="none" w="med" len="med"/>
+                      <a:tailEnd type="none" w="med" len="med"/>
+                    </a:lnB>
+                  </a:tcPr>
+                </a:tc>
+                <a:tc>
+                  <a:txBody>
+                    <a:bodyPr/>
+                    <a:lstStyle/>
+                    <a:p>
+                      <a:pPr algn="r" indent="0" marL="0">
+                        <a:buNone/>
+                      </a:pPr>
+                      <a:r>
+                        <a:rPr lang="en-US" sz="850" b="1" dirty="0">
+                          <a:solidFill>
+                            <a:srgbClr val="3D3D3D"/>
+                          </a:solidFill>
+                          <a:latin typeface="Helvetica" pitchFamily="34" charset="0"/>
+                          <a:ea typeface="Helvetica" pitchFamily="34" charset="-122"/>
+                          <a:cs typeface="Helvetica" pitchFamily="34" charset="-120"/>
+                        </a:rPr>
+                        <a:t>628.295 €</a:t>
+                      </a:r>
+                      <a:endParaRPr lang="en-US" sz="850" dirty="0">
+                        <a:latin typeface="Helvetica" charset="0"/>
+                        <a:ea typeface="Helvetica" charset="0"/>
+                        <a:cs typeface="Helvetica" charset="0"/>
+                      </a:endParaRPr>
+                    </a:p>
+                  </a:txBody>
+                  <a:tcPr marL="63500" marR="63500" marT="38100" marB="38100">
+                    <a:lnL w="0" cap="flat" cmpd="sng" algn="ctr">
+                      <a:noFill/>
+                    </a:lnL>
+                    <a:lnR w="0" cap="flat" cmpd="sng" algn="ctr">
+                      <a:noFill/>
+                    </a:lnR>
+                    <a:lnT w="0" cap="flat" cmpd="sng" algn="ctr">
+                      <a:noFill/>
+                    </a:lnT>
+                    <a:lnB w="6350" cap="flat" cmpd="sng" algn="ctr">
+                      <a:solidFill>
+                        <a:srgbClr val="EFECE7"/>
+                      </a:solidFill>
+                      <a:prstDash val="solid"/>
+                      <a:round/>
+                      <a:headEnd type="none" w="med" len="med"/>
+                      <a:tailEnd type="none" w="med" len="med"/>
+                    </a:lnB>
+                  </a:tcPr>
+                </a:tc>
+                <a:tc>
+                  <a:txBody>
+                    <a:bodyPr/>
+                    <a:lstStyle/>
+                    <a:p>
+                      <a:pPr algn="r" indent="0" marL="0">
+                        <a:buNone/>
+                      </a:pPr>
+                      <a:r>
+                        <a:rPr lang="en-US" sz="850" dirty="0">
+                          <a:solidFill>
+                            <a:srgbClr val="5A7D52"/>
+                          </a:solidFill>
+                          <a:latin typeface="Helvetica" pitchFamily="34" charset="0"/>
+                          <a:ea typeface="Helvetica" pitchFamily="34" charset="-122"/>
+                          <a:cs typeface="Helvetica" pitchFamily="34" charset="-120"/>
+                        </a:rPr>
+                        <a:t>215.736 €</a:t>
+                      </a:r>
+                      <a:endParaRPr lang="en-US" sz="850" dirty="0">
+                        <a:latin typeface="Helvetica" charset="0"/>
+                        <a:ea typeface="Helvetica" charset="0"/>
+                        <a:cs typeface="Helvetica" charset="0"/>
+                      </a:endParaRPr>
+                    </a:p>
+                  </a:txBody>
+                  <a:tcPr marL="63500" marR="63500" marT="38100" marB="38100">
+                    <a:lnL w="0" cap="flat" cmpd="sng" algn="ctr">
+                      <a:noFill/>
+                    </a:lnL>
+                    <a:lnR w="0" cap="flat" cmpd="sng" algn="ctr">
+                      <a:noFill/>
+                    </a:lnR>
+                    <a:lnT w="0" cap="flat" cmpd="sng" algn="ctr">
+                      <a:noFill/>
+                    </a:lnT>
+                    <a:lnB w="6350" cap="flat" cmpd="sng" algn="ctr">
+                      <a:solidFill>
+                        <a:srgbClr val="EFECE7"/>
+                      </a:solidFill>
+                      <a:prstDash val="solid"/>
+                      <a:round/>
+                      <a:headEnd type="none" w="med" len="med"/>
+                      <a:tailEnd type="none" w="med" len="med"/>
+                    </a:lnB>
+                  </a:tcPr>
+                </a:tc>
+                <a:tc>
+                  <a:txBody>
+                    <a:bodyPr/>
+                    <a:lstStyle/>
+                    <a:p>
+                      <a:pPr algn="r" indent="0" marL="0">
+                        <a:buNone/>
+                      </a:pPr>
+                      <a:r>
+                        <a:rPr lang="en-US" sz="850" b="1" dirty="0">
+                          <a:solidFill>
+                            <a:srgbClr val="5A7D52"/>
+                          </a:solidFill>
+                          <a:latin typeface="Helvetica" pitchFamily="34" charset="0"/>
+                          <a:ea typeface="Helvetica" pitchFamily="34" charset="-122"/>
+                          <a:cs typeface="Helvetica" pitchFamily="34" charset="-120"/>
+                        </a:rPr>
+                        <a:t>116.122 €</a:t>
+                      </a:r>
+                      <a:endParaRPr lang="en-US" sz="850" dirty="0">
+                        <a:latin typeface="Helvetica" charset="0"/>
+                        <a:ea typeface="Helvetica" charset="0"/>
+                        <a:cs typeface="Helvetica" charset="0"/>
+                      </a:endParaRPr>
+                    </a:p>
+                  </a:txBody>
+                  <a:tcPr marL="63500" marR="63500" marT="38100" marB="38100">
+                    <a:lnL w="0" cap="flat" cmpd="sng" algn="ctr">
+                      <a:noFill/>
+                    </a:lnL>
+                    <a:lnR w="0" cap="flat" cmpd="sng" algn="ctr">
+                      <a:noFill/>
+                    </a:lnR>
+                    <a:lnT w="0" cap="flat" cmpd="sng" algn="ctr">
+                      <a:noFill/>
+                    </a:lnT>
+                    <a:lnB w="6350" cap="flat" cmpd="sng" algn="ctr">
+                      <a:solidFill>
+                        <a:srgbClr val="EFECE7"/>
+                      </a:solidFill>
+                      <a:prstDash val="solid"/>
+                      <a:round/>
+                      <a:headEnd type="none" w="med" len="med"/>
+                      <a:tailEnd type="none" w="med" len="med"/>
+                    </a:lnB>
+                  </a:tcPr>
+                </a:tc>
+              </a:tr>
+              <a:tr h="365760">
+                <a:tc>
+                  <a:txBody>
+                    <a:bodyPr/>
+                    <a:lstStyle/>
+                    <a:p>
+                      <a:pPr algn="l" indent="0" marL="0">
+                        <a:buNone/>
+                      </a:pPr>
+                      <a:r>
+                        <a:rPr lang="en-US" sz="850" b="1" dirty="0">
+                          <a:solidFill>
+                            <a:srgbClr val="3D3D3D"/>
+                          </a:solidFill>
+                          <a:latin typeface="Helvetica" pitchFamily="34" charset="0"/>
+                          <a:ea typeface="Helvetica" pitchFamily="34" charset="-122"/>
+                          <a:cs typeface="Helvetica" pitchFamily="34" charset="-120"/>
+                        </a:rPr>
+                        <a:t>Nächste 12 Mon.</a:t>
+                      </a:r>
+                      <a:endParaRPr lang="en-US" sz="850" dirty="0">
+                        <a:latin typeface="Helvetica" charset="0"/>
+                        <a:ea typeface="Helvetica" charset="0"/>
+                        <a:cs typeface="Helvetica" charset="0"/>
+                      </a:endParaRPr>
+                    </a:p>
+                  </a:txBody>
+                  <a:tcPr marL="63500" marR="63500" marT="38100" marB="38100">
+                    <a:lnL w="0" cap="flat" cmpd="sng" algn="ctr">
+                      <a:noFill/>
+                    </a:lnL>
+                    <a:lnR w="0" cap="flat" cmpd="sng" algn="ctr">
+                      <a:noFill/>
+                    </a:lnR>
+                    <a:lnT w="0" cap="flat" cmpd="sng" algn="ctr">
+                      <a:noFill/>
+                    </a:lnT>
+                    <a:lnB w="6350" cap="flat" cmpd="sng" algn="ctr">
+                      <a:solidFill>
+                        <a:srgbClr val="EFECE7"/>
+                      </a:solidFill>
+                      <a:prstDash val="solid"/>
+                      <a:round/>
+                      <a:headEnd type="none" w="med" len="med"/>
+                      <a:tailEnd type="none" w="med" len="med"/>
+                    </a:lnB>
+                  </a:tcPr>
+                </a:tc>
+                <a:tc>
+                  <a:txBody>
+                    <a:bodyPr/>
+                    <a:lstStyle/>
+                    <a:p>
+                      <a:pPr algn="r" indent="0" marL="0">
+                        <a:buNone/>
+                      </a:pPr>
+                      <a:r>
+                        <a:rPr lang="en-US" sz="850" b="1" dirty="0">
+                          <a:solidFill>
+                            <a:srgbClr val="3D3D3D"/>
+                          </a:solidFill>
+                          <a:latin typeface="Helvetica" pitchFamily="34" charset="0"/>
+                          <a:ea typeface="Helvetica" pitchFamily="34" charset="-122"/>
+                          <a:cs typeface="Helvetica" pitchFamily="34" charset="-120"/>
+                        </a:rPr>
+                        <a:t>1.258.101 €</a:t>
+                      </a:r>
+                      <a:endParaRPr lang="en-US" sz="850" dirty="0">
+                        <a:latin typeface="Helvetica" charset="0"/>
+                        <a:ea typeface="Helvetica" charset="0"/>
+                        <a:cs typeface="Helvetica" charset="0"/>
+                      </a:endParaRPr>
+                    </a:p>
+                  </a:txBody>
+                  <a:tcPr marL="63500" marR="63500" marT="38100" marB="38100">
+                    <a:lnL w="0" cap="flat" cmpd="sng" algn="ctr">
+                      <a:noFill/>
+                    </a:lnL>
+                    <a:lnR w="0" cap="flat" cmpd="sng" algn="ctr">
+                      <a:noFill/>
+                    </a:lnR>
+                    <a:lnT w="0" cap="flat" cmpd="sng" algn="ctr">
+                      <a:noFill/>
+                    </a:lnT>
+                    <a:lnB w="6350" cap="flat" cmpd="sng" algn="ctr">
+                      <a:solidFill>
+                        <a:srgbClr val="EFECE7"/>
+                      </a:solidFill>
+                      <a:prstDash val="solid"/>
+                      <a:round/>
+                      <a:headEnd type="none" w="med" len="med"/>
+                      <a:tailEnd type="none" w="med" len="med"/>
+                    </a:lnB>
+                  </a:tcPr>
+                </a:tc>
+                <a:tc>
+                  <a:txBody>
+                    <a:bodyPr/>
+                    <a:lstStyle/>
+                    <a:p>
+                      <a:pPr algn="r" indent="0" marL="0">
+                        <a:buNone/>
+                      </a:pPr>
+                      <a:r>
+                        <a:rPr lang="en-US" sz="850" dirty="0">
+                          <a:solidFill>
+                            <a:srgbClr val="5A7D52"/>
+                          </a:solidFill>
+                          <a:latin typeface="Helvetica" pitchFamily="34" charset="0"/>
+                          <a:ea typeface="Helvetica" pitchFamily="34" charset="-122"/>
+                          <a:cs typeface="Helvetica" pitchFamily="34" charset="-120"/>
+                        </a:rPr>
+                        <a:t>279.150 €</a:t>
+                      </a:r>
+                      <a:endParaRPr lang="en-US" sz="850" dirty="0">
+                        <a:latin typeface="Helvetica" charset="0"/>
+                        <a:ea typeface="Helvetica" charset="0"/>
+                        <a:cs typeface="Helvetica" charset="0"/>
+                      </a:endParaRPr>
+                    </a:p>
+                  </a:txBody>
+                  <a:tcPr marL="63500" marR="63500" marT="38100" marB="38100">
+                    <a:lnL w="0" cap="flat" cmpd="sng" algn="ctr">
+                      <a:noFill/>
+                    </a:lnL>
+                    <a:lnR w="0" cap="flat" cmpd="sng" algn="ctr">
+                      <a:noFill/>
+                    </a:lnR>
+                    <a:lnT w="0" cap="flat" cmpd="sng" algn="ctr">
+                      <a:noFill/>
+                    </a:lnT>
+                    <a:lnB w="6350" cap="flat" cmpd="sng" algn="ctr">
+                      <a:solidFill>
+                        <a:srgbClr val="EFECE7"/>
+                      </a:solidFill>
+                      <a:prstDash val="solid"/>
+                      <a:round/>
+                      <a:headEnd type="none" w="med" len="med"/>
+                      <a:tailEnd type="none" w="med" len="med"/>
+                    </a:lnB>
+                  </a:tcPr>
+                </a:tc>
+                <a:tc>
+                  <a:txBody>
+                    <a:bodyPr/>
+                    <a:lstStyle/>
+                    <a:p>
+                      <a:pPr algn="r" indent="0" marL="0">
+                        <a:buNone/>
+                      </a:pPr>
+                      <a:r>
+                        <a:rPr lang="en-US" sz="850" b="1" dirty="0">
+                          <a:solidFill>
+                            <a:srgbClr val="5A7D52"/>
+                          </a:solidFill>
+                          <a:latin typeface="Helvetica" pitchFamily="34" charset="0"/>
+                          <a:ea typeface="Helvetica" pitchFamily="34" charset="-122"/>
+                          <a:cs typeface="Helvetica" pitchFamily="34" charset="-120"/>
+                        </a:rPr>
+                        <a:t>181.036 €</a:t>
+                      </a:r>
+                      <a:endParaRPr lang="en-US" sz="850" dirty="0">
+                        <a:latin typeface="Helvetica" charset="0"/>
+                        <a:ea typeface="Helvetica" charset="0"/>
+                        <a:cs typeface="Helvetica" charset="0"/>
+                      </a:endParaRPr>
+                    </a:p>
+                  </a:txBody>
+                  <a:tcPr marL="63500" marR="63500" marT="38100" marB="38100">
+                    <a:lnL w="0" cap="flat" cmpd="sng" algn="ctr">
+                      <a:noFill/>
+                    </a:lnL>
+                    <a:lnR w="0" cap="flat" cmpd="sng" algn="ctr">
+                      <a:noFill/>
+                    </a:lnR>
+                    <a:lnT w="0" cap="flat" cmpd="sng" algn="ctr">
+                      <a:noFill/>
+                    </a:lnT>
+                    <a:lnB w="6350" cap="flat" cmpd="sng" algn="ctr">
+                      <a:solidFill>
+                        <a:srgbClr val="EFECE7"/>
+                      </a:solidFill>
+                      <a:prstDash val="solid"/>
+                      <a:round/>
+                      <a:headEnd type="none" w="med" len="med"/>
+                      <a:tailEnd type="none" w="med" len="med"/>
+                    </a:lnB>
+                  </a:tcPr>
+                </a:tc>
+              </a:tr>
+            </a:tbl>
+          </a:graphicData>
+        </a:graphic>
+      </p:graphicFrame>
+      <p:sp>
+        <p:nvSpPr>
+          <p:cNvPr id="37" name="Text 32"/>
+          <p:cNvSpPr txBox="1"/>
+          <p:nvPr/>
+        </p:nvSpPr>
+        <p:spPr>
+          <a:xfrm>
+            <a:off x="8275320" y="5440680"/>
+            <a:ext cx="3200400" cy="548640"/>
+          </a:xfrm>
+          <a:prstGeom prst="rect">
+            <a:avLst/>
+          </a:prstGeom>
+          <a:noFill/>
+          <a:ln/>
+        </p:spPr>
+        <p:txBody>
+          <a:bodyPr wrap="square" lIns="0" tIns="0" rIns="0" bIns="0" rtlCol="0" anchor="t"/>
+          <a:lstStyle/>
+          <a:p>
+            <a:pPr indent="0" marL="0">
+              <a:buNone/>
+            </a:pPr>
+            <a:r>
+              <a:rPr lang="en-US" sz="800" dirty="0">
+                <a:solidFill>
+                  <a:srgbClr val="6A6A6A"/>
+                </a:solidFill>
+                <a:latin typeface="Helvetica" pitchFamily="34" charset="0"/>
+                <a:ea typeface="Helvetica" pitchFamily="34" charset="-122"/>
+                <a:cs typeface="Helvetica" pitchFamily="34" charset="-120"/>
+              </a:rPr>
+              <a:t>Kalenderjahr 2026: 1.572.556 € abgerechnet · Kosten geplant 1.781.049 € · Fixkosten 88.267 €</a:t>
+            </a:r>
+            <a:endParaRPr lang="en-US" sz="800" dirty="0"/>
           </a:p>
         </p:txBody>
       </p:sp>

</xml_diff>

<commit_message>
Gesellschafterversammlung: Kennzahlen auf Datensicherung vom 22.09.2026 aktualisiert
Co-Authored-By: Claude Fable 5.1 <noreply@anthropic.com>
Claude-Session: https://claude.ai/code/session_0118VeQCFGC8WVSdKpLNkHCn
</commit_message>
<xml_diff>
--- a/praesentationen/Gesellschafterversammlung_2026-09-23.pptx
+++ b/praesentationen/Gesellschafterversammlung_2026-09-23.pptx
@@ -117,45 +117,45 @@
   <p:extLst>
     <p:ext uri="{521415D9-36F7-43E2-AB2F-B90AF26B5E84}">
       <p14:sectionLst xmlns:p14="http://schemas.microsoft.com/office/powerpoint/2010/main">
-        <p14:section name="Einstieg" id="{e1699406-e4d7-222f-cc5a-77e509046243}">
+        <p14:section name="Einstieg" id="{5f84d1a2-4f9d-f061-69f9-747faf0adc8b}">
           <p14:sldIdLst>
             <p14:sldId id="256"/>
             <p14:sldId id="257"/>
           </p14:sldIdLst>
         </p14:section>
-        <p14:section name="TOP 1 · Kurze Zusammenfassung und IST-Zustand" id="{fc5062d2-5e5c-a39d-14b3-9f7dcd028bd2}">
+        <p14:section name="TOP 1 · Kurze Zusammenfassung und IST-Zustand" id="{f1329768-703b-49cf-5b56-89a186c42aa5}">
           <p14:sldIdLst>
             <p14:sldId id="258"/>
           </p14:sldIdLst>
         </p14:section>
-        <p14:section name="TOP 2 · Überblick der letzten 4 Monate" id="{4d5fe321-9d25-bc1b-f2d3-3120543c2060}">
+        <p14:section name="TOP 2 · Überblick der letzten 4 Monate" id="{729c52e3-5e36-cb13-5520-08369502ac3d}">
           <p14:sldIdLst>
             <p14:sldId id="259"/>
             <p14:sldId id="260"/>
           </p14:sldIdLst>
         </p14:section>
-        <p14:section name="TOP 3 · 80er im Detail und Zukunft Kunde MK?" id="{d540d21e-3d97-80b0-9138-52ad587fc4fb}">
+        <p14:section name="TOP 3 · 80er im Detail und Zukunft Kunde MK?" id="{5374b64f-47de-6228-989f-73d0fcbf7d37}">
           <p14:sldIdLst>
             <p14:sldId id="261"/>
             <p14:sldId id="262"/>
           </p14:sldIdLst>
         </p14:section>
-        <p14:section name="TOP 4 · Messeauftritt" id="{29066fe7-fb04-64ef-f1de-9bc3f67d07ef}">
+        <p14:section name="TOP 4 · Messeauftritt" id="{67e4496d-3023-ec42-8b40-3814c260d0cc}">
           <p14:sldIdLst>
             <p14:sldId id="263"/>
           </p14:sldIdLst>
         </p14:section>
-        <p14:section name="TOP 5 · Forecast und Ausblick" id="{ecf74539-b534-2022-4b42-dcb8750b66ca}">
+        <p14:section name="TOP 5 · Forecast und Ausblick" id="{0adf7285-98d7-c508-c77e-94e679071790}">
           <p14:sldIdLst>
             <p14:sldId id="264"/>
           </p14:sldIdLst>
         </p14:section>
-        <p14:section name="TOP 6 · Sonstiges" id="{5d4495d8-51fb-0fc5-68a3-25ce0ae95ba4}">
+        <p14:section name="TOP 6 · Sonstiges" id="{c5eb0d11-d874-b33e-4076-7786cb6c7bca}">
           <p14:sldIdLst>
             <p14:sldId id="265"/>
           </p14:sldIdLst>
         </p14:section>
-        <p14:section name="Abschluss" id="{7d449268-ba34-b3be-5a12-3101a18a6bcc}">
+        <p14:section name="Abschluss" id="{ac692809-6edb-fcfe-706f-97f46a35203f}">
           <p14:sldIdLst>
             <p14:sldId id="266"/>
           </p14:sldIdLst>
@@ -981,7 +981,7 @@
                 <c:formatCode>General</c:formatCode>
                 <c:ptCount val="12"/>
                 <c:pt idx="0">
-                  <c:v>254446</c:v>
+                  <c:v>253606</c:v>
                 </c:pt>
                 <c:pt idx="1">
                   <c:v>0</c:v>
@@ -1121,13 +1121,13 @@
                   <c:v>0</c:v>
                 </c:pt>
                 <c:pt idx="1">
-                  <c:v>130449</c:v>
+                  <c:v>70162</c:v>
                 </c:pt>
                 <c:pt idx="2">
-                  <c:v>141174</c:v>
+                  <c:v>131966</c:v>
                 </c:pt>
                 <c:pt idx="3">
-                  <c:v>57217</c:v>
+                  <c:v>52317</c:v>
                 </c:pt>
                 <c:pt idx="4">
                   <c:v>4625</c:v>
@@ -1255,7 +1255,7 @@
                 <c:formatCode>General</c:formatCode>
                 <c:ptCount val="12"/>
                 <c:pt idx="0">
-                  <c:v>45738</c:v>
+                  <c:v>226099</c:v>
                 </c:pt>
                 <c:pt idx="1">
                   <c:v>0</c:v>
@@ -2470,7 +2470,7 @@
           <a:p>
             <a:r>
               <a:rPr lang="en-US" dirty="0"/>
-              <a:t>TOP 3 – Deal-Auswertung aus der Nova Works App (Auswertung → Deal-Auswertung), Stand 18.09.2026. Nova-Works-Umsatz = bestätigte Projektsumme, Partnerumsätze CGS/TCLG manuell erfasst, Kosten (NW) aus der Kostenkontrolle, Auszahlungen an Partner aus dem Kostensplit.</a:t>
+              <a:t>TOP 3 – Deal-Auswertung aus der Nova Works App (Auswertung → Deal-Auswertung), Stand 22.09.2026. Nova-Works-Umsatz = bestätigte Projektsumme, Partnerumsätze CGS/TCLG manuell erfasst, Kosten (NW) aus der Kostenkontrolle, Auszahlungen an Partner aus dem Kostensplit.</a:t>
             </a:r>
             <a:endParaRPr lang="en-US" dirty="0"/>
           </a:p>
@@ -2558,7 +2558,7 @@
           <a:p>
             <a:r>
               <a:rPr lang="en-US" dirty="0"/>
-              <a:t>TOP 3 – Rechnungsstand aus der Deal-Auswertung (Stand 18.09.2026). Diskussionspunkte zur Zukunft mit dem Kunden.</a:t>
+              <a:t>TOP 3 – Rechnungsstand aus der Deal-Auswertung (Stand 22.09.2026). Diskussionspunkte zur Zukunft mit dem Kunden.</a:t>
             </a:r>
             <a:endParaRPr lang="en-US" dirty="0"/>
           </a:p>
@@ -2734,7 +2734,7 @@
           <a:p>
             <a:r>
               <a:rPr lang="en-US" dirty="0"/>
-              <a:t>TOP 5 – Forecast und Ausblick. Zahlen aus Nova Works App → Forecast (Standard „nächste 12 Monate“, dazu Kalenderjahr 2026 und 2027), berechnet aus der Datensicherung vom 18.09.2026.</a:t>
+              <a:t>TOP 5 – Forecast und Ausblick. Zahlen aus Nova Works App → Forecast (Standard „nächste 12 Monate“, dazu Kalenderjahr 2026 und 2027), berechnet aus der Datensicherung vom 22.09.2026.</a:t>
             </a:r>
             <a:endParaRPr lang="en-US" dirty="0"/>
           </a:p>
@@ -6575,7 +6575,7 @@
                 <a:ea typeface="Helvetica" pitchFamily="34" charset="-122"/>
                 <a:cs typeface="Helvetica" pitchFamily="34" charset="-120"/>
               </a:rPr>
-              <a:t>Gesamt Nova Works · Auswertung der bestätigten Projekte · Stand 18.09.2026 · alle Beträge netto</a:t>
+              <a:t>Gesamt Nova Works · Auswertung der bestätigten Projekte · Stand 22.09.2026 · alle Beträge netto</a:t>
             </a:r>
             <a:endParaRPr lang="en-US" sz="1250" dirty="0"/>
           </a:p>
@@ -6726,7 +6726,7 @@
                 <a:ea typeface="Helvetica" pitchFamily="34" charset="-122"/>
                 <a:cs typeface="Helvetica" pitchFamily="34" charset="-120"/>
               </a:rPr>
-              <a:t>1.704.057 €</a:t>
+              <a:t>1.703.217 €</a:t>
             </a:r>
             <a:endParaRPr lang="en-US" sz="1800" dirty="0"/>
           </a:p>
@@ -6877,7 +6877,7 @@
                 <a:ea typeface="Helvetica" pitchFamily="34" charset="-122"/>
                 <a:cs typeface="Helvetica" pitchFamily="34" charset="-120"/>
               </a:rPr>
-              <a:t>1.814.727 €</a:t>
+              <a:t>1.813.887 €</a:t>
             </a:r>
             <a:endParaRPr lang="en-US" sz="1800" dirty="0"/>
           </a:p>
@@ -7028,7 +7028,7 @@
                 <a:ea typeface="Helvetica" pitchFamily="34" charset="-122"/>
                 <a:cs typeface="Helvetica" pitchFamily="34" charset="-120"/>
               </a:rPr>
-              <a:t>1.572.556 €</a:t>
+              <a:t>1.752.917 €</a:t>
             </a:r>
             <a:endParaRPr lang="en-US" sz="1800" dirty="0"/>
           </a:p>
@@ -7179,7 +7179,7 @@
                 <a:ea typeface="Helvetica" pitchFamily="34" charset="-122"/>
                 <a:cs typeface="Helvetica" pitchFamily="34" charset="-120"/>
               </a:rPr>
-              <a:t>1.530.115 €</a:t>
+              <a:t>1.642.787 €</a:t>
             </a:r>
             <a:endParaRPr lang="en-US" sz="1800" dirty="0"/>
           </a:p>
@@ -7330,7 +7330,7 @@
                 <a:ea typeface="Helvetica" pitchFamily="34" charset="-122"/>
                 <a:cs typeface="Helvetica" pitchFamily="34" charset="-120"/>
               </a:rPr>
-              <a:t>-123.644 €</a:t>
+              <a:t>-124.484 €</a:t>
             </a:r>
             <a:endParaRPr lang="en-US" sz="1900" dirty="0"/>
           </a:p>
@@ -7481,7 +7481,7 @@
                 <a:ea typeface="Helvetica" pitchFamily="34" charset="-122"/>
                 <a:cs typeface="Helvetica" pitchFamily="34" charset="-120"/>
               </a:rPr>
-              <a:t>281.412 €</a:t>
+              <a:t>167.900 €</a:t>
             </a:r>
             <a:endParaRPr lang="en-US" sz="2100" dirty="0"/>
           </a:p>
@@ -7520,7 +7520,7 @@
                 <a:ea typeface="Helvetica" pitchFamily="34" charset="-122"/>
                 <a:cs typeface="Helvetica" pitchFamily="34" charset="-120"/>
               </a:rPr>
-              <a:t>16 % · Budget − Kosten Ist</a:t>
+              <a:t>9 % · Budget − Kosten Ist</a:t>
             </a:r>
             <a:endParaRPr lang="en-US" sz="950" dirty="0"/>
           </a:p>
@@ -7632,7 +7632,7 @@
                 <a:ea typeface="Helvetica" pitchFamily="34" charset="-122"/>
                 <a:cs typeface="Helvetica" pitchFamily="34" charset="-120"/>
               </a:rPr>
-              <a:t>1.536.144 €</a:t>
+              <a:t>1.648.816 €</a:t>
             </a:r>
             <a:endParaRPr lang="en-US" sz="1800" dirty="0"/>
           </a:p>
@@ -7775,7 +7775,7 @@
               <a:buNone/>
             </a:pPr>
             <a:r>
-              <a:rPr lang="en-US" sz="2100" b="1" dirty="0">
+              <a:rPr lang="en-US" sz="2200" b="1" dirty="0">
                 <a:solidFill>
                   <a:srgbClr val="A8884F"/>
                 </a:solidFill>
@@ -7783,9 +7783,9 @@
                 <a:ea typeface="Helvetica" pitchFamily="34" charset="-122"/>
                 <a:cs typeface="Helvetica" pitchFamily="34" charset="-120"/>
               </a:rPr>
-              <a:t>242.170 €</a:t>
-            </a:r>
-            <a:endParaRPr lang="en-US" sz="2100" dirty="0"/>
+              <a:t>60.970 €</a:t>
+            </a:r>
+            <a:endParaRPr lang="en-US" sz="2200" dirty="0"/>
           </a:p>
         </p:txBody>
       </p:sp>
@@ -11754,7 +11754,7 @@
                 <a:ea typeface="Helvetica" pitchFamily="34" charset="-122"/>
                 <a:cs typeface="Helvetica" pitchFamily="34" charset="-120"/>
               </a:rPr>
-              <a:t>Deal-Auswertung ProEvent 2026 · Stand 18.09.2026 · alle Beträge netto</a:t>
+              <a:t>Deal-Auswertung ProEvent 2026 · Stand 22.09.2026 · alle Beträge netto</a:t>
             </a:r>
             <a:endParaRPr lang="en-US" sz="1250" dirty="0"/>
           </a:p>
@@ -12545,7 +12545,7 @@
                           <a:ea typeface="Helvetica" pitchFamily="34" charset="-122"/>
                           <a:cs typeface="Helvetica" pitchFamily="34" charset="-120"/>
                         </a:rPr>
-                        <a:t>458.040 €</a:t>
+                        <a:t>541.385 €</a:t>
                       </a:r>
                       <a:endParaRPr lang="en-US" sz="1000" dirty="0">
                         <a:latin typeface="Helvetica" charset="0"/>
@@ -12592,7 +12592,7 @@
                           <a:ea typeface="Helvetica" pitchFamily="34" charset="-122"/>
                           <a:cs typeface="Helvetica" pitchFamily="34" charset="-120"/>
                         </a:rPr>
-                        <a:t>434.516 €</a:t>
+                        <a:t>351.171 €</a:t>
                       </a:r>
                       <a:endParaRPr lang="en-US" sz="1000" dirty="0">
                         <a:latin typeface="Helvetica" charset="0"/>
@@ -12639,7 +12639,7 @@
                           <a:ea typeface="Helvetica" pitchFamily="34" charset="-122"/>
                           <a:cs typeface="Helvetica" pitchFamily="34" charset="-120"/>
                         </a:rPr>
-                        <a:t>-45.484 €</a:t>
+                        <a:t>-128.829 €</a:t>
                       </a:r>
                       <a:endParaRPr lang="en-US" sz="1000" dirty="0">
                         <a:latin typeface="Helvetica" charset="0"/>
@@ -13384,7 +13384,7 @@
                           <a:ea typeface="Helvetica" pitchFamily="34" charset="-122"/>
                           <a:cs typeface="Helvetica" pitchFamily="34" charset="-120"/>
                         </a:rPr>
-                        <a:t>615.154 €</a:t>
+                        <a:t>698.499 €</a:t>
                       </a:r>
                       <a:endParaRPr lang="en-US" sz="1000" dirty="0">
                         <a:latin typeface="Helvetica" charset="0"/>
@@ -13431,7 +13431,7 @@
                           <a:ea typeface="Helvetica" pitchFamily="34" charset="-122"/>
                           <a:cs typeface="Helvetica" pitchFamily="34" charset="-120"/>
                         </a:rPr>
-                        <a:t>541.612 €</a:t>
+                        <a:t>458.267 €</a:t>
                       </a:r>
                       <a:endParaRPr lang="en-US" sz="1000" dirty="0">
                         <a:latin typeface="Helvetica" charset="0"/>
@@ -13478,7 +13478,7 @@
                           <a:ea typeface="Helvetica" pitchFamily="34" charset="-122"/>
                           <a:cs typeface="Helvetica" pitchFamily="34" charset="-120"/>
                         </a:rPr>
-                        <a:t>-58.388 €</a:t>
+                        <a:t>-141.733 €</a:t>
                       </a:r>
                       <a:endParaRPr lang="en-US" sz="1000" dirty="0">
                         <a:latin typeface="Helvetica" charset="0"/>
@@ -14122,7 +14122,7 @@
                 <a:ea typeface="Helvetica" pitchFamily="34" charset="-122"/>
                 <a:cs typeface="Helvetica" pitchFamily="34" charset="-120"/>
               </a:rPr>
-              <a:t>615.154 €</a:t>
+              <a:t>698.499 €</a:t>
             </a:r>
             <a:endParaRPr lang="en-US" sz="1100" dirty="0"/>
           </a:p>
@@ -14223,7 +14223,7 @@
                 <a:ea typeface="Helvetica" pitchFamily="34" charset="-122"/>
                 <a:cs typeface="Helvetica" pitchFamily="34" charset="-120"/>
               </a:rPr>
-              <a:t>541.612 €</a:t>
+              <a:t>458.267 €</a:t>
             </a:r>
             <a:endParaRPr lang="en-US" sz="1100" dirty="0"/>
           </a:p>
@@ -14402,7 +14402,7 @@
                 <a:ea typeface="Helvetica" pitchFamily="34" charset="-122"/>
                 <a:cs typeface="Helvetica" pitchFamily="34" charset="-120"/>
               </a:rPr>
-              <a:t>191.612 €</a:t>
+              <a:t>108.267 €</a:t>
             </a:r>
             <a:endParaRPr lang="en-US" sz="1100" dirty="0"/>
           </a:p>
@@ -14441,7 +14441,7 @@
                 <a:ea typeface="Helvetica" pitchFamily="34" charset="-122"/>
                 <a:cs typeface="Helvetica" pitchFamily="34" charset="-120"/>
               </a:rPr>
-              <a:t>Nova-Works-Sicht: Umsatz 556.766 € − Kosten 615.154 € = -58.388 € (-10 %)</a:t>
+              <a:t>Nova-Works-Sicht: Umsatz 556.766 € − Kosten 698.499 € = -141.733 € (-25 %)</a:t>
             </a:r>
             <a:endParaRPr lang="en-US" sz="900" dirty="0"/>
           </a:p>
@@ -14756,7 +14756,7 @@
                 <a:ea typeface="Helvetica" pitchFamily="34" charset="-122"/>
                 <a:cs typeface="Helvetica" pitchFamily="34" charset="-120"/>
               </a:rPr>
-              <a:t>Rechnungen an den Kunden über alle Parteien · Stand 18.09.2026</a:t>
+              <a:t>Rechnungen an den Kunden über alle Parteien · Stand 22.09.2026</a:t>
             </a:r>
             <a:endParaRPr lang="en-US" sz="1250" dirty="0"/>
           </a:p>
@@ -16828,7 +16828,7 @@
                 <a:ea typeface="Helvetica" pitchFamily="34" charset="-122"/>
                 <a:cs typeface="Helvetica" pitchFamily="34" charset="-120"/>
               </a:rPr>
-              <a:t>Forecast · nächste 12 Monate (Sep 2026 – Aug 2027) · 19 Projekte, 4 Planeinträge · alle Beträge netto · Stand 18.09.2026</a:t>
+              <a:t>Forecast · nächste 12 Monate (Sep 2026 – Aug 2027) · 17 Projekte, 4 Planeinträge · alle Beträge netto · Stand 22.09.2026</a:t>
             </a:r>
             <a:endParaRPr lang="en-US" sz="1250" dirty="0"/>
           </a:p>
@@ -16940,7 +16940,7 @@
                 <a:ea typeface="Helvetica" pitchFamily="34" charset="-122"/>
                 <a:cs typeface="Helvetica" pitchFamily="34" charset="-120"/>
               </a:rPr>
-              <a:t>300.966 €</a:t>
+              <a:t>300.126 €</a:t>
             </a:r>
             <a:endParaRPr lang="en-US" sz="2100" dirty="0"/>
           </a:p>
@@ -17091,7 +17091,7 @@
                 <a:ea typeface="Helvetica" pitchFamily="34" charset="-122"/>
                 <a:cs typeface="Helvetica" pitchFamily="34" charset="-120"/>
               </a:rPr>
-              <a:t>957.135 €</a:t>
+              <a:t>882.740 €</a:t>
             </a:r>
             <a:endParaRPr lang="en-US" sz="2100" dirty="0"/>
           </a:p>
@@ -17130,7 +17130,7 @@
                 <a:ea typeface="Helvetica" pitchFamily="34" charset="-122"/>
                 <a:cs typeface="Helvetica" pitchFamily="34" charset="-120"/>
               </a:rPr>
-              <a:t>aus 1.707.495 € Angeboten „auf Anfrage“</a:t>
+              <a:t>aus 1.558.705 € Angeboten „auf Anfrage“</a:t>
             </a:r>
             <a:endParaRPr lang="en-US" sz="950" dirty="0"/>
           </a:p>
@@ -17242,7 +17242,7 @@
                 <a:ea typeface="Helvetica" pitchFamily="34" charset="-122"/>
                 <a:cs typeface="Helvetica" pitchFamily="34" charset="-120"/>
               </a:rPr>
-              <a:t>1.258.101 €</a:t>
+              <a:t>1.182.866 €</a:t>
             </a:r>
             <a:endParaRPr lang="en-US" sz="1800" dirty="0"/>
           </a:p>
@@ -17385,7 +17385,7 @@
               <a:buNone/>
             </a:pPr>
             <a:r>
-              <a:rPr lang="en-US" sz="2200" b="1" dirty="0">
+              <a:rPr lang="en-US" sz="2100" b="1" dirty="0">
                 <a:solidFill>
                   <a:srgbClr val="3D3D3D"/>
                 </a:solidFill>
@@ -17393,9 +17393,9 @@
                 <a:ea typeface="Helvetica" pitchFamily="34" charset="-122"/>
                 <a:cs typeface="Helvetica" pitchFamily="34" charset="-120"/>
               </a:rPr>
-              <a:t>45.738 €</a:t>
-            </a:r>
-            <a:endParaRPr lang="en-US" sz="2200" dirty="0"/>
+              <a:t>226.099 €</a:t>
+            </a:r>
+            <a:endParaRPr lang="en-US" sz="2100" dirty="0"/>
           </a:p>
         </p:txBody>
       </p:sp>
@@ -17544,7 +17544,7 @@
                 <a:ea typeface="Helvetica" pitchFamily="34" charset="-122"/>
                 <a:cs typeface="Helvetica" pitchFamily="34" charset="-120"/>
               </a:rPr>
-              <a:t>279.150 €</a:t>
+              <a:t>262.040 €</a:t>
             </a:r>
             <a:endParaRPr lang="en-US" sz="2100" dirty="0"/>
           </a:p>
@@ -17695,7 +17695,7 @@
                 <a:ea typeface="Helvetica" pitchFamily="34" charset="-122"/>
                 <a:cs typeface="Helvetica" pitchFamily="34" charset="-120"/>
               </a:rPr>
-              <a:t>181.036 €</a:t>
+              <a:t>163.926 €</a:t>
             </a:r>
             <a:endParaRPr lang="en-US" sz="2100" dirty="0"/>
           </a:p>
@@ -18124,7 +18124,7 @@
                           <a:ea typeface="Helvetica" pitchFamily="34" charset="-122"/>
                           <a:cs typeface="Helvetica" pitchFamily="34" charset="-120"/>
                         </a:rPr>
-                        <a:t>1.754.272 €</a:t>
+                        <a:t>1.679.037 €</a:t>
                       </a:r>
                       <a:endParaRPr lang="en-US" sz="850" dirty="0">
                         <a:latin typeface="Helvetica" charset="0"/>
@@ -18171,7 +18171,7 @@
                           <a:ea typeface="Helvetica" pitchFamily="34" charset="-122"/>
                           <a:cs typeface="Helvetica" pitchFamily="34" charset="-120"/>
                         </a:rPr>
-                        <a:t>-26.778 €</a:t>
+                        <a:t>-43.888 €</a:t>
                       </a:r>
                       <a:endParaRPr lang="en-US" sz="850" dirty="0">
                         <a:latin typeface="Helvetica" charset="0"/>
@@ -18218,7 +18218,7 @@
                           <a:ea typeface="Helvetica" pitchFamily="34" charset="-122"/>
                           <a:cs typeface="Helvetica" pitchFamily="34" charset="-120"/>
                         </a:rPr>
-                        <a:t>-115.045 €</a:t>
+                        <a:t>-132.155 €</a:t>
                       </a:r>
                       <a:endParaRPr lang="en-US" sz="850" dirty="0">
                         <a:latin typeface="Helvetica" charset="0"/>
@@ -18504,7 +18504,7 @@
                           <a:ea typeface="Helvetica" pitchFamily="34" charset="-122"/>
                           <a:cs typeface="Helvetica" pitchFamily="34" charset="-120"/>
                         </a:rPr>
-                        <a:t>1.258.101 €</a:t>
+                        <a:t>1.182.866 €</a:t>
                       </a:r>
                       <a:endParaRPr lang="en-US" sz="850" dirty="0">
                         <a:latin typeface="Helvetica" charset="0"/>
@@ -18551,7 +18551,7 @@
                           <a:ea typeface="Helvetica" pitchFamily="34" charset="-122"/>
                           <a:cs typeface="Helvetica" pitchFamily="34" charset="-120"/>
                         </a:rPr>
-                        <a:t>279.150 €</a:t>
+                        <a:t>262.040 €</a:t>
                       </a:r>
                       <a:endParaRPr lang="en-US" sz="850" dirty="0">
                         <a:latin typeface="Helvetica" charset="0"/>
@@ -18598,7 +18598,7 @@
                           <a:ea typeface="Helvetica" pitchFamily="34" charset="-122"/>
                           <a:cs typeface="Helvetica" pitchFamily="34" charset="-120"/>
                         </a:rPr>
-                        <a:t>181.036 €</a:t>
+                        <a:t>163.926 €</a:t>
                       </a:r>
                       <a:endParaRPr lang="en-US" sz="850" dirty="0">
                         <a:latin typeface="Helvetica" charset="0"/>
@@ -18666,7 +18666,7 @@
                 <a:ea typeface="Helvetica" pitchFamily="34" charset="-122"/>
                 <a:cs typeface="Helvetica" pitchFamily="34" charset="-120"/>
               </a:rPr>
-              <a:t>Kalenderjahr 2026: 1.572.556 € abgerechnet · Kosten geplant 1.781.049 € · Fixkosten 88.267 €</a:t>
+              <a:t>Kalenderjahr 2026: 1.752.917 € abgerechnet · Kosten geplant 1.722.924 € · Fixkosten 88.267 €</a:t>
             </a:r>
             <a:endParaRPr lang="en-US" sz="800" dirty="0"/>
           </a:p>

</xml_diff>